<commit_message>
minimal change- animation added for slide 5
</commit_message>
<xml_diff>
--- a/presentations/0526_Stablecoin_Exorbitant_Privilege.pptx
+++ b/presentations/0526_Stablecoin_Exorbitant_Privilege.pptx
@@ -710,7 +710,7 @@
           <a:p>
             <a:r>
               <a:rPr lang="en-US" altLang="en-US" dirty="0"/>
-              <a:t>"Then during the event window — five days before to twenty days after the crisis — for each trading day, we subtract the predicted spread from the actual spread. That difference is the abnormal spread. A positive abnormal spread or rising line means something beyond normal market conditions is pushing T-bill yields above the risk-free rate - forced selling pressure. A negative abnormal spread or falling line means something is compressing them below normal- flight-to-safety buying."</a:t>
+              <a:t>"Then during the event window — five days before to twenty days after the crisis — for each trading day, we subtract the predicted spread from the actual spread. That difference is the abnormal spread. A positive abnormal spread or rising line means something beyond normal market conditions is pushing T-bill yields above the risk-free rate - suggesting forced selling pressure. A negative abnormal spread or falling line means something is compressing them below normal- suggesting flight-to-safety buying."</a:t>
             </a:r>
             <a:endParaRPr lang="en-US" altLang="en-US" dirty="0"/>
           </a:p>
@@ -5408,47 +5408,6 @@
       </p:sp>
       <p:sp>
         <p:nvSpPr>
-          <p:cNvPr id="5" name="TextBox 4"/>
-          <p:cNvSpPr txBox="1"/>
-          <p:nvPr/>
-        </p:nvSpPr>
-        <p:spPr>
-          <a:xfrm>
-            <a:off x="11686032" y="6473952"/>
-            <a:ext cx="411480" cy="320040"/>
-          </a:xfrm>
-          <a:prstGeom prst="rect">
-            <a:avLst/>
-          </a:prstGeom>
-          <a:noFill/>
-        </p:spPr>
-        <p:txBody>
-          <a:bodyPr wrap="square">
-            <a:spAutoFit/>
-          </a:bodyPr>
-          <a:lstStyle/>
-          <a:p>
-            <a:pPr algn="r"/>
-            <a:r>
-              <a:rPr sz="1300" b="0" i="0">
-                <a:solidFill>
-                  <a:srgbClr val="555566"/>
-                </a:solidFill>
-                <a:latin typeface="Calibri"/>
-              </a:rPr>
-              <a:t>2</a:t>
-            </a:r>
-            <a:endParaRPr sz="1300" b="0" i="0">
-              <a:solidFill>
-                <a:srgbClr val="555566"/>
-              </a:solidFill>
-              <a:latin typeface="Calibri"/>
-            </a:endParaRPr>
-          </a:p>
-        </p:txBody>
-      </p:sp>
-      <p:sp>
-        <p:nvSpPr>
           <p:cNvPr id="6" name="Rectangle 5"/>
           <p:cNvSpPr/>
           <p:nvPr/>
@@ -6585,8 +6544,8 @@
         </p:nvSpPr>
         <p:spPr>
           <a:xfrm>
-            <a:off x="10265434" y="320040"/>
-            <a:ext cx="1576046" cy="323165"/>
+            <a:off x="10064750" y="320040"/>
+            <a:ext cx="1776730" cy="321945"/>
           </a:xfrm>
           <a:prstGeom prst="rect">
             <a:avLst/>
@@ -9752,47 +9711,33 @@
           <a:bodyPr rtlCol="0" anchor="ctr"/>
           <a:lstStyle/>
           <a:p>
-            <a:pPr algn="ctr"/>
-          </a:p>
-        </p:txBody>
-      </p:sp>
-      <p:sp>
-        <p:nvSpPr>
-          <p:cNvPr id="4" name="TextBox 3"/>
-          <p:cNvSpPr txBox="1"/>
-          <p:nvPr/>
-        </p:nvSpPr>
-        <p:spPr>
-          <a:xfrm>
-            <a:off x="274320" y="91440"/>
-            <a:ext cx="10515600" cy="491490"/>
-          </a:xfrm>
-          <a:prstGeom prst="rect">
-            <a:avLst/>
-          </a:prstGeom>
-          <a:noFill/>
-        </p:spPr>
-        <p:txBody>
-          <a:bodyPr wrap="square">
-            <a:spAutoFit/>
-          </a:bodyPr>
-          <a:lstStyle/>
-          <a:p>
             <a:pPr algn="l"/>
             <a:r>
-              <a:rPr sz="2600" b="0" i="0" dirty="0">
+              <a:rPr sz="2400" dirty="0">
                 <a:solidFill>
                   <a:srgbClr val="FFFFFF"/>
                 </a:solidFill>
                 <a:latin typeface="Calibri"/>
-              </a:rPr>
-              <a:t>What is CAR? </a:t>
-            </a:r>
-            <a:endParaRPr lang="en-US" sz="2600" b="0" i="0" dirty="0">
+                <a:sym typeface="+mn-ea"/>
+              </a:rPr>
+              <a:t>CAR</a:t>
+            </a:r>
+            <a:r>
+              <a:rPr lang="en-US" sz="2400" dirty="0">
+                <a:solidFill>
+                  <a:srgbClr val="FFFFFF"/>
+                </a:solidFill>
+                <a:latin typeface="Calibri"/>
+                <a:sym typeface="+mn-ea"/>
+              </a:rPr>
+              <a:t> and Conditioned Event Study</a:t>
+            </a:r>
+            <a:endParaRPr lang="en-US" sz="2400" dirty="0">
               <a:solidFill>
                 <a:srgbClr val="FFFFFF"/>
               </a:solidFill>
               <a:latin typeface="Calibri"/>
+              <a:sym typeface="+mn-ea"/>
             </a:endParaRPr>
           </a:p>
         </p:txBody>
@@ -9847,6 +9792,13 @@
               </a:rPr>
               <a:t>CAR = Cumulative Abnormal Return on the OIS–Treasury Spread</a:t>
             </a:r>
+            <a:endParaRPr b="1">
+              <a:solidFill>
+                <a:srgbClr val="FFFFFF"/>
+              </a:solidFill>
+              <a:latin typeface="Calibri"/>
+              <a:sym typeface="+mn-ea"/>
+            </a:endParaRPr>
           </a:p>
         </p:txBody>
       </p:sp>
@@ -10308,6 +10260,318 @@
   <p:clrMapOvr>
     <a:masterClrMapping/>
   </p:clrMapOvr>
+  <p:timing>
+    <p:tnLst>
+      <p:par>
+        <p:cTn id="1" dur="indefinite" restart="never" nodeType="tmRoot">
+          <p:childTnLst>
+            <p:seq concurrent="1" nextAc="seek">
+              <p:cTn id="2" dur="indefinite" nodeType="mainSeq">
+                <p:childTnLst>
+                  <p:par>
+                    <p:cTn id="3" fill="hold">
+                      <p:stCondLst>
+                        <p:cond delay="indefinite"/>
+                      </p:stCondLst>
+                      <p:childTnLst>
+                        <p:par>
+                          <p:cTn id="4" fill="hold">
+                            <p:stCondLst>
+                              <p:cond delay="0"/>
+                            </p:stCondLst>
+                            <p:childTnLst>
+                              <p:par>
+                                <p:cTn id="5" presetID="1" presetClass="entr" presetSubtype="0" fill="hold" grpId="0" nodeType="clickEffect">
+                                  <p:stCondLst>
+                                    <p:cond delay="0"/>
+                                  </p:stCondLst>
+                                  <p:childTnLst>
+                                    <p:set>
+                                      <p:cBhvr>
+                                        <p:cTn id="6" dur="1" fill="hold">
+                                          <p:stCondLst>
+                                            <p:cond delay="0"/>
+                                          </p:stCondLst>
+                                        </p:cTn>
+                                        <p:tgtEl>
+                                          <p:spTgt spid="3"/>
+                                        </p:tgtEl>
+                                        <p:attrNameLst>
+                                          <p:attrName>style.visibility</p:attrName>
+                                        </p:attrNameLst>
+                                      </p:cBhvr>
+                                      <p:to>
+                                        <p:strVal val="visible"/>
+                                      </p:to>
+                                    </p:set>
+                                  </p:childTnLst>
+                                </p:cTn>
+                              </p:par>
+                            </p:childTnLst>
+                          </p:cTn>
+                        </p:par>
+                      </p:childTnLst>
+                    </p:cTn>
+                  </p:par>
+                  <p:par>
+                    <p:cTn id="7" fill="hold">
+                      <p:stCondLst>
+                        <p:cond delay="indefinite"/>
+                      </p:stCondLst>
+                      <p:childTnLst>
+                        <p:par>
+                          <p:cTn id="8" fill="hold">
+                            <p:stCondLst>
+                              <p:cond delay="0"/>
+                            </p:stCondLst>
+                            <p:childTnLst>
+                              <p:par>
+                                <p:cTn id="9" presetID="1" presetClass="entr" presetSubtype="0" fill="hold" grpId="0" nodeType="clickEffect">
+                                  <p:stCondLst>
+                                    <p:cond delay="0"/>
+                                  </p:stCondLst>
+                                  <p:childTnLst>
+                                    <p:set>
+                                      <p:cBhvr>
+                                        <p:cTn id="10" dur="1" fill="hold">
+                                          <p:stCondLst>
+                                            <p:cond delay="0"/>
+                                          </p:stCondLst>
+                                        </p:cTn>
+                                        <p:tgtEl>
+                                          <p:spTgt spid="6"/>
+                                        </p:tgtEl>
+                                        <p:attrNameLst>
+                                          <p:attrName>style.visibility</p:attrName>
+                                        </p:attrNameLst>
+                                      </p:cBhvr>
+                                      <p:to>
+                                        <p:strVal val="visible"/>
+                                      </p:to>
+                                    </p:set>
+                                  </p:childTnLst>
+                                </p:cTn>
+                              </p:par>
+                            </p:childTnLst>
+                          </p:cTn>
+                        </p:par>
+                      </p:childTnLst>
+                    </p:cTn>
+                  </p:par>
+                  <p:par>
+                    <p:cTn id="11" fill="hold">
+                      <p:stCondLst>
+                        <p:cond delay="indefinite"/>
+                      </p:stCondLst>
+                      <p:childTnLst>
+                        <p:par>
+                          <p:cTn id="12" fill="hold">
+                            <p:stCondLst>
+                              <p:cond delay="0"/>
+                            </p:stCondLst>
+                            <p:childTnLst>
+                              <p:par>
+                                <p:cTn id="13" presetID="1" presetClass="entr" presetSubtype="0" fill="hold" grpId="0" nodeType="clickEffect">
+                                  <p:stCondLst>
+                                    <p:cond delay="0"/>
+                                  </p:stCondLst>
+                                  <p:childTnLst>
+                                    <p:set>
+                                      <p:cBhvr>
+                                        <p:cTn id="14" dur="1" fill="hold">
+                                          <p:stCondLst>
+                                            <p:cond delay="0"/>
+                                          </p:stCondLst>
+                                        </p:cTn>
+                                        <p:tgtEl>
+                                          <p:spTgt spid="10"/>
+                                        </p:tgtEl>
+                                        <p:attrNameLst>
+                                          <p:attrName>style.visibility</p:attrName>
+                                        </p:attrNameLst>
+                                      </p:cBhvr>
+                                      <p:to>
+                                        <p:strVal val="visible"/>
+                                      </p:to>
+                                    </p:set>
+                                  </p:childTnLst>
+                                </p:cTn>
+                              </p:par>
+                            </p:childTnLst>
+                          </p:cTn>
+                        </p:par>
+                      </p:childTnLst>
+                    </p:cTn>
+                  </p:par>
+                  <p:par>
+                    <p:cTn id="15" fill="hold">
+                      <p:stCondLst>
+                        <p:cond delay="indefinite"/>
+                      </p:stCondLst>
+                      <p:childTnLst>
+                        <p:par>
+                          <p:cTn id="16" fill="hold">
+                            <p:stCondLst>
+                              <p:cond delay="0"/>
+                            </p:stCondLst>
+                            <p:childTnLst>
+                              <p:par>
+                                <p:cTn id="17" presetID="1" presetClass="entr" presetSubtype="0" fill="hold" grpId="0" nodeType="clickEffect">
+                                  <p:stCondLst>
+                                    <p:cond delay="0"/>
+                                  </p:stCondLst>
+                                  <p:childTnLst>
+                                    <p:set>
+                                      <p:cBhvr>
+                                        <p:cTn id="18" dur="1" fill="hold">
+                                          <p:stCondLst>
+                                            <p:cond delay="0"/>
+                                          </p:stCondLst>
+                                        </p:cTn>
+                                        <p:tgtEl>
+                                          <p:spTgt spid="38"/>
+                                        </p:tgtEl>
+                                        <p:attrNameLst>
+                                          <p:attrName>style.visibility</p:attrName>
+                                        </p:attrNameLst>
+                                      </p:cBhvr>
+                                      <p:to>
+                                        <p:strVal val="visible"/>
+                                      </p:to>
+                                    </p:set>
+                                  </p:childTnLst>
+                                </p:cTn>
+                              </p:par>
+                            </p:childTnLst>
+                          </p:cTn>
+                        </p:par>
+                      </p:childTnLst>
+                    </p:cTn>
+                  </p:par>
+                  <p:par>
+                    <p:cTn id="19" fill="hold">
+                      <p:stCondLst>
+                        <p:cond delay="indefinite"/>
+                      </p:stCondLst>
+                      <p:childTnLst>
+                        <p:par>
+                          <p:cTn id="20" fill="hold">
+                            <p:stCondLst>
+                              <p:cond delay="0"/>
+                            </p:stCondLst>
+                            <p:childTnLst>
+                              <p:par>
+                                <p:cTn id="21" presetID="1" presetClass="entr" presetSubtype="0" fill="hold" nodeType="clickEffect">
+                                  <p:stCondLst>
+                                    <p:cond delay="0"/>
+                                  </p:stCondLst>
+                                  <p:childTnLst>
+                                    <p:set>
+                                      <p:cBhvr>
+                                        <p:cTn id="22" dur="1" fill="hold">
+                                          <p:stCondLst>
+                                            <p:cond delay="0"/>
+                                          </p:stCondLst>
+                                        </p:cTn>
+                                        <p:tgtEl>
+                                          <p:spTgt spid="41"/>
+                                        </p:tgtEl>
+                                        <p:attrNameLst>
+                                          <p:attrName>style.visibility</p:attrName>
+                                        </p:attrNameLst>
+                                      </p:cBhvr>
+                                      <p:to>
+                                        <p:strVal val="visible"/>
+                                      </p:to>
+                                    </p:set>
+                                  </p:childTnLst>
+                                </p:cTn>
+                              </p:par>
+                            </p:childTnLst>
+                          </p:cTn>
+                        </p:par>
+                      </p:childTnLst>
+                    </p:cTn>
+                  </p:par>
+                  <p:par>
+                    <p:cTn id="23" fill="hold">
+                      <p:stCondLst>
+                        <p:cond delay="indefinite"/>
+                      </p:stCondLst>
+                      <p:childTnLst>
+                        <p:par>
+                          <p:cTn id="24" fill="hold">
+                            <p:stCondLst>
+                              <p:cond delay="0"/>
+                            </p:stCondLst>
+                            <p:childTnLst>
+                              <p:par>
+                                <p:cTn id="25" presetID="1" presetClass="entr" presetSubtype="0" fill="hold" grpId="0" nodeType="clickEffect">
+                                  <p:stCondLst>
+                                    <p:cond delay="0"/>
+                                  </p:stCondLst>
+                                  <p:childTnLst>
+                                    <p:set>
+                                      <p:cBhvr>
+                                        <p:cTn id="26" dur="1" fill="hold">
+                                          <p:stCondLst>
+                                            <p:cond delay="0"/>
+                                          </p:stCondLst>
+                                        </p:cTn>
+                                        <p:tgtEl>
+                                          <p:spTgt spid="39"/>
+                                        </p:tgtEl>
+                                        <p:attrNameLst>
+                                          <p:attrName>style.visibility</p:attrName>
+                                        </p:attrNameLst>
+                                      </p:cBhvr>
+                                      <p:to>
+                                        <p:strVal val="visible"/>
+                                      </p:to>
+                                    </p:set>
+                                  </p:childTnLst>
+                                </p:cTn>
+                              </p:par>
+                            </p:childTnLst>
+                          </p:cTn>
+                        </p:par>
+                      </p:childTnLst>
+                    </p:cTn>
+                  </p:par>
+                </p:childTnLst>
+              </p:cTn>
+              <p:prevCondLst>
+                <p:cond evt="onPrev" delay="0">
+                  <p:tgtEl>
+                    <p:sldTgt/>
+                  </p:tgtEl>
+                </p:cond>
+              </p:prevCondLst>
+              <p:nextCondLst>
+                <p:cond evt="onNext" delay="0">
+                  <p:tgtEl>
+                    <p:sldTgt/>
+                  </p:tgtEl>
+                </p:cond>
+              </p:nextCondLst>
+            </p:seq>
+          </p:childTnLst>
+        </p:cTn>
+      </p:par>
+    </p:tnLst>
+    <p:bldLst>
+      <p:bldP spid="3" grpId="0" animBg="1"/>
+      <p:bldP spid="3" grpId="1" animBg="1"/>
+      <p:bldP spid="6" grpId="0" animBg="1"/>
+      <p:bldP spid="6" grpId="1" animBg="1"/>
+      <p:bldP spid="10" grpId="0" animBg="1"/>
+      <p:bldP spid="10" grpId="1" animBg="1"/>
+      <p:bldP spid="38" grpId="0" animBg="1"/>
+      <p:bldP spid="38" grpId="1" animBg="1"/>
+      <p:bldP spid="39" grpId="0" animBg="1"/>
+      <p:bldP spid="39" grpId="1" animBg="1"/>
+    </p:bldLst>
+  </p:timing>
 </p:sld>
 </file>
 
@@ -11154,7 +11418,7 @@
         <p:spPr>
           <a:xfrm>
             <a:off x="10265434" y="320040"/>
-            <a:ext cx="1576046" cy="323165"/>
+            <a:ext cx="1576046" cy="321945"/>
           </a:xfrm>
           <a:prstGeom prst="rect">
             <a:avLst/>
@@ -11175,7 +11439,7 @@
                 </a:solidFill>
                 <a:latin typeface="Calibri"/>
               </a:rPr>
-              <a:t>Mimi – Page 8</a:t>
+              <a:t>Mimi – Page 6</a:t>
             </a:r>
             <a:endParaRPr sz="1500" b="1" i="0" dirty="0">
               <a:solidFill>
@@ -11326,6 +11590,13 @@
   <p:clrMapOvr>
     <a:masterClrMapping/>
   </p:clrMapOvr>
+  <p:timing>
+    <p:tnLst>
+      <p:par>
+        <p:cTn id="1" dur="indefinite" restart="never" nodeType="tmRoot"/>
+      </p:par>
+    </p:tnLst>
+  </p:timing>
 </p:sld>
 </file>
 
@@ -11467,47 +11738,6 @@
             <a:endParaRPr sz="2600" b="0" i="0" dirty="0">
               <a:solidFill>
                 <a:srgbClr val="FFFFFF"/>
-              </a:solidFill>
-              <a:latin typeface="Calibri"/>
-            </a:endParaRPr>
-          </a:p>
-        </p:txBody>
-      </p:sp>
-      <p:sp>
-        <p:nvSpPr>
-          <p:cNvPr id="5" name="TextBox 4"/>
-          <p:cNvSpPr txBox="1"/>
-          <p:nvPr/>
-        </p:nvSpPr>
-        <p:spPr>
-          <a:xfrm>
-            <a:off x="11686032" y="6473952"/>
-            <a:ext cx="411480" cy="320040"/>
-          </a:xfrm>
-          <a:prstGeom prst="rect">
-            <a:avLst/>
-          </a:prstGeom>
-          <a:noFill/>
-        </p:spPr>
-        <p:txBody>
-          <a:bodyPr wrap="square">
-            <a:spAutoFit/>
-          </a:bodyPr>
-          <a:lstStyle/>
-          <a:p>
-            <a:pPr algn="r"/>
-            <a:r>
-              <a:rPr sz="1300" b="0" i="0">
-                <a:solidFill>
-                  <a:srgbClr val="555566"/>
-                </a:solidFill>
-                <a:latin typeface="Calibri"/>
-              </a:rPr>
-              <a:t>2</a:t>
-            </a:r>
-            <a:endParaRPr sz="1300" b="0" i="0">
-              <a:solidFill>
-                <a:srgbClr val="555566"/>
               </a:solidFill>
               <a:latin typeface="Calibri"/>
             </a:endParaRPr>

</xml_diff>

<commit_message>
update presentation with revised content
</commit_message>
<xml_diff>
--- a/presentations/0526_Stablecoin_Exorbitant_Privilege.pptx
+++ b/presentations/0526_Stablecoin_Exorbitant_Privilege.pptx
@@ -5,17 +5,17 @@
     <p:sldMasterId id="2147483648" r:id="rId1"/>
   </p:sldMasterIdLst>
   <p:notesMasterIdLst>
-    <p:notesMasterId r:id="rId10"/>
+    <p:notesMasterId r:id="rId4"/>
   </p:notesMasterIdLst>
   <p:sldIdLst>
-    <p:sldId id="266" r:id="rId2"/>
-    <p:sldId id="257" r:id="rId3"/>
-    <p:sldId id="258" r:id="rId4"/>
-    <p:sldId id="259" r:id="rId5"/>
-    <p:sldId id="260" r:id="rId6"/>
-    <p:sldId id="263" r:id="rId7"/>
-    <p:sldId id="268" r:id="rId8"/>
-    <p:sldId id="267" r:id="rId9"/>
+    <p:sldId id="266" r:id="rId3"/>
+    <p:sldId id="257" r:id="rId5"/>
+    <p:sldId id="258" r:id="rId6"/>
+    <p:sldId id="259" r:id="rId7"/>
+    <p:sldId id="260" r:id="rId8"/>
+    <p:sldId id="263" r:id="rId9"/>
+    <p:sldId id="268" r:id="rId10"/>
+    <p:sldId id="267" r:id="rId11"/>
   </p:sldIdLst>
   <p:sldSz cx="12188825" cy="6858000"/>
   <p:notesSz cx="6858000" cy="9144000"/>
@@ -301,6 +301,7 @@
               <a:rPr dirty="0"/>
               <a:t>Good afternoon everyone. Today we want to address some methodological questions from last session and walk clearly through our three stress events.</a:t>
             </a:r>
+            <a:endParaRPr dirty="0"/>
           </a:p>
         </p:txBody>
       </p:sp>
@@ -382,6 +383,7 @@
               <a:rPr dirty="0"/>
               <a:t>And we ran a buffer-conditioned event study across three stress episodes, which produced a 27 percentage point swing between the low and high buffer regimes. This deck specifically addresses the clarification questions from last time — why we use the OIS spread, what the buffer condition actually means, and how to read the CAR graphs. </a:t>
             </a:r>
+            <a:endParaRPr dirty="0"/>
           </a:p>
         </p:txBody>
       </p:sp>
@@ -477,6 +479,7 @@
               <a:rPr dirty="0"/>
               <a:t>The practical point is this: if we had used raw yields, a Fed rate cut and a Tether buying surge would look identical in our data. The spread cleanly separates them.</a:t>
             </a:r>
+            <a:endParaRPr dirty="0"/>
           </a:p>
         </p:txBody>
       </p:sp>
@@ -581,6 +584,7 @@
               <a:rPr dirty="0"/>
               <a:t> Treasury markets from one that disrupts them.</a:t>
             </a:r>
+            <a:endParaRPr dirty="0"/>
           </a:p>
         </p:txBody>
       </p:sp>
@@ -649,27 +653,194 @@
           <a:lstStyle/>
           <a:p>
             <a:r>
-              <a:rPr dirty="0"/>
-              <a:t>CAR stands for Cumulative Abnormal Return — but in our context it measures the cumulative abnormal spread, not a stock return. Let me explain what the y-axis actually means. Before each crisis, we estimate how the OIS-Treasury spread normally behaves using data from around six months prior. We build a model that says: given today's VIX level and global equity returns, what would we expect the spread to be? The abnormal spread on any given day is the actual spread minus that prediction. CAR is the running total of those daily abnormal spreads from five days before the event onward. A positive CAR means the spread has been persistently higher than expected — T-bill selling pressure. A negative CAR means it has been persistently lower than expected — flight-to-safety buying. A flat line at zero would mean the event had no effect on Treasury markets at all. Now, the second event shown here is the USDT partial </a:t>
-            </a:r>
-            <a:r>
-              <a:rPr dirty="0" err="1"/>
-              <a:t>depeg</a:t>
-            </a:r>
-            <a:r>
-              <a:rPr dirty="0"/>
-              <a:t> on May 12th, 2022 — three days after the LUNA collapse. </a:t>
-            </a:r>
-            <a:endParaRPr lang="en-US" dirty="0"/>
-          </a:p>
-          <a:p>
-            <a:endParaRPr lang="en-US" dirty="0"/>
-          </a:p>
-          <a:p>
-            <a:r>
-              <a:rPr dirty="0"/>
-              <a:t>This was a direct bank-run on Tether itself. USDT briefly fell to 95 cents. Unlike UST, which was algorithmic with no real reserves, Tether holds actual assets. The problem was that Tether's cash was only 5 to 8 percent of its reserves — the rest was T-bills. When over 7 billion dollars of USDT was redeemed in a single day, Tether had to sell T-bills to pay out, and the spread spiked. The CAR came in at plus 8.85 percentage points — essentially identical to the LUNA event. Same buffer, same constraint, same outcome — regardless of what triggered the run.</a:t>
-            </a:r>
+              <a:rPr lang="en-US" altLang="en-US" dirty="0"/>
+              <a:t>Full 2-Minute Script</a:t>
+            </a:r>
+            <a:endParaRPr lang="en-US" altLang="en-US" dirty="0"/>
+          </a:p>
+          <a:p>
+            <a:r>
+              <a:rPr lang="en-US" altLang="en-US" dirty="0"/>
+              <a:t>[Look at the audience. Do not touch the slide yet.]</a:t>
+            </a:r>
+            <a:endParaRPr lang="en-US" altLang="en-US" dirty="0"/>
+          </a:p>
+          <a:p>
+            <a:r>
+              <a:rPr lang="en-US" altLang="en-US" dirty="0"/>
+              <a:t>"Before I show you the results, I need to explain what you are looking at — because without understanding the model, the graphs are just lines."</a:t>
+            </a:r>
+            <a:endParaRPr lang="en-US" altLang="en-US" dirty="0"/>
+          </a:p>
+          <a:p>
+            <a:br>
+              <a:rPr lang="en-US" altLang="en-US" dirty="0"/>
+            </a:br>
+            <a:r>
+              <a:rPr lang="en-US" altLang="en-US" dirty="0"/>
+              <a:t>[Point to Step 1]</a:t>
+            </a:r>
+            <a:endParaRPr lang="en-US" altLang="en-US" dirty="0"/>
+          </a:p>
+          <a:p>
+            <a:r>
+              <a:rPr lang="en-US" altLang="en-US" dirty="0"/>
+              <a:t>"Before each crisis event, we take data from 120 to 6 trading days prior to the event — roughly six months of pre-crisis data — and we run a regression. We ask: given the VIX level and global equity returns on any given day, what would we expect the OIS-Treasury spread to be? This gives us our normal model. It tells us what the spread looks like when nothing unusual is happening."</a:t>
+            </a:r>
+            <a:endParaRPr lang="en-US" altLang="en-US" dirty="0"/>
+          </a:p>
+          <a:p>
+            <a:br>
+              <a:rPr lang="en-US" altLang="en-US" dirty="0"/>
+            </a:br>
+            <a:r>
+              <a:rPr lang="en-US" altLang="en-US" dirty="0"/>
+              <a:t>[Point to Step 2]</a:t>
+            </a:r>
+            <a:endParaRPr lang="en-US" altLang="en-US" dirty="0"/>
+          </a:p>
+          <a:p>
+            <a:r>
+              <a:rPr lang="en-US" altLang="en-US" dirty="0"/>
+              <a:t>"Then during the event window — five days before to twenty days after the crisis — for each trading day, we subtract the predicted spread from the actual spread. That difference is the abnormal spread. A positive abnormal spread means something beyond normal market conditions is pushing T-bill yields above the risk-free rate. A negative abnormal spread means something is compressing them below normal."</a:t>
+            </a:r>
+            <a:endParaRPr lang="en-US" altLang="en-US" dirty="0"/>
+          </a:p>
+          <a:p>
+            <a:r>
+              <a:rPr lang="en-US" altLang="en-US" dirty="0"/>
+              <a:t>Conceptually:</a:t>
+            </a:r>
+            <a:endParaRPr lang="en-US" altLang="en-US" dirty="0"/>
+          </a:p>
+          <a:p>
+            <a:endParaRPr lang="en-US" altLang="en-US" dirty="0"/>
+          </a:p>
+          <a:p>
+            <a:r>
+              <a:rPr lang="en-US" altLang="en-US" dirty="0"/>
+              <a:t>Actual Spread_t = 3M Treasury Yield_t - SOFR/OIS Rate_t</a:t>
+            </a:r>
+            <a:endParaRPr lang="en-US" altLang="en-US" dirty="0"/>
+          </a:p>
+          <a:p>
+            <a:endParaRPr lang="en-US" altLang="en-US" dirty="0"/>
+          </a:p>
+          <a:p>
+            <a:r>
+              <a:rPr lang="en-US" altLang="en-US" dirty="0"/>
+              <a:t>Predicted Spread: This is generated from your “normal model.”</a:t>
+            </a:r>
+            <a:endParaRPr lang="en-US" altLang="en-US" dirty="0"/>
+          </a:p>
+          <a:p>
+            <a:r>
+              <a:rPr lang="en-US" altLang="en-US" dirty="0"/>
+              <a:t>You estimate: Spread_t = f(VIX_t, delta ln N_t*)</a:t>
+            </a:r>
+            <a:endParaRPr lang="en-US" altLang="en-US" dirty="0"/>
+          </a:p>
+          <a:p>
+            <a:r>
+              <a:rPr lang="en-US" altLang="en-US" dirty="0"/>
+              <a:t>Meaning:</a:t>
+            </a:r>
+            <a:endParaRPr lang="en-US" altLang="en-US" dirty="0"/>
+          </a:p>
+          <a:p>
+            <a:r>
+              <a:rPr lang="en-US" altLang="en-US" dirty="0"/>
+              <a:t>“Under normal conditions, spreads move because of general market fear and global financial conditions.”</a:t>
+            </a:r>
+            <a:endParaRPr lang="en-US" altLang="en-US" dirty="0"/>
+          </a:p>
+          <a:p>
+            <a:endParaRPr lang="en-US" altLang="en-US" dirty="0"/>
+          </a:p>
+          <a:p>
+            <a:endParaRPr lang="en-US" altLang="en-US" dirty="0"/>
+          </a:p>
+          <a:p>
+            <a:r>
+              <a:rPr lang="en-US" altLang="en-US" dirty="0"/>
+              <a:t>[Point to Step 3]</a:t>
+            </a:r>
+            <a:endParaRPr lang="en-US" altLang="en-US" dirty="0"/>
+          </a:p>
+          <a:p>
+            <a:r>
+              <a:rPr lang="en-US" altLang="en-US" dirty="0"/>
+              <a:t>"We then add up all those daily abnormal values. That running total — from day minus five to day plus twenty — is the CAR. The Y-axis shows percentage points of accumulated deviation. The X-axis shows trading days. Day zero is the crisis date itself.</a:t>
+            </a:r>
+            <a:endParaRPr lang="en-US" altLang="en-US" dirty="0"/>
+          </a:p>
+          <a:p>
+            <a:endParaRPr lang="en-US" altLang="en-US" dirty="0"/>
+          </a:p>
+          <a:p>
+            <a:r>
+              <a:rPr lang="en-US" altLang="en-US" dirty="0"/>
+              <a:t>CAR_t = sum Abnormal Spread</a:t>
+            </a:r>
+            <a:endParaRPr lang="en-US" altLang="en-US" dirty="0"/>
+          </a:p>
+          <a:p>
+            <a:endParaRPr lang="en-US" altLang="en-US" dirty="0"/>
+          </a:p>
+          <a:p>
+            <a:r>
+              <a:rPr lang="en-US" altLang="en-US" dirty="0"/>
+              <a:t>[Click — LUNA graph appears on the right]</a:t>
+            </a:r>
+            <a:endParaRPr lang="en-US" altLang="en-US" dirty="0"/>
+          </a:p>
+          <a:p>
+            <a:r>
+              <a:rPr lang="en-US" altLang="en-US" dirty="0"/>
+              <a:t>"This is Event 1. Day zero is May 9th 2022 — the LUNA collapse. UST was an algorithmic stablecoin. It had no real dollar reserves. Its one-dollar peg was maintained by minting and burning LUNA tokens. When confidence broke, the mechanism failed instantly. Forty billion dollars wiped out in 72 hours."</a:t>
+            </a:r>
+            <a:endParaRPr lang="en-US" altLang="en-US" dirty="0"/>
+          </a:p>
+          <a:p>
+            <a:r>
+              <a:rPr lang="en-US" altLang="en-US" dirty="0"/>
+              <a:t>"The panic spread to Tether — a completely different issuer, fiat-backed with real reserves. But Tether had a critical vulnerability: its liquid cash buffer was only 5 to 8 percent of outstanding supply. When investors demanded their dollars back, Tether had no choice — it had to sell T-bills immediately to raise cash."</a:t>
+            </a:r>
+            <a:endParaRPr lang="en-US" altLang="en-US" dirty="0"/>
+          </a:p>
+          <a:p>
+            <a:r>
+              <a:rPr lang="en-US" altLang="en-US" dirty="0"/>
+              <a:t>"Look at the graph. The line starts near zero before the event and rises steadily. By day plus twenty, the CAR has accumulated to plus 8.9 percentage points. That means the OIS-Treasury spread accumulated 8.9 percentage points above what normal market conditions predicted — sustained, persistent T-bill selling pressure over twenty trading days. Exactly what our theory predicts for a low-buffer issuer."</a:t>
+            </a:r>
+            <a:br>
+              <a:rPr lang="en-US" altLang="en-US" dirty="0"/>
+            </a:br>
+            <a:br>
+              <a:rPr lang="en-US" altLang="en-US" dirty="0"/>
+            </a:br>
+            <a:r>
+              <a:rPr lang="en-US" altLang="en-US" dirty="0"/>
+              <a:t>"Three days later — Event 2 — USDT itself partially depegged to 95 cents. This time the run was directly on Tether, not on an algorithmic stablecoin. Different trigger, different mechanism — but the same buffer level of 5 to 8 percent, and the same result: CAR of plus 8.85 — nearly identical. The buffer determined the outcome. Not the nature of the shock."</a:t>
+            </a:r>
+            <a:endParaRPr lang="en-US" altLang="en-US" dirty="0"/>
+          </a:p>
+          <a:p>
+            <a:r>
+              <a:rPr lang="en-US" altLang="en-US" dirty="0"/>
+              <a:t>[Hand to Mimi]</a:t>
+            </a:r>
+            <a:endParaRPr lang="en-US" altLang="en-US" dirty="0"/>
+          </a:p>
+          <a:p>
+            <a:r>
+              <a:rPr lang="en-US" altLang="en-US" dirty="0"/>
+              <a:t>"Mimi will now show you what happens when the same type of stress hits a high-buffer issuer — and why the outcome is completely different."</a:t>
+            </a:r>
+            <a:endParaRPr lang="en-US" altLang="en-US" dirty="0"/>
+          </a:p>
+          <a:p>
+            <a:endParaRPr lang="en-US" altLang="en-US" dirty="0"/>
           </a:p>
         </p:txBody>
       </p:sp>
@@ -1701,370 +1872,6 @@
               </a:rPr>
               <a:t>.</a:t>
             </a:r>
-          </a:p>
-          <a:p>
-            <a:r>
-              <a:rPr lang="ko-KR" altLang="ko-KR" sz="1200" b="0" i="0" kern="1200" dirty="0" err="1">
-                <a:solidFill>
-                  <a:schemeClr val="tx1"/>
-                </a:solidFill>
-                <a:effectLst/>
-                <a:latin typeface="+mn-lt"/>
-                <a:ea typeface="+mn-ea"/>
-                <a:cs typeface="+mn-cs"/>
-              </a:rPr>
-              <a:t>You</a:t>
-            </a:r>
-            <a:r>
-              <a:rPr lang="ko-KR" altLang="ko-KR" sz="1200" b="0" i="0" kern="1200" dirty="0">
-                <a:solidFill>
-                  <a:schemeClr val="tx1"/>
-                </a:solidFill>
-                <a:effectLst/>
-                <a:latin typeface="+mn-lt"/>
-                <a:ea typeface="+mn-ea"/>
-                <a:cs typeface="+mn-cs"/>
-              </a:rPr>
-              <a:t> </a:t>
-            </a:r>
-            <a:r>
-              <a:rPr lang="ko-KR" altLang="ko-KR" sz="1200" b="0" i="0" kern="1200" dirty="0" err="1">
-                <a:solidFill>
-                  <a:schemeClr val="tx1"/>
-                </a:solidFill>
-                <a:effectLst/>
-                <a:latin typeface="+mn-lt"/>
-                <a:ea typeface="+mn-ea"/>
-                <a:cs typeface="+mn-cs"/>
-              </a:rPr>
-              <a:t>have</a:t>
-            </a:r>
-            <a:r>
-              <a:rPr lang="ko-KR" altLang="ko-KR" sz="1200" b="0" i="0" kern="1200" dirty="0">
-                <a:solidFill>
-                  <a:schemeClr val="tx1"/>
-                </a:solidFill>
-                <a:effectLst/>
-                <a:latin typeface="+mn-lt"/>
-                <a:ea typeface="+mn-ea"/>
-                <a:cs typeface="+mn-cs"/>
-              </a:rPr>
-              <a:t> </a:t>
-            </a:r>
-            <a:r>
-              <a:rPr lang="ko-KR" altLang="ko-KR" sz="1200" b="0" i="0" kern="1200" dirty="0" err="1">
-                <a:solidFill>
-                  <a:schemeClr val="tx1"/>
-                </a:solidFill>
-                <a:effectLst/>
-                <a:latin typeface="+mn-lt"/>
-                <a:ea typeface="+mn-ea"/>
-                <a:cs typeface="+mn-cs"/>
-              </a:rPr>
-              <a:t>two</a:t>
-            </a:r>
-            <a:r>
-              <a:rPr lang="ko-KR" altLang="ko-KR" sz="1200" b="0" i="0" kern="1200" dirty="0">
-                <a:solidFill>
-                  <a:schemeClr val="tx1"/>
-                </a:solidFill>
-                <a:effectLst/>
-                <a:latin typeface="+mn-lt"/>
-                <a:ea typeface="+mn-ea"/>
-                <a:cs typeface="+mn-cs"/>
-              </a:rPr>
-              <a:t> </a:t>
-            </a:r>
-            <a:r>
-              <a:rPr lang="ko-KR" altLang="ko-KR" sz="1200" b="0" i="0" kern="1200" dirty="0" err="1">
-                <a:solidFill>
-                  <a:schemeClr val="tx1"/>
-                </a:solidFill>
-                <a:effectLst/>
-                <a:latin typeface="+mn-lt"/>
-                <a:ea typeface="+mn-ea"/>
-                <a:cs typeface="+mn-cs"/>
-              </a:rPr>
-              <a:t>groups</a:t>
-            </a:r>
-            <a:r>
-              <a:rPr lang="ko-KR" altLang="ko-KR" sz="1200" b="0" i="0" kern="1200" dirty="0">
-                <a:solidFill>
-                  <a:schemeClr val="tx1"/>
-                </a:solidFill>
-                <a:effectLst/>
-                <a:latin typeface="+mn-lt"/>
-                <a:ea typeface="+mn-ea"/>
-                <a:cs typeface="+mn-cs"/>
-              </a:rPr>
-              <a:t> of </a:t>
-            </a:r>
-            <a:r>
-              <a:rPr lang="ko-KR" altLang="ko-KR" sz="1200" b="0" i="0" kern="1200" dirty="0" err="1">
-                <a:solidFill>
-                  <a:schemeClr val="tx1"/>
-                </a:solidFill>
-                <a:effectLst/>
-                <a:latin typeface="+mn-lt"/>
-                <a:ea typeface="+mn-ea"/>
-                <a:cs typeface="+mn-cs"/>
-              </a:rPr>
-              <a:t>events</a:t>
-            </a:r>
-            <a:r>
-              <a:rPr lang="ko-KR" altLang="ko-KR" sz="1200" b="0" i="0" kern="1200" dirty="0">
-                <a:solidFill>
-                  <a:schemeClr val="tx1"/>
-                </a:solidFill>
-                <a:effectLst/>
-                <a:latin typeface="+mn-lt"/>
-                <a:ea typeface="+mn-ea"/>
-                <a:cs typeface="+mn-cs"/>
-              </a:rPr>
-              <a:t>:</a:t>
-            </a:r>
-          </a:p>
-          <a:p>
-            <a:r>
-              <a:rPr lang="ko-KR" altLang="ko-KR" sz="1200" b="1" i="0" kern="1200" dirty="0" err="1">
-                <a:solidFill>
-                  <a:schemeClr val="tx1"/>
-                </a:solidFill>
-                <a:effectLst/>
-                <a:latin typeface="+mn-lt"/>
-                <a:ea typeface="+mn-ea"/>
-                <a:cs typeface="+mn-cs"/>
-              </a:rPr>
-              <a:t>Low</a:t>
-            </a:r>
-            <a:r>
-              <a:rPr lang="ko-KR" altLang="ko-KR" sz="1200" b="1" i="0" kern="1200" dirty="0">
-                <a:solidFill>
-                  <a:schemeClr val="tx1"/>
-                </a:solidFill>
-                <a:effectLst/>
-                <a:latin typeface="+mn-lt"/>
-                <a:ea typeface="+mn-ea"/>
-                <a:cs typeface="+mn-cs"/>
-              </a:rPr>
-              <a:t> </a:t>
-            </a:r>
-            <a:r>
-              <a:rPr lang="ko-KR" altLang="ko-KR" sz="1200" b="1" i="0" kern="1200" dirty="0" err="1">
-                <a:solidFill>
-                  <a:schemeClr val="tx1"/>
-                </a:solidFill>
-                <a:effectLst/>
-                <a:latin typeface="+mn-lt"/>
-                <a:ea typeface="+mn-ea"/>
-                <a:cs typeface="+mn-cs"/>
-              </a:rPr>
-              <a:t>buffer</a:t>
-            </a:r>
-            <a:r>
-              <a:rPr lang="ko-KR" altLang="ko-KR" sz="1200" b="1" i="0" kern="1200" dirty="0">
-                <a:solidFill>
-                  <a:schemeClr val="tx1"/>
-                </a:solidFill>
-                <a:effectLst/>
-                <a:latin typeface="+mn-lt"/>
-                <a:ea typeface="+mn-ea"/>
-                <a:cs typeface="+mn-cs"/>
-              </a:rPr>
-              <a:t> </a:t>
-            </a:r>
-            <a:r>
-              <a:rPr lang="ko-KR" altLang="ko-KR" sz="1200" b="1" i="0" kern="1200" dirty="0" err="1">
-                <a:solidFill>
-                  <a:schemeClr val="tx1"/>
-                </a:solidFill>
-                <a:effectLst/>
-                <a:latin typeface="+mn-lt"/>
-                <a:ea typeface="+mn-ea"/>
-                <a:cs typeface="+mn-cs"/>
-              </a:rPr>
-              <a:t>events</a:t>
-            </a:r>
-            <a:r>
-              <a:rPr lang="ko-KR" altLang="ko-KR" sz="1200" b="0" i="0" kern="1200" dirty="0">
-                <a:solidFill>
-                  <a:schemeClr val="tx1"/>
-                </a:solidFill>
-                <a:effectLst/>
-                <a:latin typeface="+mn-lt"/>
-                <a:ea typeface="+mn-ea"/>
-                <a:cs typeface="+mn-cs"/>
-              </a:rPr>
-              <a:t> (LUNA + USDT): </a:t>
-            </a:r>
-            <a:r>
-              <a:rPr lang="ko-KR" altLang="ko-KR" sz="1200" b="0" i="0" kern="1200" dirty="0" err="1">
-                <a:solidFill>
-                  <a:schemeClr val="tx1"/>
-                </a:solidFill>
-                <a:effectLst/>
-                <a:latin typeface="+mn-lt"/>
-                <a:ea typeface="+mn-ea"/>
-                <a:cs typeface="+mn-cs"/>
-              </a:rPr>
-              <a:t>spread</a:t>
-            </a:r>
-            <a:r>
-              <a:rPr lang="ko-KR" altLang="ko-KR" sz="1200" b="0" i="0" kern="1200" dirty="0">
-                <a:solidFill>
-                  <a:schemeClr val="tx1"/>
-                </a:solidFill>
-                <a:effectLst/>
-                <a:latin typeface="+mn-lt"/>
-                <a:ea typeface="+mn-ea"/>
-                <a:cs typeface="+mn-cs"/>
-              </a:rPr>
-              <a:t> </a:t>
-            </a:r>
-            <a:r>
-              <a:rPr lang="ko-KR" altLang="ko-KR" sz="1200" b="0" i="0" kern="1200" dirty="0" err="1">
-                <a:solidFill>
-                  <a:schemeClr val="tx1"/>
-                </a:solidFill>
-                <a:effectLst/>
-                <a:latin typeface="+mn-lt"/>
-                <a:ea typeface="+mn-ea"/>
-                <a:cs typeface="+mn-cs"/>
-              </a:rPr>
-              <a:t>went</a:t>
-            </a:r>
-            <a:r>
-              <a:rPr lang="ko-KR" altLang="ko-KR" sz="1200" b="0" i="0" kern="1200" dirty="0">
-                <a:solidFill>
-                  <a:schemeClr val="tx1"/>
-                </a:solidFill>
-                <a:effectLst/>
-                <a:latin typeface="+mn-lt"/>
-                <a:ea typeface="+mn-ea"/>
-                <a:cs typeface="+mn-cs"/>
-              </a:rPr>
-              <a:t> </a:t>
-            </a:r>
-            <a:r>
-              <a:rPr lang="ko-KR" altLang="ko-KR" sz="1200" b="1" i="0" kern="1200" dirty="0">
-                <a:solidFill>
-                  <a:schemeClr val="tx1"/>
-                </a:solidFill>
-                <a:effectLst/>
-                <a:latin typeface="+mn-lt"/>
-                <a:ea typeface="+mn-ea"/>
-                <a:cs typeface="+mn-cs"/>
-              </a:rPr>
-              <a:t>+8.9 </a:t>
-            </a:r>
-            <a:r>
-              <a:rPr lang="ko-KR" altLang="ko-KR" sz="1200" b="1" i="0" kern="1200" dirty="0" err="1">
-                <a:solidFill>
-                  <a:schemeClr val="tx1"/>
-                </a:solidFill>
-                <a:effectLst/>
-                <a:latin typeface="+mn-lt"/>
-                <a:ea typeface="+mn-ea"/>
-                <a:cs typeface="+mn-cs"/>
-              </a:rPr>
-              <a:t>pp</a:t>
-            </a:r>
-            <a:r>
-              <a:rPr lang="ko-KR" altLang="ko-KR" sz="1200" b="0" i="0" kern="1200" dirty="0">
-                <a:solidFill>
-                  <a:schemeClr val="tx1"/>
-                </a:solidFill>
-                <a:effectLst/>
-                <a:latin typeface="+mn-lt"/>
-                <a:ea typeface="+mn-ea"/>
-                <a:cs typeface="+mn-cs"/>
-              </a:rPr>
-              <a:t> </a:t>
-            </a:r>
-            <a:r>
-              <a:rPr lang="ko-KR" altLang="ko-KR" sz="1200" b="0" i="0" kern="1200" dirty="0" err="1">
-                <a:solidFill>
-                  <a:schemeClr val="tx1"/>
-                </a:solidFill>
-                <a:effectLst/>
-                <a:latin typeface="+mn-lt"/>
-                <a:ea typeface="+mn-ea"/>
-                <a:cs typeface="+mn-cs"/>
-              </a:rPr>
-              <a:t>above</a:t>
-            </a:r>
-            <a:r>
-              <a:rPr lang="ko-KR" altLang="ko-KR" sz="1200" b="0" i="0" kern="1200" dirty="0">
-                <a:solidFill>
-                  <a:schemeClr val="tx1"/>
-                </a:solidFill>
-                <a:effectLst/>
-                <a:latin typeface="+mn-lt"/>
-                <a:ea typeface="+mn-ea"/>
-                <a:cs typeface="+mn-cs"/>
-              </a:rPr>
-              <a:t> </a:t>
-            </a:r>
-            <a:r>
-              <a:rPr lang="ko-KR" altLang="ko-KR" sz="1200" b="0" i="0" kern="1200" dirty="0" err="1">
-                <a:solidFill>
-                  <a:schemeClr val="tx1"/>
-                </a:solidFill>
-                <a:effectLst/>
-                <a:latin typeface="+mn-lt"/>
-                <a:ea typeface="+mn-ea"/>
-                <a:cs typeface="+mn-cs"/>
-              </a:rPr>
-              <a:t>normal</a:t>
-            </a:r>
-            <a:r>
-              <a:rPr lang="ko-KR" altLang="ko-KR" sz="1200" b="0" i="0" kern="1200" dirty="0">
-                <a:solidFill>
-                  <a:schemeClr val="tx1"/>
-                </a:solidFill>
-                <a:effectLst/>
-                <a:latin typeface="+mn-lt"/>
-                <a:ea typeface="+mn-ea"/>
-                <a:cs typeface="+mn-cs"/>
-              </a:rPr>
-              <a:t> </a:t>
-            </a:r>
-            <a:r>
-              <a:rPr lang="ko-KR" altLang="ko-KR" sz="1200" b="0" i="0" kern="1200" dirty="0" err="1">
-                <a:solidFill>
-                  <a:schemeClr val="tx1"/>
-                </a:solidFill>
-                <a:effectLst/>
-                <a:latin typeface="+mn-lt"/>
-                <a:ea typeface="+mn-ea"/>
-                <a:cs typeface="+mn-cs"/>
-              </a:rPr>
-              <a:t>on</a:t>
-            </a:r>
-            <a:r>
-              <a:rPr lang="ko-KR" altLang="ko-KR" sz="1200" b="0" i="0" kern="1200" dirty="0">
-                <a:solidFill>
-                  <a:schemeClr val="tx1"/>
-                </a:solidFill>
-                <a:effectLst/>
-                <a:latin typeface="+mn-lt"/>
-                <a:ea typeface="+mn-ea"/>
-                <a:cs typeface="+mn-cs"/>
-              </a:rPr>
-              <a:t> </a:t>
-            </a:r>
-            <a:r>
-              <a:rPr lang="ko-KR" altLang="ko-KR" sz="1200" b="0" i="0" kern="1200" dirty="0" err="1">
-                <a:solidFill>
-                  <a:schemeClr val="tx1"/>
-                </a:solidFill>
-                <a:effectLst/>
-                <a:latin typeface="+mn-lt"/>
-                <a:ea typeface="+mn-ea"/>
-                <a:cs typeface="+mn-cs"/>
-              </a:rPr>
-              <a:t>average</a:t>
-            </a:r>
             <a:endParaRPr lang="ko-KR" altLang="ko-KR" sz="1200" b="0" i="0" kern="1200" dirty="0">
               <a:solidFill>
                 <a:schemeClr val="tx1"/>
@@ -2077,78 +1884,6 @@
           </a:p>
           <a:p>
             <a:r>
-              <a:rPr lang="ko-KR" altLang="ko-KR" sz="1200" b="1" i="0" kern="1200" dirty="0" err="1">
-                <a:solidFill>
-                  <a:schemeClr val="tx1"/>
-                </a:solidFill>
-                <a:effectLst/>
-                <a:latin typeface="+mn-lt"/>
-                <a:ea typeface="+mn-ea"/>
-                <a:cs typeface="+mn-cs"/>
-              </a:rPr>
-              <a:t>High</a:t>
-            </a:r>
-            <a:r>
-              <a:rPr lang="ko-KR" altLang="ko-KR" sz="1200" b="1" i="0" kern="1200" dirty="0">
-                <a:solidFill>
-                  <a:schemeClr val="tx1"/>
-                </a:solidFill>
-                <a:effectLst/>
-                <a:latin typeface="+mn-lt"/>
-                <a:ea typeface="+mn-ea"/>
-                <a:cs typeface="+mn-cs"/>
-              </a:rPr>
-              <a:t> </a:t>
-            </a:r>
-            <a:r>
-              <a:rPr lang="ko-KR" altLang="ko-KR" sz="1200" b="1" i="0" kern="1200" dirty="0" err="1">
-                <a:solidFill>
-                  <a:schemeClr val="tx1"/>
-                </a:solidFill>
-                <a:effectLst/>
-                <a:latin typeface="+mn-lt"/>
-                <a:ea typeface="+mn-ea"/>
-                <a:cs typeface="+mn-cs"/>
-              </a:rPr>
-              <a:t>buffer</a:t>
-            </a:r>
-            <a:r>
-              <a:rPr lang="ko-KR" altLang="ko-KR" sz="1200" b="1" i="0" kern="1200" dirty="0">
-                <a:solidFill>
-                  <a:schemeClr val="tx1"/>
-                </a:solidFill>
-                <a:effectLst/>
-                <a:latin typeface="+mn-lt"/>
-                <a:ea typeface="+mn-ea"/>
-                <a:cs typeface="+mn-cs"/>
-              </a:rPr>
-              <a:t> </a:t>
-            </a:r>
-            <a:r>
-              <a:rPr lang="ko-KR" altLang="ko-KR" sz="1200" b="1" i="0" kern="1200" dirty="0" err="1">
-                <a:solidFill>
-                  <a:schemeClr val="tx1"/>
-                </a:solidFill>
-                <a:effectLst/>
-                <a:latin typeface="+mn-lt"/>
-                <a:ea typeface="+mn-ea"/>
-                <a:cs typeface="+mn-cs"/>
-              </a:rPr>
-              <a:t>event</a:t>
-            </a:r>
-            <a:r>
-              <a:rPr lang="ko-KR" altLang="ko-KR" sz="1200" b="0" i="0" kern="1200" dirty="0">
-                <a:solidFill>
-                  <a:schemeClr val="tx1"/>
-                </a:solidFill>
-                <a:effectLst/>
-                <a:latin typeface="+mn-lt"/>
-                <a:ea typeface="+mn-ea"/>
-                <a:cs typeface="+mn-cs"/>
-              </a:rPr>
-              <a:t> (SVB): </a:t>
-            </a:r>
-            <a:r>
               <a:rPr lang="ko-KR" altLang="ko-KR" sz="1200" b="0" i="0" kern="1200" dirty="0" err="1">
                 <a:solidFill>
                   <a:schemeClr val="tx1"/>
@@ -2158,7 +1893,7 @@
                 <a:ea typeface="+mn-ea"/>
                 <a:cs typeface="+mn-cs"/>
               </a:rPr>
-              <a:t>spread</a:t>
+              <a:t>You</a:t>
             </a:r>
             <a:r>
               <a:rPr lang="ko-KR" altLang="ko-KR" sz="1200" b="0" i="0" kern="1200" dirty="0">
@@ -2182,55 +1917,19 @@
                 <a:ea typeface="+mn-ea"/>
                 <a:cs typeface="+mn-cs"/>
               </a:rPr>
-              <a:t>went</a:t>
-            </a:r>
-            <a:r>
-              <a:rPr lang="ko-KR" altLang="ko-KR" sz="1200" b="0" i="0" kern="1200" dirty="0">
-                <a:solidFill>
-                  <a:schemeClr val="tx1"/>
-                </a:solidFill>
-                <a:effectLst/>
-                <a:latin typeface="+mn-lt"/>
-                <a:ea typeface="+mn-ea"/>
-                <a:cs typeface="+mn-cs"/>
-              </a:rPr>
-              <a:t> </a:t>
-            </a:r>
-            <a:r>
-              <a:rPr lang="ko-KR" altLang="ko-KR" sz="1200" b="1" i="0" kern="1200" dirty="0">
-                <a:solidFill>
-                  <a:schemeClr val="tx1"/>
-                </a:solidFill>
-                <a:effectLst/>
-                <a:latin typeface="+mn-lt"/>
-                <a:ea typeface="+mn-ea"/>
-                <a:cs typeface="+mn-cs"/>
-              </a:rPr>
-              <a:t>−18.0 </a:t>
-            </a:r>
-            <a:r>
-              <a:rPr lang="ko-KR" altLang="ko-KR" sz="1200" b="1" i="0" kern="1200" dirty="0" err="1">
-                <a:solidFill>
-                  <a:schemeClr val="tx1"/>
-                </a:solidFill>
-                <a:effectLst/>
-                <a:latin typeface="+mn-lt"/>
-                <a:ea typeface="+mn-ea"/>
-                <a:cs typeface="+mn-cs"/>
-              </a:rPr>
-              <a:t>pp</a:t>
-            </a:r>
-            <a:r>
-              <a:rPr lang="ko-KR" altLang="ko-KR" sz="1200" b="0" i="0" kern="1200" dirty="0">
-                <a:solidFill>
-                  <a:schemeClr val="tx1"/>
-                </a:solidFill>
-                <a:effectLst/>
-                <a:latin typeface="+mn-lt"/>
-                <a:ea typeface="+mn-ea"/>
-                <a:cs typeface="+mn-cs"/>
-              </a:rPr>
-              <a:t> </a:t>
+              <a:t>have</a:t>
+            </a:r>
+            <a:r>
+              <a:rPr lang="ko-KR" altLang="ko-KR" sz="1200" b="0" i="0" kern="1200" dirty="0">
+                <a:solidFill>
+                  <a:schemeClr val="tx1"/>
+                </a:solidFill>
+                <a:effectLst/>
+                <a:latin typeface="+mn-lt"/>
+                <a:ea typeface="+mn-ea"/>
+                <a:cs typeface="+mn-cs"/>
+              </a:rPr>
+              <a:t> </a:t>
             </a:r>
             <a:r>
               <a:rPr lang="ko-KR" altLang="ko-KR" sz="1200" b="0" i="0" kern="1200" dirty="0" err="1">
@@ -2242,7 +1941,7 @@
                 <a:ea typeface="+mn-ea"/>
                 <a:cs typeface="+mn-cs"/>
               </a:rPr>
-              <a:t>below</a:t>
+              <a:t>two</a:t>
             </a:r>
             <a:r>
               <a:rPr lang="ko-KR" altLang="ko-KR" sz="1200" b="0" i="0" kern="1200" dirty="0">
@@ -2266,7 +1965,43 @@
                 <a:ea typeface="+mn-ea"/>
                 <a:cs typeface="+mn-cs"/>
               </a:rPr>
-              <a:t>normal</a:t>
+              <a:t>groups</a:t>
+            </a:r>
+            <a:r>
+              <a:rPr lang="ko-KR" altLang="ko-KR" sz="1200" b="0" i="0" kern="1200" dirty="0">
+                <a:solidFill>
+                  <a:schemeClr val="tx1"/>
+                </a:solidFill>
+                <a:effectLst/>
+                <a:latin typeface="+mn-lt"/>
+                <a:ea typeface="+mn-ea"/>
+                <a:cs typeface="+mn-cs"/>
+              </a:rPr>
+              <a:t> of </a:t>
+            </a:r>
+            <a:r>
+              <a:rPr lang="ko-KR" altLang="ko-KR" sz="1200" b="0" i="0" kern="1200" dirty="0" err="1">
+                <a:solidFill>
+                  <a:schemeClr val="tx1"/>
+                </a:solidFill>
+                <a:effectLst/>
+                <a:latin typeface="+mn-lt"/>
+                <a:ea typeface="+mn-ea"/>
+                <a:cs typeface="+mn-cs"/>
+              </a:rPr>
+              <a:t>events</a:t>
+            </a:r>
+            <a:r>
+              <a:rPr lang="ko-KR" altLang="ko-KR" sz="1200" b="0" i="0" kern="1200" dirty="0">
+                <a:solidFill>
+                  <a:schemeClr val="tx1"/>
+                </a:solidFill>
+                <a:effectLst/>
+                <a:latin typeface="+mn-lt"/>
+                <a:ea typeface="+mn-ea"/>
+                <a:cs typeface="+mn-cs"/>
+              </a:rPr>
+              <a:t>:</a:t>
             </a:r>
             <a:endParaRPr lang="ko-KR" altLang="ko-KR" sz="1200" b="0" i="0" kern="1200" dirty="0">
               <a:solidFill>
@@ -2280,16 +2015,76 @@
           </a:p>
           <a:p>
             <a:r>
-              <a:rPr lang="ko-KR" altLang="ko-KR" sz="1200" b="0" i="0" kern="1200" dirty="0">
-                <a:solidFill>
-                  <a:schemeClr val="tx1"/>
-                </a:solidFill>
-                <a:effectLst/>
-                <a:latin typeface="+mn-lt"/>
-                <a:ea typeface="+mn-ea"/>
-                <a:cs typeface="+mn-cs"/>
-              </a:rPr>
-              <a:t>The </a:t>
+              <a:rPr lang="ko-KR" altLang="ko-KR" sz="1200" b="1" i="0" kern="1200" dirty="0" err="1">
+                <a:solidFill>
+                  <a:schemeClr val="tx1"/>
+                </a:solidFill>
+                <a:effectLst/>
+                <a:latin typeface="+mn-lt"/>
+                <a:ea typeface="+mn-ea"/>
+                <a:cs typeface="+mn-cs"/>
+              </a:rPr>
+              <a:t>Low</a:t>
+            </a:r>
+            <a:r>
+              <a:rPr lang="ko-KR" altLang="ko-KR" sz="1200" b="1" i="0" kern="1200" dirty="0">
+                <a:solidFill>
+                  <a:schemeClr val="tx1"/>
+                </a:solidFill>
+                <a:effectLst/>
+                <a:latin typeface="+mn-lt"/>
+                <a:ea typeface="+mn-ea"/>
+                <a:cs typeface="+mn-cs"/>
+              </a:rPr>
+              <a:t> </a:t>
+            </a:r>
+            <a:r>
+              <a:rPr lang="ko-KR" altLang="ko-KR" sz="1200" b="1" i="0" kern="1200" dirty="0" err="1">
+                <a:solidFill>
+                  <a:schemeClr val="tx1"/>
+                </a:solidFill>
+                <a:effectLst/>
+                <a:latin typeface="+mn-lt"/>
+                <a:ea typeface="+mn-ea"/>
+                <a:cs typeface="+mn-cs"/>
+              </a:rPr>
+              <a:t>buffer</a:t>
+            </a:r>
+            <a:r>
+              <a:rPr lang="ko-KR" altLang="ko-KR" sz="1200" b="1" i="0" kern="1200" dirty="0">
+                <a:solidFill>
+                  <a:schemeClr val="tx1"/>
+                </a:solidFill>
+                <a:effectLst/>
+                <a:latin typeface="+mn-lt"/>
+                <a:ea typeface="+mn-ea"/>
+                <a:cs typeface="+mn-cs"/>
+              </a:rPr>
+              <a:t> </a:t>
+            </a:r>
+            <a:r>
+              <a:rPr lang="ko-KR" altLang="ko-KR" sz="1200" b="1" i="0" kern="1200" dirty="0" err="1">
+                <a:solidFill>
+                  <a:schemeClr val="tx1"/>
+                </a:solidFill>
+                <a:effectLst/>
+                <a:latin typeface="+mn-lt"/>
+                <a:ea typeface="+mn-ea"/>
+                <a:cs typeface="+mn-cs"/>
+              </a:rPr>
+              <a:t>events</a:t>
+            </a:r>
+            <a:r>
+              <a:rPr lang="ko-KR" altLang="ko-KR" sz="1200" b="0" i="0" kern="1200" dirty="0">
+                <a:solidFill>
+                  <a:schemeClr val="tx1"/>
+                </a:solidFill>
+                <a:effectLst/>
+                <a:latin typeface="+mn-lt"/>
+                <a:ea typeface="+mn-ea"/>
+                <a:cs typeface="+mn-cs"/>
+              </a:rPr>
+              <a:t> (LUNA + USDT): </a:t>
             </a:r>
             <a:r>
               <a:rPr lang="ko-KR" altLang="ko-KR" sz="1200" b="0" i="0" kern="1200" dirty="0" err="1">
@@ -2301,7 +2096,7 @@
                 <a:ea typeface="+mn-ea"/>
                 <a:cs typeface="+mn-cs"/>
               </a:rPr>
-              <a:t>swing</a:t>
+              <a:t>spread</a:t>
             </a:r>
             <a:r>
               <a:rPr lang="ko-KR" altLang="ko-KR" sz="1200" b="0" i="0" kern="1200" dirty="0">
@@ -2325,19 +2120,55 @@
                 <a:ea typeface="+mn-ea"/>
                 <a:cs typeface="+mn-cs"/>
               </a:rPr>
-              <a:t>is</a:t>
-            </a:r>
-            <a:r>
-              <a:rPr lang="ko-KR" altLang="ko-KR" sz="1200" b="0" i="0" kern="1200" dirty="0">
-                <a:solidFill>
-                  <a:schemeClr val="tx1"/>
-                </a:solidFill>
-                <a:effectLst/>
-                <a:latin typeface="+mn-lt"/>
-                <a:ea typeface="+mn-ea"/>
-                <a:cs typeface="+mn-cs"/>
-              </a:rPr>
-              <a:t> </a:t>
+              <a:t>went</a:t>
+            </a:r>
+            <a:r>
+              <a:rPr lang="ko-KR" altLang="ko-KR" sz="1200" b="0" i="0" kern="1200" dirty="0">
+                <a:solidFill>
+                  <a:schemeClr val="tx1"/>
+                </a:solidFill>
+                <a:effectLst/>
+                <a:latin typeface="+mn-lt"/>
+                <a:ea typeface="+mn-ea"/>
+                <a:cs typeface="+mn-cs"/>
+              </a:rPr>
+              <a:t> </a:t>
+            </a:r>
+            <a:r>
+              <a:rPr lang="ko-KR" altLang="ko-KR" sz="1200" b="1" i="0" kern="1200" dirty="0">
+                <a:solidFill>
+                  <a:schemeClr val="tx1"/>
+                </a:solidFill>
+                <a:effectLst/>
+                <a:latin typeface="+mn-lt"/>
+                <a:ea typeface="+mn-ea"/>
+                <a:cs typeface="+mn-cs"/>
+              </a:rPr>
+              <a:t>+8.9 </a:t>
+            </a:r>
+            <a:r>
+              <a:rPr lang="ko-KR" altLang="ko-KR" sz="1200" b="1" i="0" kern="1200" dirty="0" err="1">
+                <a:solidFill>
+                  <a:schemeClr val="tx1"/>
+                </a:solidFill>
+                <a:effectLst/>
+                <a:latin typeface="+mn-lt"/>
+                <a:ea typeface="+mn-ea"/>
+                <a:cs typeface="+mn-cs"/>
+              </a:rPr>
+              <a:t>pp</a:t>
+            </a:r>
+            <a:r>
+              <a:rPr lang="ko-KR" altLang="ko-KR" sz="1200" b="0" i="0" kern="1200" dirty="0">
+                <a:solidFill>
+                  <a:schemeClr val="tx1"/>
+                </a:solidFill>
+                <a:effectLst/>
+                <a:latin typeface="+mn-lt"/>
+                <a:ea typeface="+mn-ea"/>
+                <a:cs typeface="+mn-cs"/>
+              </a:rPr>
+              <a:t> </a:t>
             </a:r>
             <a:r>
               <a:rPr lang="ko-KR" altLang="ko-KR" sz="1200" b="0" i="0" kern="1200" dirty="0" err="1">
@@ -2349,7 +2180,7 @@
                 <a:ea typeface="+mn-ea"/>
                 <a:cs typeface="+mn-cs"/>
               </a:rPr>
-              <a:t>the</a:t>
+              <a:t>above</a:t>
             </a:r>
             <a:r>
               <a:rPr lang="ko-KR" altLang="ko-KR" sz="1200" b="0" i="0" kern="1200" dirty="0">
@@ -2373,7 +2204,7 @@
                 <a:ea typeface="+mn-ea"/>
                 <a:cs typeface="+mn-cs"/>
               </a:rPr>
-              <a:t>gap</a:t>
+              <a:t>normal</a:t>
             </a:r>
             <a:r>
               <a:rPr lang="ko-KR" altLang="ko-KR" sz="1200" b="0" i="0" kern="1200" dirty="0">
@@ -2397,7 +2228,7 @@
                 <a:ea typeface="+mn-ea"/>
                 <a:cs typeface="+mn-cs"/>
               </a:rPr>
-              <a:t>between</a:t>
+              <a:t>on</a:t>
             </a:r>
             <a:r>
               <a:rPr lang="ko-KR" altLang="ko-KR" sz="1200" b="0" i="0" kern="1200" dirty="0">
@@ -2421,57 +2252,7 @@
                 <a:ea typeface="+mn-ea"/>
                 <a:cs typeface="+mn-cs"/>
               </a:rPr>
-              <a:t>them</a:t>
-            </a:r>
-            <a:r>
-              <a:rPr lang="ko-KR" altLang="ko-KR" sz="1200" b="0" i="0" kern="1200" dirty="0">
-                <a:solidFill>
-                  <a:schemeClr val="tx1"/>
-                </a:solidFill>
-                <a:effectLst/>
-                <a:latin typeface="+mn-lt"/>
-                <a:ea typeface="+mn-ea"/>
-                <a:cs typeface="+mn-cs"/>
-              </a:rPr>
-              <a:t>:</a:t>
-            </a:r>
-          </a:p>
-          <a:p>
-            <a:r>
-              <a:rPr lang="ko-KR" altLang="ko-KR" sz="1200" b="0" i="0" kern="1200" dirty="0">
-                <a:solidFill>
-                  <a:schemeClr val="tx1"/>
-                </a:solidFill>
-                <a:effectLst/>
-                <a:latin typeface="+mn-lt"/>
-                <a:ea typeface="+mn-ea"/>
-                <a:cs typeface="+mn-cs"/>
-              </a:rPr>
-              <a:t>8.9 − (−18.0) = </a:t>
-            </a:r>
-            <a:r>
-              <a:rPr lang="ko-KR" altLang="ko-KR" sz="1200" b="1" i="0" kern="1200" dirty="0">
-                <a:solidFill>
-                  <a:schemeClr val="tx1"/>
-                </a:solidFill>
-                <a:effectLst/>
-                <a:latin typeface="+mn-lt"/>
-                <a:ea typeface="+mn-ea"/>
-                <a:cs typeface="+mn-cs"/>
-              </a:rPr>
-              <a:t>26.9 </a:t>
-            </a:r>
-            <a:r>
-              <a:rPr lang="ko-KR" altLang="ko-KR" sz="1200" b="1" i="0" kern="1200" dirty="0" err="1">
-                <a:solidFill>
-                  <a:schemeClr val="tx1"/>
-                </a:solidFill>
-                <a:effectLst/>
-                <a:latin typeface="+mn-lt"/>
-                <a:ea typeface="+mn-ea"/>
-                <a:cs typeface="+mn-cs"/>
-              </a:rPr>
-              <a:t>pp</a:t>
+              <a:t>average</a:t>
             </a:r>
             <a:endParaRPr lang="ko-KR" altLang="ko-KR" sz="1200" b="0" i="0" kern="1200" dirty="0">
               <a:solidFill>
@@ -2485,6 +2266,78 @@
           </a:p>
           <a:p>
             <a:r>
+              <a:rPr lang="ko-KR" altLang="ko-KR" sz="1200" b="1" i="0" kern="1200" dirty="0" err="1">
+                <a:solidFill>
+                  <a:schemeClr val="tx1"/>
+                </a:solidFill>
+                <a:effectLst/>
+                <a:latin typeface="+mn-lt"/>
+                <a:ea typeface="+mn-ea"/>
+                <a:cs typeface="+mn-cs"/>
+              </a:rPr>
+              <a:t>High</a:t>
+            </a:r>
+            <a:r>
+              <a:rPr lang="ko-KR" altLang="ko-KR" sz="1200" b="1" i="0" kern="1200" dirty="0">
+                <a:solidFill>
+                  <a:schemeClr val="tx1"/>
+                </a:solidFill>
+                <a:effectLst/>
+                <a:latin typeface="+mn-lt"/>
+                <a:ea typeface="+mn-ea"/>
+                <a:cs typeface="+mn-cs"/>
+              </a:rPr>
+              <a:t> </a:t>
+            </a:r>
+            <a:r>
+              <a:rPr lang="ko-KR" altLang="ko-KR" sz="1200" b="1" i="0" kern="1200" dirty="0" err="1">
+                <a:solidFill>
+                  <a:schemeClr val="tx1"/>
+                </a:solidFill>
+                <a:effectLst/>
+                <a:latin typeface="+mn-lt"/>
+                <a:ea typeface="+mn-ea"/>
+                <a:cs typeface="+mn-cs"/>
+              </a:rPr>
+              <a:t>buffer</a:t>
+            </a:r>
+            <a:r>
+              <a:rPr lang="ko-KR" altLang="ko-KR" sz="1200" b="1" i="0" kern="1200" dirty="0">
+                <a:solidFill>
+                  <a:schemeClr val="tx1"/>
+                </a:solidFill>
+                <a:effectLst/>
+                <a:latin typeface="+mn-lt"/>
+                <a:ea typeface="+mn-ea"/>
+                <a:cs typeface="+mn-cs"/>
+              </a:rPr>
+              <a:t> </a:t>
+            </a:r>
+            <a:r>
+              <a:rPr lang="ko-KR" altLang="ko-KR" sz="1200" b="1" i="0" kern="1200" dirty="0" err="1">
+                <a:solidFill>
+                  <a:schemeClr val="tx1"/>
+                </a:solidFill>
+                <a:effectLst/>
+                <a:latin typeface="+mn-lt"/>
+                <a:ea typeface="+mn-ea"/>
+                <a:cs typeface="+mn-cs"/>
+              </a:rPr>
+              <a:t>event</a:t>
+            </a:r>
+            <a:r>
+              <a:rPr lang="ko-KR" altLang="ko-KR" sz="1200" b="0" i="0" kern="1200" dirty="0">
+                <a:solidFill>
+                  <a:schemeClr val="tx1"/>
+                </a:solidFill>
+                <a:effectLst/>
+                <a:latin typeface="+mn-lt"/>
+                <a:ea typeface="+mn-ea"/>
+                <a:cs typeface="+mn-cs"/>
+              </a:rPr>
+              <a:t> (SVB): </a:t>
+            </a:r>
+            <a:r>
               <a:rPr lang="ko-KR" altLang="ko-KR" sz="1200" b="0" i="0" kern="1200" dirty="0" err="1">
                 <a:solidFill>
                   <a:schemeClr val="tx1"/>
@@ -2494,6 +2347,351 @@
                 <a:ea typeface="+mn-ea"/>
                 <a:cs typeface="+mn-cs"/>
               </a:rPr>
+              <a:t>spread</a:t>
+            </a:r>
+            <a:r>
+              <a:rPr lang="ko-KR" altLang="ko-KR" sz="1200" b="0" i="0" kern="1200" dirty="0">
+                <a:solidFill>
+                  <a:schemeClr val="tx1"/>
+                </a:solidFill>
+                <a:effectLst/>
+                <a:latin typeface="+mn-lt"/>
+                <a:ea typeface="+mn-ea"/>
+                <a:cs typeface="+mn-cs"/>
+              </a:rPr>
+              <a:t> </a:t>
+            </a:r>
+            <a:r>
+              <a:rPr lang="ko-KR" altLang="ko-KR" sz="1200" b="0" i="0" kern="1200" dirty="0" err="1">
+                <a:solidFill>
+                  <a:schemeClr val="tx1"/>
+                </a:solidFill>
+                <a:effectLst/>
+                <a:latin typeface="+mn-lt"/>
+                <a:ea typeface="+mn-ea"/>
+                <a:cs typeface="+mn-cs"/>
+              </a:rPr>
+              <a:t>went</a:t>
+            </a:r>
+            <a:r>
+              <a:rPr lang="ko-KR" altLang="ko-KR" sz="1200" b="0" i="0" kern="1200" dirty="0">
+                <a:solidFill>
+                  <a:schemeClr val="tx1"/>
+                </a:solidFill>
+                <a:effectLst/>
+                <a:latin typeface="+mn-lt"/>
+                <a:ea typeface="+mn-ea"/>
+                <a:cs typeface="+mn-cs"/>
+              </a:rPr>
+              <a:t> </a:t>
+            </a:r>
+            <a:r>
+              <a:rPr lang="ko-KR" altLang="ko-KR" sz="1200" b="1" i="0" kern="1200" dirty="0">
+                <a:solidFill>
+                  <a:schemeClr val="tx1"/>
+                </a:solidFill>
+                <a:effectLst/>
+                <a:latin typeface="+mn-lt"/>
+                <a:ea typeface="+mn-ea"/>
+                <a:cs typeface="+mn-cs"/>
+              </a:rPr>
+              <a:t>−18.0 </a:t>
+            </a:r>
+            <a:r>
+              <a:rPr lang="ko-KR" altLang="ko-KR" sz="1200" b="1" i="0" kern="1200" dirty="0" err="1">
+                <a:solidFill>
+                  <a:schemeClr val="tx1"/>
+                </a:solidFill>
+                <a:effectLst/>
+                <a:latin typeface="+mn-lt"/>
+                <a:ea typeface="+mn-ea"/>
+                <a:cs typeface="+mn-cs"/>
+              </a:rPr>
+              <a:t>pp</a:t>
+            </a:r>
+            <a:r>
+              <a:rPr lang="ko-KR" altLang="ko-KR" sz="1200" b="0" i="0" kern="1200" dirty="0">
+                <a:solidFill>
+                  <a:schemeClr val="tx1"/>
+                </a:solidFill>
+                <a:effectLst/>
+                <a:latin typeface="+mn-lt"/>
+                <a:ea typeface="+mn-ea"/>
+                <a:cs typeface="+mn-cs"/>
+              </a:rPr>
+              <a:t> </a:t>
+            </a:r>
+            <a:r>
+              <a:rPr lang="ko-KR" altLang="ko-KR" sz="1200" b="0" i="0" kern="1200" dirty="0" err="1">
+                <a:solidFill>
+                  <a:schemeClr val="tx1"/>
+                </a:solidFill>
+                <a:effectLst/>
+                <a:latin typeface="+mn-lt"/>
+                <a:ea typeface="+mn-ea"/>
+                <a:cs typeface="+mn-cs"/>
+              </a:rPr>
+              <a:t>below</a:t>
+            </a:r>
+            <a:r>
+              <a:rPr lang="ko-KR" altLang="ko-KR" sz="1200" b="0" i="0" kern="1200" dirty="0">
+                <a:solidFill>
+                  <a:schemeClr val="tx1"/>
+                </a:solidFill>
+                <a:effectLst/>
+                <a:latin typeface="+mn-lt"/>
+                <a:ea typeface="+mn-ea"/>
+                <a:cs typeface="+mn-cs"/>
+              </a:rPr>
+              <a:t> </a:t>
+            </a:r>
+            <a:r>
+              <a:rPr lang="ko-KR" altLang="ko-KR" sz="1200" b="0" i="0" kern="1200" dirty="0" err="1">
+                <a:solidFill>
+                  <a:schemeClr val="tx1"/>
+                </a:solidFill>
+                <a:effectLst/>
+                <a:latin typeface="+mn-lt"/>
+                <a:ea typeface="+mn-ea"/>
+                <a:cs typeface="+mn-cs"/>
+              </a:rPr>
+              <a:t>normal</a:t>
+            </a:r>
+            <a:endParaRPr lang="ko-KR" altLang="ko-KR" sz="1200" b="0" i="0" kern="1200" dirty="0">
+              <a:solidFill>
+                <a:schemeClr val="tx1"/>
+              </a:solidFill>
+              <a:effectLst/>
+              <a:latin typeface="+mn-lt"/>
+              <a:ea typeface="+mn-ea"/>
+              <a:cs typeface="+mn-cs"/>
+            </a:endParaRPr>
+          </a:p>
+          <a:p>
+            <a:r>
+              <a:rPr lang="ko-KR" altLang="ko-KR" sz="1200" b="0" i="0" kern="1200" dirty="0">
+                <a:solidFill>
+                  <a:schemeClr val="tx1"/>
+                </a:solidFill>
+                <a:effectLst/>
+                <a:latin typeface="+mn-lt"/>
+                <a:ea typeface="+mn-ea"/>
+                <a:cs typeface="+mn-cs"/>
+              </a:rPr>
+              <a:t>The </a:t>
+            </a:r>
+            <a:r>
+              <a:rPr lang="ko-KR" altLang="ko-KR" sz="1200" b="0" i="0" kern="1200" dirty="0" err="1">
+                <a:solidFill>
+                  <a:schemeClr val="tx1"/>
+                </a:solidFill>
+                <a:effectLst/>
+                <a:latin typeface="+mn-lt"/>
+                <a:ea typeface="+mn-ea"/>
+                <a:cs typeface="+mn-cs"/>
+              </a:rPr>
+              <a:t>swing</a:t>
+            </a:r>
+            <a:r>
+              <a:rPr lang="ko-KR" altLang="ko-KR" sz="1200" b="0" i="0" kern="1200" dirty="0">
+                <a:solidFill>
+                  <a:schemeClr val="tx1"/>
+                </a:solidFill>
+                <a:effectLst/>
+                <a:latin typeface="+mn-lt"/>
+                <a:ea typeface="+mn-ea"/>
+                <a:cs typeface="+mn-cs"/>
+              </a:rPr>
+              <a:t> </a:t>
+            </a:r>
+            <a:r>
+              <a:rPr lang="ko-KR" altLang="ko-KR" sz="1200" b="0" i="0" kern="1200" dirty="0" err="1">
+                <a:solidFill>
+                  <a:schemeClr val="tx1"/>
+                </a:solidFill>
+                <a:effectLst/>
+                <a:latin typeface="+mn-lt"/>
+                <a:ea typeface="+mn-ea"/>
+                <a:cs typeface="+mn-cs"/>
+              </a:rPr>
+              <a:t>is</a:t>
+            </a:r>
+            <a:r>
+              <a:rPr lang="ko-KR" altLang="ko-KR" sz="1200" b="0" i="0" kern="1200" dirty="0">
+                <a:solidFill>
+                  <a:schemeClr val="tx1"/>
+                </a:solidFill>
+                <a:effectLst/>
+                <a:latin typeface="+mn-lt"/>
+                <a:ea typeface="+mn-ea"/>
+                <a:cs typeface="+mn-cs"/>
+              </a:rPr>
+              <a:t> </a:t>
+            </a:r>
+            <a:r>
+              <a:rPr lang="ko-KR" altLang="ko-KR" sz="1200" b="0" i="0" kern="1200" dirty="0" err="1">
+                <a:solidFill>
+                  <a:schemeClr val="tx1"/>
+                </a:solidFill>
+                <a:effectLst/>
+                <a:latin typeface="+mn-lt"/>
+                <a:ea typeface="+mn-ea"/>
+                <a:cs typeface="+mn-cs"/>
+              </a:rPr>
+              <a:t>the</a:t>
+            </a:r>
+            <a:r>
+              <a:rPr lang="ko-KR" altLang="ko-KR" sz="1200" b="0" i="0" kern="1200" dirty="0">
+                <a:solidFill>
+                  <a:schemeClr val="tx1"/>
+                </a:solidFill>
+                <a:effectLst/>
+                <a:latin typeface="+mn-lt"/>
+                <a:ea typeface="+mn-ea"/>
+                <a:cs typeface="+mn-cs"/>
+              </a:rPr>
+              <a:t> </a:t>
+            </a:r>
+            <a:r>
+              <a:rPr lang="ko-KR" altLang="ko-KR" sz="1200" b="0" i="0" kern="1200" dirty="0" err="1">
+                <a:solidFill>
+                  <a:schemeClr val="tx1"/>
+                </a:solidFill>
+                <a:effectLst/>
+                <a:latin typeface="+mn-lt"/>
+                <a:ea typeface="+mn-ea"/>
+                <a:cs typeface="+mn-cs"/>
+              </a:rPr>
+              <a:t>gap</a:t>
+            </a:r>
+            <a:r>
+              <a:rPr lang="ko-KR" altLang="ko-KR" sz="1200" b="0" i="0" kern="1200" dirty="0">
+                <a:solidFill>
+                  <a:schemeClr val="tx1"/>
+                </a:solidFill>
+                <a:effectLst/>
+                <a:latin typeface="+mn-lt"/>
+                <a:ea typeface="+mn-ea"/>
+                <a:cs typeface="+mn-cs"/>
+              </a:rPr>
+              <a:t> </a:t>
+            </a:r>
+            <a:r>
+              <a:rPr lang="ko-KR" altLang="ko-KR" sz="1200" b="0" i="0" kern="1200" dirty="0" err="1">
+                <a:solidFill>
+                  <a:schemeClr val="tx1"/>
+                </a:solidFill>
+                <a:effectLst/>
+                <a:latin typeface="+mn-lt"/>
+                <a:ea typeface="+mn-ea"/>
+                <a:cs typeface="+mn-cs"/>
+              </a:rPr>
+              <a:t>between</a:t>
+            </a:r>
+            <a:r>
+              <a:rPr lang="ko-KR" altLang="ko-KR" sz="1200" b="0" i="0" kern="1200" dirty="0">
+                <a:solidFill>
+                  <a:schemeClr val="tx1"/>
+                </a:solidFill>
+                <a:effectLst/>
+                <a:latin typeface="+mn-lt"/>
+                <a:ea typeface="+mn-ea"/>
+                <a:cs typeface="+mn-cs"/>
+              </a:rPr>
+              <a:t> </a:t>
+            </a:r>
+            <a:r>
+              <a:rPr lang="ko-KR" altLang="ko-KR" sz="1200" b="0" i="0" kern="1200" dirty="0" err="1">
+                <a:solidFill>
+                  <a:schemeClr val="tx1"/>
+                </a:solidFill>
+                <a:effectLst/>
+                <a:latin typeface="+mn-lt"/>
+                <a:ea typeface="+mn-ea"/>
+                <a:cs typeface="+mn-cs"/>
+              </a:rPr>
+              <a:t>them</a:t>
+            </a:r>
+            <a:r>
+              <a:rPr lang="ko-KR" altLang="ko-KR" sz="1200" b="0" i="0" kern="1200" dirty="0">
+                <a:solidFill>
+                  <a:schemeClr val="tx1"/>
+                </a:solidFill>
+                <a:effectLst/>
+                <a:latin typeface="+mn-lt"/>
+                <a:ea typeface="+mn-ea"/>
+                <a:cs typeface="+mn-cs"/>
+              </a:rPr>
+              <a:t>:</a:t>
+            </a:r>
+            <a:endParaRPr lang="ko-KR" altLang="ko-KR" sz="1200" b="0" i="0" kern="1200" dirty="0">
+              <a:solidFill>
+                <a:schemeClr val="tx1"/>
+              </a:solidFill>
+              <a:effectLst/>
+              <a:latin typeface="+mn-lt"/>
+              <a:ea typeface="+mn-ea"/>
+              <a:cs typeface="+mn-cs"/>
+            </a:endParaRPr>
+          </a:p>
+          <a:p>
+            <a:r>
+              <a:rPr lang="ko-KR" altLang="ko-KR" sz="1200" b="0" i="0" kern="1200" dirty="0">
+                <a:solidFill>
+                  <a:schemeClr val="tx1"/>
+                </a:solidFill>
+                <a:effectLst/>
+                <a:latin typeface="+mn-lt"/>
+                <a:ea typeface="+mn-ea"/>
+                <a:cs typeface="+mn-cs"/>
+              </a:rPr>
+              <a:t>8.9 − (−18.0) = </a:t>
+            </a:r>
+            <a:r>
+              <a:rPr lang="ko-KR" altLang="ko-KR" sz="1200" b="1" i="0" kern="1200" dirty="0">
+                <a:solidFill>
+                  <a:schemeClr val="tx1"/>
+                </a:solidFill>
+                <a:effectLst/>
+                <a:latin typeface="+mn-lt"/>
+                <a:ea typeface="+mn-ea"/>
+                <a:cs typeface="+mn-cs"/>
+              </a:rPr>
+              <a:t>26.9 </a:t>
+            </a:r>
+            <a:r>
+              <a:rPr lang="ko-KR" altLang="ko-KR" sz="1200" b="1" i="0" kern="1200" dirty="0" err="1">
+                <a:solidFill>
+                  <a:schemeClr val="tx1"/>
+                </a:solidFill>
+                <a:effectLst/>
+                <a:latin typeface="+mn-lt"/>
+                <a:ea typeface="+mn-ea"/>
+                <a:cs typeface="+mn-cs"/>
+              </a:rPr>
+              <a:t>pp</a:t>
+            </a:r>
+            <a:endParaRPr lang="ko-KR" altLang="ko-KR" sz="1200" b="0" i="0" kern="1200" dirty="0">
+              <a:solidFill>
+                <a:schemeClr val="tx1"/>
+              </a:solidFill>
+              <a:effectLst/>
+              <a:latin typeface="+mn-lt"/>
+              <a:ea typeface="+mn-ea"/>
+              <a:cs typeface="+mn-cs"/>
+            </a:endParaRPr>
+          </a:p>
+          <a:p>
+            <a:r>
+              <a:rPr lang="ko-KR" altLang="ko-KR" sz="1200" b="0" i="0" kern="1200" dirty="0" err="1">
+                <a:solidFill>
+                  <a:schemeClr val="tx1"/>
+                </a:solidFill>
+                <a:effectLst/>
+                <a:latin typeface="+mn-lt"/>
+                <a:ea typeface="+mn-ea"/>
+                <a:cs typeface="+mn-cs"/>
+              </a:rPr>
               <a:t>It</a:t>
             </a:r>
             <a:r>
@@ -3492,6 +3690,15 @@
               </a:rPr>
               <a:t>.</a:t>
             </a:r>
+            <a:endParaRPr lang="ko-KR" altLang="ko-KR" sz="1200" b="0" i="0" kern="1200" dirty="0">
+              <a:solidFill>
+                <a:schemeClr val="tx1"/>
+              </a:solidFill>
+              <a:effectLst/>
+              <a:latin typeface="+mn-lt"/>
+              <a:ea typeface="+mn-ea"/>
+              <a:cs typeface="+mn-cs"/>
+            </a:endParaRPr>
           </a:p>
           <a:p>
             <a:br>
@@ -4386,6 +4593,15 @@
               </a:rPr>
               <a:t>:</a:t>
             </a:r>
+            <a:endParaRPr lang="ko-KR" altLang="ko-KR" sz="1200" b="0" i="0" kern="1200" dirty="0">
+              <a:solidFill>
+                <a:schemeClr val="tx1"/>
+              </a:solidFill>
+              <a:effectLst/>
+              <a:latin typeface="+mn-lt"/>
+              <a:ea typeface="+mn-ea"/>
+              <a:cs typeface="+mn-cs"/>
+            </a:endParaRPr>
           </a:p>
           <a:p>
             <a:r>
@@ -4604,6 +4820,15 @@
               </a:rPr>
               <a:t>?</a:t>
             </a:r>
+            <a:endParaRPr lang="ko-KR" altLang="ko-KR" sz="1200" b="0" i="0" kern="1200" dirty="0">
+              <a:solidFill>
+                <a:schemeClr val="tx1"/>
+              </a:solidFill>
+              <a:effectLst/>
+              <a:latin typeface="+mn-lt"/>
+              <a:ea typeface="+mn-ea"/>
+              <a:cs typeface="+mn-cs"/>
+            </a:endParaRPr>
           </a:p>
           <a:p>
             <a:r>
@@ -5326,6 +5551,15 @@
               </a:rPr>
               <a:t>.</a:t>
             </a:r>
+            <a:endParaRPr lang="ko-KR" altLang="ko-KR" sz="1200" b="0" i="0" kern="1200" dirty="0">
+              <a:solidFill>
+                <a:schemeClr val="tx1"/>
+              </a:solidFill>
+              <a:effectLst/>
+              <a:latin typeface="+mn-lt"/>
+              <a:ea typeface="+mn-ea"/>
+              <a:cs typeface="+mn-cs"/>
+            </a:endParaRPr>
           </a:p>
           <a:p>
             <a:r>
@@ -5892,6 +6126,15 @@
               </a:rPr>
               <a:t> 0.1%.</a:t>
             </a:r>
+            <a:endParaRPr lang="ko-KR" altLang="ko-KR" sz="1200" b="0" i="0" kern="1200" dirty="0">
+              <a:solidFill>
+                <a:schemeClr val="tx1"/>
+              </a:solidFill>
+              <a:effectLst/>
+              <a:latin typeface="+mn-lt"/>
+              <a:ea typeface="+mn-ea"/>
+              <a:cs typeface="+mn-cs"/>
+            </a:endParaRPr>
           </a:p>
           <a:p>
             <a:br>
@@ -7146,212 +7389,6 @@
               </a:rPr>
               <a:t>.</a:t>
             </a:r>
-          </a:p>
-          <a:p>
-            <a:r>
-              <a:rPr lang="ko-KR" altLang="ko-KR" sz="1200" b="0" i="1" kern="1200" dirty="0">
-                <a:solidFill>
-                  <a:schemeClr val="tx1"/>
-                </a:solidFill>
-                <a:effectLst/>
-                <a:latin typeface="+mn-lt"/>
-                <a:ea typeface="+mn-ea"/>
-                <a:cs typeface="+mn-cs"/>
-              </a:rPr>
-              <a:t>"</a:t>
-            </a:r>
-            <a:r>
-              <a:rPr lang="ko-KR" altLang="ko-KR" sz="1200" b="0" i="1" kern="1200" dirty="0" err="1">
-                <a:solidFill>
-                  <a:schemeClr val="tx1"/>
-                </a:solidFill>
-                <a:effectLst/>
-                <a:latin typeface="+mn-lt"/>
-                <a:ea typeface="+mn-ea"/>
-                <a:cs typeface="+mn-cs"/>
-              </a:rPr>
-              <a:t>You</a:t>
-            </a:r>
-            <a:r>
-              <a:rPr lang="ko-KR" altLang="ko-KR" sz="1200" b="0" i="1" kern="1200" dirty="0">
-                <a:solidFill>
-                  <a:schemeClr val="tx1"/>
-                </a:solidFill>
-                <a:effectLst/>
-                <a:latin typeface="+mn-lt"/>
-                <a:ea typeface="+mn-ea"/>
-                <a:cs typeface="+mn-cs"/>
-              </a:rPr>
-              <a:t> </a:t>
-            </a:r>
-            <a:r>
-              <a:rPr lang="ko-KR" altLang="ko-KR" sz="1200" b="0" i="1" kern="1200" dirty="0" err="1">
-                <a:solidFill>
-                  <a:schemeClr val="tx1"/>
-                </a:solidFill>
-                <a:effectLst/>
-                <a:latin typeface="+mn-lt"/>
-                <a:ea typeface="+mn-ea"/>
-                <a:cs typeface="+mn-cs"/>
-              </a:rPr>
-              <a:t>only</a:t>
-            </a:r>
-            <a:r>
-              <a:rPr lang="ko-KR" altLang="ko-KR" sz="1200" b="0" i="1" kern="1200" dirty="0">
-                <a:solidFill>
-                  <a:schemeClr val="tx1"/>
-                </a:solidFill>
-                <a:effectLst/>
-                <a:latin typeface="+mn-lt"/>
-                <a:ea typeface="+mn-ea"/>
-                <a:cs typeface="+mn-cs"/>
-              </a:rPr>
-              <a:t> </a:t>
-            </a:r>
-            <a:r>
-              <a:rPr lang="ko-KR" altLang="ko-KR" sz="1200" b="0" i="1" kern="1200" dirty="0" err="1">
-                <a:solidFill>
-                  <a:schemeClr val="tx1"/>
-                </a:solidFill>
-                <a:effectLst/>
-                <a:latin typeface="+mn-lt"/>
-                <a:ea typeface="+mn-ea"/>
-                <a:cs typeface="+mn-cs"/>
-              </a:rPr>
-              <a:t>have</a:t>
-            </a:r>
-            <a:r>
-              <a:rPr lang="ko-KR" altLang="ko-KR" sz="1200" b="0" i="1" kern="1200" dirty="0">
-                <a:solidFill>
-                  <a:schemeClr val="tx1"/>
-                </a:solidFill>
-                <a:effectLst/>
-                <a:latin typeface="+mn-lt"/>
-                <a:ea typeface="+mn-ea"/>
-                <a:cs typeface="+mn-cs"/>
-              </a:rPr>
-              <a:t> 3 </a:t>
-            </a:r>
-            <a:r>
-              <a:rPr lang="ko-KR" altLang="ko-KR" sz="1200" b="0" i="1" kern="1200" dirty="0" err="1">
-                <a:solidFill>
-                  <a:schemeClr val="tx1"/>
-                </a:solidFill>
-                <a:effectLst/>
-                <a:latin typeface="+mn-lt"/>
-                <a:ea typeface="+mn-ea"/>
-                <a:cs typeface="+mn-cs"/>
-              </a:rPr>
-              <a:t>events</a:t>
-            </a:r>
-            <a:r>
-              <a:rPr lang="ko-KR" altLang="ko-KR" sz="1200" b="0" i="1" kern="1200" dirty="0">
-                <a:solidFill>
-                  <a:schemeClr val="tx1"/>
-                </a:solidFill>
-                <a:effectLst/>
-                <a:latin typeface="+mn-lt"/>
-                <a:ea typeface="+mn-ea"/>
-                <a:cs typeface="+mn-cs"/>
-              </a:rPr>
-              <a:t> — </a:t>
-            </a:r>
-            <a:r>
-              <a:rPr lang="ko-KR" altLang="ko-KR" sz="1200" b="0" i="1" kern="1200" dirty="0" err="1">
-                <a:solidFill>
-                  <a:schemeClr val="tx1"/>
-                </a:solidFill>
-                <a:effectLst/>
-                <a:latin typeface="+mn-lt"/>
-                <a:ea typeface="+mn-ea"/>
-                <a:cs typeface="+mn-cs"/>
-              </a:rPr>
-              <a:t>is</a:t>
-            </a:r>
-            <a:r>
-              <a:rPr lang="ko-KR" altLang="ko-KR" sz="1200" b="0" i="1" kern="1200" dirty="0">
-                <a:solidFill>
-                  <a:schemeClr val="tx1"/>
-                </a:solidFill>
-                <a:effectLst/>
-                <a:latin typeface="+mn-lt"/>
-                <a:ea typeface="+mn-ea"/>
-                <a:cs typeface="+mn-cs"/>
-              </a:rPr>
-              <a:t> </a:t>
-            </a:r>
-            <a:r>
-              <a:rPr lang="ko-KR" altLang="ko-KR" sz="1200" b="0" i="1" kern="1200" dirty="0" err="1">
-                <a:solidFill>
-                  <a:schemeClr val="tx1"/>
-                </a:solidFill>
-                <a:effectLst/>
-                <a:latin typeface="+mn-lt"/>
-                <a:ea typeface="+mn-ea"/>
-                <a:cs typeface="+mn-cs"/>
-              </a:rPr>
-              <a:t>this</a:t>
-            </a:r>
-            <a:r>
-              <a:rPr lang="ko-KR" altLang="ko-KR" sz="1200" b="0" i="1" kern="1200" dirty="0">
-                <a:solidFill>
-                  <a:schemeClr val="tx1"/>
-                </a:solidFill>
-                <a:effectLst/>
-                <a:latin typeface="+mn-lt"/>
-                <a:ea typeface="+mn-ea"/>
-                <a:cs typeface="+mn-cs"/>
-              </a:rPr>
-              <a:t> </a:t>
-            </a:r>
-            <a:r>
-              <a:rPr lang="ko-KR" altLang="ko-KR" sz="1200" b="0" i="1" kern="1200" dirty="0" err="1">
-                <a:solidFill>
-                  <a:schemeClr val="tx1"/>
-                </a:solidFill>
-                <a:effectLst/>
-                <a:latin typeface="+mn-lt"/>
-                <a:ea typeface="+mn-ea"/>
-                <a:cs typeface="+mn-cs"/>
-              </a:rPr>
-              <a:t>test</a:t>
-            </a:r>
-            <a:r>
-              <a:rPr lang="ko-KR" altLang="ko-KR" sz="1200" b="0" i="1" kern="1200" dirty="0">
-                <a:solidFill>
-                  <a:schemeClr val="tx1"/>
-                </a:solidFill>
-                <a:effectLst/>
-                <a:latin typeface="+mn-lt"/>
-                <a:ea typeface="+mn-ea"/>
-                <a:cs typeface="+mn-cs"/>
-              </a:rPr>
-              <a:t> </a:t>
-            </a:r>
-            <a:r>
-              <a:rPr lang="ko-KR" altLang="ko-KR" sz="1200" b="0" i="1" kern="1200" dirty="0" err="1">
-                <a:solidFill>
-                  <a:schemeClr val="tx1"/>
-                </a:solidFill>
-                <a:effectLst/>
-                <a:latin typeface="+mn-lt"/>
-                <a:ea typeface="+mn-ea"/>
-                <a:cs typeface="+mn-cs"/>
-              </a:rPr>
-              <a:t>meaningful</a:t>
-            </a:r>
-            <a:r>
-              <a:rPr lang="ko-KR" altLang="ko-KR" sz="1200" b="0" i="1" kern="1200" dirty="0">
-                <a:solidFill>
-                  <a:schemeClr val="tx1"/>
-                </a:solidFill>
-                <a:effectLst/>
-                <a:latin typeface="+mn-lt"/>
-                <a:ea typeface="+mn-ea"/>
-                <a:cs typeface="+mn-cs"/>
-              </a:rPr>
-              <a:t>?"</a:t>
-            </a:r>
             <a:endParaRPr lang="ko-KR" altLang="ko-KR" sz="1200" b="0" i="0" kern="1200" dirty="0">
               <a:solidFill>
                 <a:schemeClr val="tx1"/>
@@ -7364,6 +7401,221 @@
           </a:p>
           <a:p>
             <a:r>
+              <a:rPr lang="ko-KR" altLang="ko-KR" sz="1200" b="0" i="1" kern="1200" dirty="0">
+                <a:solidFill>
+                  <a:schemeClr val="tx1"/>
+                </a:solidFill>
+                <a:effectLst/>
+                <a:latin typeface="+mn-lt"/>
+                <a:ea typeface="+mn-ea"/>
+                <a:cs typeface="+mn-cs"/>
+              </a:rPr>
+              <a:t>"</a:t>
+            </a:r>
+            <a:r>
+              <a:rPr lang="ko-KR" altLang="ko-KR" sz="1200" b="0" i="1" kern="1200" dirty="0" err="1">
+                <a:solidFill>
+                  <a:schemeClr val="tx1"/>
+                </a:solidFill>
+                <a:effectLst/>
+                <a:latin typeface="+mn-lt"/>
+                <a:ea typeface="+mn-ea"/>
+                <a:cs typeface="+mn-cs"/>
+              </a:rPr>
+              <a:t>You</a:t>
+            </a:r>
+            <a:r>
+              <a:rPr lang="ko-KR" altLang="ko-KR" sz="1200" b="0" i="1" kern="1200" dirty="0">
+                <a:solidFill>
+                  <a:schemeClr val="tx1"/>
+                </a:solidFill>
+                <a:effectLst/>
+                <a:latin typeface="+mn-lt"/>
+                <a:ea typeface="+mn-ea"/>
+                <a:cs typeface="+mn-cs"/>
+              </a:rPr>
+              <a:t> </a:t>
+            </a:r>
+            <a:r>
+              <a:rPr lang="ko-KR" altLang="ko-KR" sz="1200" b="0" i="1" kern="1200" dirty="0" err="1">
+                <a:solidFill>
+                  <a:schemeClr val="tx1"/>
+                </a:solidFill>
+                <a:effectLst/>
+                <a:latin typeface="+mn-lt"/>
+                <a:ea typeface="+mn-ea"/>
+                <a:cs typeface="+mn-cs"/>
+              </a:rPr>
+              <a:t>only</a:t>
+            </a:r>
+            <a:r>
+              <a:rPr lang="ko-KR" altLang="ko-KR" sz="1200" b="0" i="1" kern="1200" dirty="0">
+                <a:solidFill>
+                  <a:schemeClr val="tx1"/>
+                </a:solidFill>
+                <a:effectLst/>
+                <a:latin typeface="+mn-lt"/>
+                <a:ea typeface="+mn-ea"/>
+                <a:cs typeface="+mn-cs"/>
+              </a:rPr>
+              <a:t> </a:t>
+            </a:r>
+            <a:r>
+              <a:rPr lang="ko-KR" altLang="ko-KR" sz="1200" b="0" i="1" kern="1200" dirty="0" err="1">
+                <a:solidFill>
+                  <a:schemeClr val="tx1"/>
+                </a:solidFill>
+                <a:effectLst/>
+                <a:latin typeface="+mn-lt"/>
+                <a:ea typeface="+mn-ea"/>
+                <a:cs typeface="+mn-cs"/>
+              </a:rPr>
+              <a:t>have</a:t>
+            </a:r>
+            <a:r>
+              <a:rPr lang="ko-KR" altLang="ko-KR" sz="1200" b="0" i="1" kern="1200" dirty="0">
+                <a:solidFill>
+                  <a:schemeClr val="tx1"/>
+                </a:solidFill>
+                <a:effectLst/>
+                <a:latin typeface="+mn-lt"/>
+                <a:ea typeface="+mn-ea"/>
+                <a:cs typeface="+mn-cs"/>
+              </a:rPr>
+              <a:t> 3 </a:t>
+            </a:r>
+            <a:r>
+              <a:rPr lang="ko-KR" altLang="ko-KR" sz="1200" b="0" i="1" kern="1200" dirty="0" err="1">
+                <a:solidFill>
+                  <a:schemeClr val="tx1"/>
+                </a:solidFill>
+                <a:effectLst/>
+                <a:latin typeface="+mn-lt"/>
+                <a:ea typeface="+mn-ea"/>
+                <a:cs typeface="+mn-cs"/>
+              </a:rPr>
+              <a:t>events</a:t>
+            </a:r>
+            <a:r>
+              <a:rPr lang="ko-KR" altLang="ko-KR" sz="1200" b="0" i="1" kern="1200" dirty="0">
+                <a:solidFill>
+                  <a:schemeClr val="tx1"/>
+                </a:solidFill>
+                <a:effectLst/>
+                <a:latin typeface="+mn-lt"/>
+                <a:ea typeface="+mn-ea"/>
+                <a:cs typeface="+mn-cs"/>
+              </a:rPr>
+              <a:t> — </a:t>
+            </a:r>
+            <a:r>
+              <a:rPr lang="ko-KR" altLang="ko-KR" sz="1200" b="0" i="1" kern="1200" dirty="0" err="1">
+                <a:solidFill>
+                  <a:schemeClr val="tx1"/>
+                </a:solidFill>
+                <a:effectLst/>
+                <a:latin typeface="+mn-lt"/>
+                <a:ea typeface="+mn-ea"/>
+                <a:cs typeface="+mn-cs"/>
+              </a:rPr>
+              <a:t>is</a:t>
+            </a:r>
+            <a:r>
+              <a:rPr lang="ko-KR" altLang="ko-KR" sz="1200" b="0" i="1" kern="1200" dirty="0">
+                <a:solidFill>
+                  <a:schemeClr val="tx1"/>
+                </a:solidFill>
+                <a:effectLst/>
+                <a:latin typeface="+mn-lt"/>
+                <a:ea typeface="+mn-ea"/>
+                <a:cs typeface="+mn-cs"/>
+              </a:rPr>
+              <a:t> </a:t>
+            </a:r>
+            <a:r>
+              <a:rPr lang="ko-KR" altLang="ko-KR" sz="1200" b="0" i="1" kern="1200" dirty="0" err="1">
+                <a:solidFill>
+                  <a:schemeClr val="tx1"/>
+                </a:solidFill>
+                <a:effectLst/>
+                <a:latin typeface="+mn-lt"/>
+                <a:ea typeface="+mn-ea"/>
+                <a:cs typeface="+mn-cs"/>
+              </a:rPr>
+              <a:t>this</a:t>
+            </a:r>
+            <a:r>
+              <a:rPr lang="ko-KR" altLang="ko-KR" sz="1200" b="0" i="1" kern="1200" dirty="0">
+                <a:solidFill>
+                  <a:schemeClr val="tx1"/>
+                </a:solidFill>
+                <a:effectLst/>
+                <a:latin typeface="+mn-lt"/>
+                <a:ea typeface="+mn-ea"/>
+                <a:cs typeface="+mn-cs"/>
+              </a:rPr>
+              <a:t> </a:t>
+            </a:r>
+            <a:r>
+              <a:rPr lang="ko-KR" altLang="ko-KR" sz="1200" b="0" i="1" kern="1200" dirty="0" err="1">
+                <a:solidFill>
+                  <a:schemeClr val="tx1"/>
+                </a:solidFill>
+                <a:effectLst/>
+                <a:latin typeface="+mn-lt"/>
+                <a:ea typeface="+mn-ea"/>
+                <a:cs typeface="+mn-cs"/>
+              </a:rPr>
+              <a:t>test</a:t>
+            </a:r>
+            <a:r>
+              <a:rPr lang="ko-KR" altLang="ko-KR" sz="1200" b="0" i="1" kern="1200" dirty="0">
+                <a:solidFill>
+                  <a:schemeClr val="tx1"/>
+                </a:solidFill>
+                <a:effectLst/>
+                <a:latin typeface="+mn-lt"/>
+                <a:ea typeface="+mn-ea"/>
+                <a:cs typeface="+mn-cs"/>
+              </a:rPr>
+              <a:t> </a:t>
+            </a:r>
+            <a:r>
+              <a:rPr lang="ko-KR" altLang="ko-KR" sz="1200" b="0" i="1" kern="1200" dirty="0" err="1">
+                <a:solidFill>
+                  <a:schemeClr val="tx1"/>
+                </a:solidFill>
+                <a:effectLst/>
+                <a:latin typeface="+mn-lt"/>
+                <a:ea typeface="+mn-ea"/>
+                <a:cs typeface="+mn-cs"/>
+              </a:rPr>
+              <a:t>meaningful</a:t>
+            </a:r>
+            <a:r>
+              <a:rPr lang="ko-KR" altLang="ko-KR" sz="1200" b="0" i="1" kern="1200" dirty="0">
+                <a:solidFill>
+                  <a:schemeClr val="tx1"/>
+                </a:solidFill>
+                <a:effectLst/>
+                <a:latin typeface="+mn-lt"/>
+                <a:ea typeface="+mn-ea"/>
+                <a:cs typeface="+mn-cs"/>
+              </a:rPr>
+              <a:t>?"</a:t>
+            </a:r>
+            <a:endParaRPr lang="ko-KR" altLang="ko-KR" sz="1200" b="0" i="0" kern="1200" dirty="0">
+              <a:solidFill>
+                <a:schemeClr val="tx1"/>
+              </a:solidFill>
+              <a:effectLst/>
+              <a:latin typeface="+mn-lt"/>
+              <a:ea typeface="+mn-ea"/>
+              <a:cs typeface="+mn-cs"/>
+            </a:endParaRPr>
+          </a:p>
+          <a:p>
+            <a:r>
               <a:rPr lang="ko-KR" altLang="ko-KR" sz="1200" b="0" i="0" kern="1200" dirty="0">
                 <a:solidFill>
                   <a:schemeClr val="tx1"/>
@@ -8215,6 +8467,15 @@
               </a:rPr>
               <a:t>.</a:t>
             </a:r>
+            <a:endParaRPr lang="ko-KR" altLang="ko-KR" sz="1200" b="0" i="0" kern="1200" dirty="0">
+              <a:solidFill>
+                <a:schemeClr val="tx1"/>
+              </a:solidFill>
+              <a:effectLst/>
+              <a:latin typeface="+mn-lt"/>
+              <a:ea typeface="+mn-ea"/>
+              <a:cs typeface="+mn-cs"/>
+            </a:endParaRPr>
           </a:p>
           <a:p>
             <a:endParaRPr dirty="0"/>
@@ -8299,6 +8560,7 @@
               <a:rPr lang="en-US" dirty="0"/>
               <a:t>Asides from this, for the remaining days, we plan to go through our data and methodology once again. This time in the eyes of the critiques and what are some other flags that may be raised during a review. After that, we plan to finish up our paper for this semester.  </a:t>
             </a:r>
+            <a:endParaRPr lang="en-US" dirty="0"/>
           </a:p>
           <a:p>
             <a:endParaRPr lang="en-US" dirty="0"/>
@@ -8308,6 +8570,7 @@
               <a:rPr lang="en-US" dirty="0"/>
               <a:t>Thank you, that’s all that we prepared for this week’s presentation. </a:t>
             </a:r>
+            <a:endParaRPr lang="en-US" dirty="0"/>
           </a:p>
           <a:p>
             <a:endParaRPr lang="en-US" dirty="0"/>
@@ -8448,6 +8711,7 @@
               <a:rPr lang="en-US"/>
               <a:t>Click to edit Master title style</a:t>
             </a:r>
+            <a:endParaRPr lang="en-US"/>
           </a:p>
         </p:txBody>
       </p:sp>
@@ -8566,6 +8830,7 @@
               <a:rPr lang="en-US"/>
               <a:t>Click to edit Master subtitle style</a:t>
             </a:r>
+            <a:endParaRPr lang="en-US"/>
           </a:p>
         </p:txBody>
       </p:sp>
@@ -8586,7 +8851,6 @@
           <a:p>
             <a:fld id="{5BCAD085-E8A6-8845-BD4E-CB4CCA059FC4}" type="datetimeFigureOut">
               <a:rPr lang="en-US" smtClean="0"/>
-              <a:t>5/26/26</a:t>
             </a:fld>
             <a:endParaRPr lang="en-US"/>
           </a:p>
@@ -8628,7 +8892,6 @@
           <a:p>
             <a:fld id="{C1FF6DA9-008F-8B48-92A6-B652298478BF}" type="slidenum">
               <a:rPr lang="en-US" smtClean="0"/>
-              <a:t>‹#›</a:t>
             </a:fld>
             <a:endParaRPr lang="en-US"/>
           </a:p>
@@ -8678,6 +8941,7 @@
               <a:rPr lang="en-US"/>
               <a:t>Click to edit Master title style</a:t>
             </a:r>
+            <a:endParaRPr lang="en-US"/>
           </a:p>
         </p:txBody>
       </p:sp>
@@ -8701,6 +8965,7 @@
               <a:rPr lang="en-US"/>
               <a:t>Click to edit Master text styles</a:t>
             </a:r>
+            <a:endParaRPr lang="en-US"/>
           </a:p>
           <a:p>
             <a:pPr lvl="1"/>
@@ -8708,6 +8973,7 @@
               <a:rPr lang="en-US"/>
               <a:t>Second level</a:t>
             </a:r>
+            <a:endParaRPr lang="en-US"/>
           </a:p>
           <a:p>
             <a:pPr lvl="2"/>
@@ -8715,6 +8981,7 @@
               <a:rPr lang="en-US"/>
               <a:t>Third level</a:t>
             </a:r>
+            <a:endParaRPr lang="en-US"/>
           </a:p>
           <a:p>
             <a:pPr lvl="3"/>
@@ -8722,6 +8989,7 @@
               <a:rPr lang="en-US"/>
               <a:t>Fourth level</a:t>
             </a:r>
+            <a:endParaRPr lang="en-US"/>
           </a:p>
           <a:p>
             <a:pPr lvl="4"/>
@@ -8729,6 +8997,7 @@
               <a:rPr lang="en-US"/>
               <a:t>Fifth level</a:t>
             </a:r>
+            <a:endParaRPr lang="en-US"/>
           </a:p>
         </p:txBody>
       </p:sp>
@@ -8749,7 +9018,6 @@
           <a:p>
             <a:fld id="{5BCAD085-E8A6-8845-BD4E-CB4CCA059FC4}" type="datetimeFigureOut">
               <a:rPr lang="en-US" smtClean="0"/>
-              <a:t>5/26/26</a:t>
             </a:fld>
             <a:endParaRPr lang="en-US"/>
           </a:p>
@@ -8791,7 +9059,6 @@
           <a:p>
             <a:fld id="{C1FF6DA9-008F-8B48-92A6-B652298478BF}" type="slidenum">
               <a:rPr lang="en-US" smtClean="0"/>
-              <a:t>‹#›</a:t>
             </a:fld>
             <a:endParaRPr lang="en-US"/>
           </a:p>
@@ -8846,6 +9113,7 @@
               <a:rPr lang="en-US"/>
               <a:t>Click to edit Master title style</a:t>
             </a:r>
+            <a:endParaRPr lang="en-US"/>
           </a:p>
         </p:txBody>
       </p:sp>
@@ -8874,6 +9142,7 @@
               <a:rPr lang="en-US"/>
               <a:t>Click to edit Master text styles</a:t>
             </a:r>
+            <a:endParaRPr lang="en-US"/>
           </a:p>
           <a:p>
             <a:pPr lvl="1"/>
@@ -8881,6 +9150,7 @@
               <a:rPr lang="en-US"/>
               <a:t>Second level</a:t>
             </a:r>
+            <a:endParaRPr lang="en-US"/>
           </a:p>
           <a:p>
             <a:pPr lvl="2"/>
@@ -8888,6 +9158,7 @@
               <a:rPr lang="en-US"/>
               <a:t>Third level</a:t>
             </a:r>
+            <a:endParaRPr lang="en-US"/>
           </a:p>
           <a:p>
             <a:pPr lvl="3"/>
@@ -8895,6 +9166,7 @@
               <a:rPr lang="en-US"/>
               <a:t>Fourth level</a:t>
             </a:r>
+            <a:endParaRPr lang="en-US"/>
           </a:p>
           <a:p>
             <a:pPr lvl="4"/>
@@ -8902,6 +9174,7 @@
               <a:rPr lang="en-US"/>
               <a:t>Fifth level</a:t>
             </a:r>
+            <a:endParaRPr lang="en-US"/>
           </a:p>
         </p:txBody>
       </p:sp>
@@ -8922,7 +9195,6 @@
           <a:p>
             <a:fld id="{5BCAD085-E8A6-8845-BD4E-CB4CCA059FC4}" type="datetimeFigureOut">
               <a:rPr lang="en-US" smtClean="0"/>
-              <a:t>5/26/26</a:t>
             </a:fld>
             <a:endParaRPr lang="en-US"/>
           </a:p>
@@ -8964,7 +9236,6 @@
           <a:p>
             <a:fld id="{C1FF6DA9-008F-8B48-92A6-B652298478BF}" type="slidenum">
               <a:rPr lang="en-US" smtClean="0"/>
-              <a:t>‹#›</a:t>
             </a:fld>
             <a:endParaRPr lang="en-US"/>
           </a:p>
@@ -9014,6 +9285,7 @@
               <a:rPr lang="en-US"/>
               <a:t>Click to edit Master title style</a:t>
             </a:r>
+            <a:endParaRPr lang="en-US"/>
           </a:p>
         </p:txBody>
       </p:sp>
@@ -9037,6 +9309,7 @@
               <a:rPr lang="en-US"/>
               <a:t>Click to edit Master text styles</a:t>
             </a:r>
+            <a:endParaRPr lang="en-US"/>
           </a:p>
           <a:p>
             <a:pPr lvl="1"/>
@@ -9044,6 +9317,7 @@
               <a:rPr lang="en-US"/>
               <a:t>Second level</a:t>
             </a:r>
+            <a:endParaRPr lang="en-US"/>
           </a:p>
           <a:p>
             <a:pPr lvl="2"/>
@@ -9051,6 +9325,7 @@
               <a:rPr lang="en-US"/>
               <a:t>Third level</a:t>
             </a:r>
+            <a:endParaRPr lang="en-US"/>
           </a:p>
           <a:p>
             <a:pPr lvl="3"/>
@@ -9058,6 +9333,7 @@
               <a:rPr lang="en-US"/>
               <a:t>Fourth level</a:t>
             </a:r>
+            <a:endParaRPr lang="en-US"/>
           </a:p>
           <a:p>
             <a:pPr lvl="4"/>
@@ -9065,6 +9341,7 @@
               <a:rPr lang="en-US"/>
               <a:t>Fifth level</a:t>
             </a:r>
+            <a:endParaRPr lang="en-US"/>
           </a:p>
         </p:txBody>
       </p:sp>
@@ -9085,7 +9362,6 @@
           <a:p>
             <a:fld id="{5BCAD085-E8A6-8845-BD4E-CB4CCA059FC4}" type="datetimeFigureOut">
               <a:rPr lang="en-US" smtClean="0"/>
-              <a:t>5/26/26</a:t>
             </a:fld>
             <a:endParaRPr lang="en-US"/>
           </a:p>
@@ -9127,7 +9403,6 @@
           <a:p>
             <a:fld id="{C1FF6DA9-008F-8B48-92A6-B652298478BF}" type="slidenum">
               <a:rPr lang="en-US" smtClean="0"/>
-              <a:t>‹#›</a:t>
             </a:fld>
             <a:endParaRPr lang="en-US"/>
           </a:p>
@@ -9186,6 +9461,7 @@
               <a:rPr lang="en-US"/>
               <a:t>Click to edit Master title style</a:t>
             </a:r>
+            <a:endParaRPr lang="en-US"/>
           </a:p>
         </p:txBody>
       </p:sp>
@@ -9305,6 +9581,7 @@
               <a:rPr lang="en-US"/>
               <a:t>Click to edit Master text styles</a:t>
             </a:r>
+            <a:endParaRPr lang="en-US"/>
           </a:p>
         </p:txBody>
       </p:sp>
@@ -9325,7 +9602,6 @@
           <a:p>
             <a:fld id="{5BCAD085-E8A6-8845-BD4E-CB4CCA059FC4}" type="datetimeFigureOut">
               <a:rPr lang="en-US" smtClean="0"/>
-              <a:t>5/26/26</a:t>
             </a:fld>
             <a:endParaRPr lang="en-US"/>
           </a:p>
@@ -9367,7 +9643,6 @@
           <a:p>
             <a:fld id="{C1FF6DA9-008F-8B48-92A6-B652298478BF}" type="slidenum">
               <a:rPr lang="en-US" smtClean="0"/>
-              <a:t>‹#›</a:t>
             </a:fld>
             <a:endParaRPr lang="en-US"/>
           </a:p>
@@ -9417,6 +9692,7 @@
               <a:rPr lang="en-US"/>
               <a:t>Click to edit Master title style</a:t>
             </a:r>
+            <a:endParaRPr lang="en-US"/>
           </a:p>
         </p:txBody>
       </p:sp>
@@ -9473,6 +9749,7 @@
               <a:rPr lang="en-US"/>
               <a:t>Click to edit Master text styles</a:t>
             </a:r>
+            <a:endParaRPr lang="en-US"/>
           </a:p>
           <a:p>
             <a:pPr lvl="1"/>
@@ -9480,6 +9757,7 @@
               <a:rPr lang="en-US"/>
               <a:t>Second level</a:t>
             </a:r>
+            <a:endParaRPr lang="en-US"/>
           </a:p>
           <a:p>
             <a:pPr lvl="2"/>
@@ -9487,6 +9765,7 @@
               <a:rPr lang="en-US"/>
               <a:t>Third level</a:t>
             </a:r>
+            <a:endParaRPr lang="en-US"/>
           </a:p>
           <a:p>
             <a:pPr lvl="3"/>
@@ -9494,6 +9773,7 @@
               <a:rPr lang="en-US"/>
               <a:t>Fourth level</a:t>
             </a:r>
+            <a:endParaRPr lang="en-US"/>
           </a:p>
           <a:p>
             <a:pPr lvl="4"/>
@@ -9501,6 +9781,7 @@
               <a:rPr lang="en-US"/>
               <a:t>Fifth level</a:t>
             </a:r>
+            <a:endParaRPr lang="en-US"/>
           </a:p>
         </p:txBody>
       </p:sp>
@@ -9557,6 +9838,7 @@
               <a:rPr lang="en-US"/>
               <a:t>Click to edit Master text styles</a:t>
             </a:r>
+            <a:endParaRPr lang="en-US"/>
           </a:p>
           <a:p>
             <a:pPr lvl="1"/>
@@ -9564,6 +9846,7 @@
               <a:rPr lang="en-US"/>
               <a:t>Second level</a:t>
             </a:r>
+            <a:endParaRPr lang="en-US"/>
           </a:p>
           <a:p>
             <a:pPr lvl="2"/>
@@ -9571,6 +9854,7 @@
               <a:rPr lang="en-US"/>
               <a:t>Third level</a:t>
             </a:r>
+            <a:endParaRPr lang="en-US"/>
           </a:p>
           <a:p>
             <a:pPr lvl="3"/>
@@ -9578,6 +9862,7 @@
               <a:rPr lang="en-US"/>
               <a:t>Fourth level</a:t>
             </a:r>
+            <a:endParaRPr lang="en-US"/>
           </a:p>
           <a:p>
             <a:pPr lvl="4"/>
@@ -9585,6 +9870,7 @@
               <a:rPr lang="en-US"/>
               <a:t>Fifth level</a:t>
             </a:r>
+            <a:endParaRPr lang="en-US"/>
           </a:p>
         </p:txBody>
       </p:sp>
@@ -9605,7 +9891,6 @@
           <a:p>
             <a:fld id="{5BCAD085-E8A6-8845-BD4E-CB4CCA059FC4}" type="datetimeFigureOut">
               <a:rPr lang="en-US" smtClean="0"/>
-              <a:t>5/26/26</a:t>
             </a:fld>
             <a:endParaRPr lang="en-US"/>
           </a:p>
@@ -9647,7 +9932,6 @@
           <a:p>
             <a:fld id="{C1FF6DA9-008F-8B48-92A6-B652298478BF}" type="slidenum">
               <a:rPr lang="en-US" smtClean="0"/>
-              <a:t>‹#›</a:t>
             </a:fld>
             <a:endParaRPr lang="en-US"/>
           </a:p>
@@ -9701,6 +9985,7 @@
               <a:rPr lang="en-US"/>
               <a:t>Click to edit Master title style</a:t>
             </a:r>
+            <a:endParaRPr lang="en-US"/>
           </a:p>
         </p:txBody>
       </p:sp>
@@ -9766,6 +10051,7 @@
               <a:rPr lang="en-US"/>
               <a:t>Click to edit Master text styles</a:t>
             </a:r>
+            <a:endParaRPr lang="en-US"/>
           </a:p>
         </p:txBody>
       </p:sp>
@@ -9822,6 +10108,7 @@
               <a:rPr lang="en-US"/>
               <a:t>Click to edit Master text styles</a:t>
             </a:r>
+            <a:endParaRPr lang="en-US"/>
           </a:p>
           <a:p>
             <a:pPr lvl="1"/>
@@ -9829,6 +10116,7 @@
               <a:rPr lang="en-US"/>
               <a:t>Second level</a:t>
             </a:r>
+            <a:endParaRPr lang="en-US"/>
           </a:p>
           <a:p>
             <a:pPr lvl="2"/>
@@ -9836,6 +10124,7 @@
               <a:rPr lang="en-US"/>
               <a:t>Third level</a:t>
             </a:r>
+            <a:endParaRPr lang="en-US"/>
           </a:p>
           <a:p>
             <a:pPr lvl="3"/>
@@ -9843,6 +10132,7 @@
               <a:rPr lang="en-US"/>
               <a:t>Fourth level</a:t>
             </a:r>
+            <a:endParaRPr lang="en-US"/>
           </a:p>
           <a:p>
             <a:pPr lvl="4"/>
@@ -9850,6 +10140,7 @@
               <a:rPr lang="en-US"/>
               <a:t>Fifth level</a:t>
             </a:r>
+            <a:endParaRPr lang="en-US"/>
           </a:p>
         </p:txBody>
       </p:sp>
@@ -9915,6 +10206,7 @@
               <a:rPr lang="en-US"/>
               <a:t>Click to edit Master text styles</a:t>
             </a:r>
+            <a:endParaRPr lang="en-US"/>
           </a:p>
         </p:txBody>
       </p:sp>
@@ -9971,6 +10263,7 @@
               <a:rPr lang="en-US"/>
               <a:t>Click to edit Master text styles</a:t>
             </a:r>
+            <a:endParaRPr lang="en-US"/>
           </a:p>
           <a:p>
             <a:pPr lvl="1"/>
@@ -9978,6 +10271,7 @@
               <a:rPr lang="en-US"/>
               <a:t>Second level</a:t>
             </a:r>
+            <a:endParaRPr lang="en-US"/>
           </a:p>
           <a:p>
             <a:pPr lvl="2"/>
@@ -9985,6 +10279,7 @@
               <a:rPr lang="en-US"/>
               <a:t>Third level</a:t>
             </a:r>
+            <a:endParaRPr lang="en-US"/>
           </a:p>
           <a:p>
             <a:pPr lvl="3"/>
@@ -9992,6 +10287,7 @@
               <a:rPr lang="en-US"/>
               <a:t>Fourth level</a:t>
             </a:r>
+            <a:endParaRPr lang="en-US"/>
           </a:p>
           <a:p>
             <a:pPr lvl="4"/>
@@ -9999,6 +10295,7 @@
               <a:rPr lang="en-US"/>
               <a:t>Fifth level</a:t>
             </a:r>
+            <a:endParaRPr lang="en-US"/>
           </a:p>
         </p:txBody>
       </p:sp>
@@ -10019,7 +10316,6 @@
           <a:p>
             <a:fld id="{5BCAD085-E8A6-8845-BD4E-CB4CCA059FC4}" type="datetimeFigureOut">
               <a:rPr lang="en-US" smtClean="0"/>
-              <a:t>5/26/26</a:t>
             </a:fld>
             <a:endParaRPr lang="en-US"/>
           </a:p>
@@ -10061,7 +10357,6 @@
           <a:p>
             <a:fld id="{C1FF6DA9-008F-8B48-92A6-B652298478BF}" type="slidenum">
               <a:rPr lang="en-US" smtClean="0"/>
-              <a:t>‹#›</a:t>
             </a:fld>
             <a:endParaRPr lang="en-US"/>
           </a:p>
@@ -10111,6 +10406,7 @@
               <a:rPr lang="en-US"/>
               <a:t>Click to edit Master title style</a:t>
             </a:r>
+            <a:endParaRPr lang="en-US"/>
           </a:p>
         </p:txBody>
       </p:sp>
@@ -10131,7 +10427,6 @@
           <a:p>
             <a:fld id="{5BCAD085-E8A6-8845-BD4E-CB4CCA059FC4}" type="datetimeFigureOut">
               <a:rPr lang="en-US" smtClean="0"/>
-              <a:t>5/26/26</a:t>
             </a:fld>
             <a:endParaRPr lang="en-US"/>
           </a:p>
@@ -10173,7 +10468,6 @@
           <a:p>
             <a:fld id="{C1FF6DA9-008F-8B48-92A6-B652298478BF}" type="slidenum">
               <a:rPr lang="en-US" smtClean="0"/>
-              <a:t>‹#›</a:t>
             </a:fld>
             <a:endParaRPr lang="en-US"/>
           </a:p>
@@ -10221,7 +10515,6 @@
           <a:p>
             <a:fld id="{5BCAD085-E8A6-8845-BD4E-CB4CCA059FC4}" type="datetimeFigureOut">
               <a:rPr lang="en-US" smtClean="0"/>
-              <a:t>5/26/26</a:t>
             </a:fld>
             <a:endParaRPr lang="en-US"/>
           </a:p>
@@ -10263,7 +10556,6 @@
           <a:p>
             <a:fld id="{C1FF6DA9-008F-8B48-92A6-B652298478BF}" type="slidenum">
               <a:rPr lang="en-US" smtClean="0"/>
-              <a:t>‹#›</a:t>
             </a:fld>
             <a:endParaRPr lang="en-US"/>
           </a:p>
@@ -10322,6 +10614,7 @@
               <a:rPr lang="en-US"/>
               <a:t>Click to edit Master title style</a:t>
             </a:r>
+            <a:endParaRPr lang="en-US"/>
           </a:p>
         </p:txBody>
       </p:sp>
@@ -10378,6 +10671,7 @@
               <a:rPr lang="en-US"/>
               <a:t>Click to edit Master text styles</a:t>
             </a:r>
+            <a:endParaRPr lang="en-US"/>
           </a:p>
           <a:p>
             <a:pPr lvl="1"/>
@@ -10385,6 +10679,7 @@
               <a:rPr lang="en-US"/>
               <a:t>Second level</a:t>
             </a:r>
+            <a:endParaRPr lang="en-US"/>
           </a:p>
           <a:p>
             <a:pPr lvl="2"/>
@@ -10392,6 +10687,7 @@
               <a:rPr lang="en-US"/>
               <a:t>Third level</a:t>
             </a:r>
+            <a:endParaRPr lang="en-US"/>
           </a:p>
           <a:p>
             <a:pPr lvl="3"/>
@@ -10399,6 +10695,7 @@
               <a:rPr lang="en-US"/>
               <a:t>Fourth level</a:t>
             </a:r>
+            <a:endParaRPr lang="en-US"/>
           </a:p>
           <a:p>
             <a:pPr lvl="4"/>
@@ -10406,6 +10703,7 @@
               <a:rPr lang="en-US"/>
               <a:t>Fifth level</a:t>
             </a:r>
+            <a:endParaRPr lang="en-US"/>
           </a:p>
         </p:txBody>
       </p:sp>
@@ -10471,6 +10769,7 @@
               <a:rPr lang="en-US"/>
               <a:t>Click to edit Master text styles</a:t>
             </a:r>
+            <a:endParaRPr lang="en-US"/>
           </a:p>
         </p:txBody>
       </p:sp>
@@ -10491,7 +10790,6 @@
           <a:p>
             <a:fld id="{5BCAD085-E8A6-8845-BD4E-CB4CCA059FC4}" type="datetimeFigureOut">
               <a:rPr lang="en-US" smtClean="0"/>
-              <a:t>5/26/26</a:t>
             </a:fld>
             <a:endParaRPr lang="en-US"/>
           </a:p>
@@ -10533,7 +10831,6 @@
           <a:p>
             <a:fld id="{C1FF6DA9-008F-8B48-92A6-B652298478BF}" type="slidenum">
               <a:rPr lang="en-US" smtClean="0"/>
-              <a:t>‹#›</a:t>
             </a:fld>
             <a:endParaRPr lang="en-US"/>
           </a:p>
@@ -10592,6 +10889,7 @@
               <a:rPr lang="en-US"/>
               <a:t>Click to edit Master title style</a:t>
             </a:r>
+            <a:endParaRPr lang="en-US"/>
           </a:p>
         </p:txBody>
       </p:sp>
@@ -10718,6 +11016,7 @@
               <a:rPr lang="en-US"/>
               <a:t>Click to edit Master text styles</a:t>
             </a:r>
+            <a:endParaRPr lang="en-US"/>
           </a:p>
         </p:txBody>
       </p:sp>
@@ -10738,7 +11037,6 @@
           <a:p>
             <a:fld id="{5BCAD085-E8A6-8845-BD4E-CB4CCA059FC4}" type="datetimeFigureOut">
               <a:rPr lang="en-US" smtClean="0"/>
-              <a:t>5/26/26</a:t>
             </a:fld>
             <a:endParaRPr lang="en-US"/>
           </a:p>
@@ -10780,7 +11078,6 @@
           <a:p>
             <a:fld id="{C1FF6DA9-008F-8B48-92A6-B652298478BF}" type="slidenum">
               <a:rPr lang="en-US" smtClean="0"/>
-              <a:t>‹#›</a:t>
             </a:fld>
             <a:endParaRPr lang="en-US"/>
           </a:p>
@@ -10845,6 +11142,7 @@
               <a:rPr lang="en-US"/>
               <a:t>Click to edit Master title style</a:t>
             </a:r>
+            <a:endParaRPr lang="en-US"/>
           </a:p>
         </p:txBody>
       </p:sp>
@@ -10878,6 +11176,7 @@
               <a:rPr lang="en-US"/>
               <a:t>Click to edit Master text styles</a:t>
             </a:r>
+            <a:endParaRPr lang="en-US"/>
           </a:p>
           <a:p>
             <a:pPr lvl="1"/>
@@ -10885,6 +11184,7 @@
               <a:rPr lang="en-US"/>
               <a:t>Second level</a:t>
             </a:r>
+            <a:endParaRPr lang="en-US"/>
           </a:p>
           <a:p>
             <a:pPr lvl="2"/>
@@ -10892,6 +11192,7 @@
               <a:rPr lang="en-US"/>
               <a:t>Third level</a:t>
             </a:r>
+            <a:endParaRPr lang="en-US"/>
           </a:p>
           <a:p>
             <a:pPr lvl="3"/>
@@ -10899,6 +11200,7 @@
               <a:rPr lang="en-US"/>
               <a:t>Fourth level</a:t>
             </a:r>
+            <a:endParaRPr lang="en-US"/>
           </a:p>
           <a:p>
             <a:pPr lvl="4"/>
@@ -10906,6 +11208,7 @@
               <a:rPr lang="en-US"/>
               <a:t>Fifth level</a:t>
             </a:r>
+            <a:endParaRPr lang="en-US"/>
           </a:p>
         </p:txBody>
       </p:sp>
@@ -10944,7 +11247,6 @@
           <a:p>
             <a:fld id="{5BCAD085-E8A6-8845-BD4E-CB4CCA059FC4}" type="datetimeFigureOut">
               <a:rPr lang="en-US" smtClean="0"/>
-              <a:t>5/26/26</a:t>
             </a:fld>
             <a:endParaRPr lang="en-US"/>
           </a:p>
@@ -11022,7 +11324,6 @@
           <a:p>
             <a:fld id="{C1FF6DA9-008F-8B48-92A6-B652298478BF}" type="slidenum">
               <a:rPr lang="en-US" smtClean="0"/>
-              <a:t>‹#›</a:t>
             </a:fld>
             <a:endParaRPr lang="en-US"/>
           </a:p>
@@ -11331,14 +11632,14 @@
           <p:nvPr/>
         </p:nvPicPr>
         <p:blipFill>
-          <a:blip r:embed="rId3">
+          <a:blip r:embed="rId1">
             <a:lum bright="70000" contrast="-70000"/>
             <a:extLst>
               <a:ext uri="{BEBA8EAE-BF5A-486C-A8C5-ECC9F3942E4B}">
                 <a14:imgProps xmlns:a14="http://schemas.microsoft.com/office/drawing/2010/main">
-                  <a14:imgLayer r:embed="rId4">
+                  <a14:imgLayer r:embed="rId2">
                     <a14:imgEffect>
-                      <a14:artisticPhotocopy detail="2"/>
+                      <a14:artisticPhotocopy trans="30000" detail="2"/>
                     </a14:imgEffect>
                   </a14:imgLayer>
                 </a14:imgProps>
@@ -11418,6 +11719,13 @@
               </a:rPr>
               <a:t>STABLECOINS AND THE EXORBITANT PRIVILEGE</a:t>
             </a:r>
+            <a:endParaRPr lang="en-US" altLang="ko-KR" sz="2400" dirty="0">
+              <a:solidFill>
+                <a:prstClr val="white"/>
+              </a:solidFill>
+              <a:latin typeface="Hiragino Kaku Gothic Std W8" panose="020B0800000000000000" pitchFamily="34" charset="-128"/>
+              <a:ea typeface="Hiragino Kaku Gothic Std W8" panose="020B0800000000000000" pitchFamily="34" charset="-128"/>
+            </a:endParaRPr>
           </a:p>
           <a:p>
             <a:pPr algn="ctr" defTabSz="914400" latinLnBrk="1">
@@ -11463,6 +11771,11 @@
               </a:rPr>
               <a:t>Yonsei GSIS 2026-1 </a:t>
             </a:r>
+            <a:endParaRPr lang="en-US" altLang="ko-KR" sz="1800" b="1" dirty="0">
+              <a:solidFill>
+                <a:schemeClr val="bg1"/>
+              </a:solidFill>
+            </a:endParaRPr>
           </a:p>
           <a:p>
             <a:r>
@@ -11576,7 +11889,6 @@
           <a:lstStyle/>
           <a:p>
             <a:pPr algn="ctr"/>
-            <a:endParaRPr/>
           </a:p>
         </p:txBody>
       </p:sp>
@@ -11612,6 +11924,12 @@
               </a:rPr>
               <a:t>Roadmap</a:t>
             </a:r>
+            <a:endParaRPr sz="2600" b="0" i="0" dirty="0">
+              <a:solidFill>
+                <a:srgbClr val="FFFFFF"/>
+              </a:solidFill>
+              <a:latin typeface="Calibri"/>
+            </a:endParaRPr>
           </a:p>
         </p:txBody>
       </p:sp>
@@ -11655,7 +11973,6 @@
           <a:lstStyle/>
           <a:p>
             <a:pPr algn="ctr"/>
-            <a:endParaRPr/>
           </a:p>
         </p:txBody>
       </p:sp>
@@ -11691,6 +12008,12 @@
               </a:rPr>
               <a:t>What we have done</a:t>
             </a:r>
+            <a:endParaRPr sz="1500" b="1" i="0">
+              <a:solidFill>
+                <a:srgbClr val="FFFFFF"/>
+              </a:solidFill>
+              <a:latin typeface="Calibri"/>
+            </a:endParaRPr>
           </a:p>
         </p:txBody>
       </p:sp>
@@ -11734,7 +12057,6 @@
           <a:lstStyle/>
           <a:p>
             <a:pPr algn="ctr"/>
-            <a:endParaRPr/>
           </a:p>
         </p:txBody>
       </p:sp>
@@ -11770,6 +12092,12 @@
               </a:rPr>
               <a:t>Theory</a:t>
             </a:r>
+            <a:endParaRPr sz="1100" b="1" i="0">
+              <a:solidFill>
+                <a:srgbClr val="FFFFFF"/>
+              </a:solidFill>
+              <a:latin typeface="Calibri"/>
+            </a:endParaRPr>
           </a:p>
         </p:txBody>
       </p:sp>
@@ -11813,7 +12141,6 @@
           <a:lstStyle/>
           <a:p>
             <a:pPr algn="ctr"/>
-            <a:endParaRPr/>
           </a:p>
         </p:txBody>
       </p:sp>
@@ -11867,6 +12194,12 @@
               </a:rPr>
               <a:t>, and liquid buffer L</a:t>
             </a:r>
+            <a:endParaRPr sz="1200" b="0" i="0" dirty="0">
+              <a:solidFill>
+                <a:srgbClr val="1A1A2E"/>
+              </a:solidFill>
+              <a:latin typeface="Calibri"/>
+            </a:endParaRPr>
           </a:p>
         </p:txBody>
       </p:sp>
@@ -11910,7 +12243,6 @@
           <a:lstStyle/>
           <a:p>
             <a:pPr algn="ctr"/>
-            <a:endParaRPr/>
           </a:p>
         </p:txBody>
       </p:sp>
@@ -11946,6 +12278,12 @@
               </a:rPr>
               <a:t>Regression</a:t>
             </a:r>
+            <a:endParaRPr sz="1100" b="1" i="0">
+              <a:solidFill>
+                <a:srgbClr val="FFFFFF"/>
+              </a:solidFill>
+              <a:latin typeface="Calibri"/>
+            </a:endParaRPr>
           </a:p>
         </p:txBody>
       </p:sp>
@@ -11989,7 +12327,6 @@
           <a:lstStyle/>
           <a:p>
             <a:pPr algn="ctr"/>
-            <a:endParaRPr/>
           </a:p>
         </p:txBody>
       </p:sp>
@@ -12025,6 +12362,12 @@
               </a:rPr>
               <a:t>✓  β₁ = −6.02** — stablecoin growth compresses OIS–Treasury spreads (privilege amplification)</a:t>
             </a:r>
+            <a:endParaRPr sz="1200" b="0" i="0" dirty="0">
+              <a:solidFill>
+                <a:srgbClr val="1A1A2E"/>
+              </a:solidFill>
+              <a:latin typeface="Calibri"/>
+            </a:endParaRPr>
           </a:p>
         </p:txBody>
       </p:sp>
@@ -12068,7 +12411,6 @@
           <a:lstStyle/>
           <a:p>
             <a:pPr algn="ctr"/>
-            <a:endParaRPr/>
           </a:p>
         </p:txBody>
       </p:sp>
@@ -12104,6 +12446,12 @@
               </a:rPr>
               <a:t>Threshold</a:t>
             </a:r>
+            <a:endParaRPr sz="1100" b="1" i="0">
+              <a:solidFill>
+                <a:srgbClr val="FFFFFF"/>
+              </a:solidFill>
+              <a:latin typeface="Calibri"/>
+            </a:endParaRPr>
           </a:p>
         </p:txBody>
       </p:sp>
@@ -12147,7 +12495,6 @@
           <a:lstStyle/>
           <a:p>
             <a:pPr algn="ctr"/>
-            <a:endParaRPr/>
           </a:p>
         </p:txBody>
       </p:sp>
@@ -12183,6 +12530,12 @@
               </a:rPr>
               <a:t>✓  Hansen (2000) threshold at q* = 13% liquid cash — separates safe from fragile regime</a:t>
             </a:r>
+            <a:endParaRPr sz="1200" b="0" i="0" dirty="0">
+              <a:solidFill>
+                <a:srgbClr val="1A1A2E"/>
+              </a:solidFill>
+              <a:latin typeface="Calibri"/>
+            </a:endParaRPr>
           </a:p>
         </p:txBody>
       </p:sp>
@@ -12226,7 +12579,6 @@
           <a:lstStyle/>
           <a:p>
             <a:pPr algn="ctr"/>
-            <a:endParaRPr/>
           </a:p>
         </p:txBody>
       </p:sp>
@@ -12262,6 +12614,12 @@
               </a:rPr>
               <a:t>Event Study</a:t>
             </a:r>
+            <a:endParaRPr sz="1100" b="1" i="0">
+              <a:solidFill>
+                <a:srgbClr val="FFFFFF"/>
+              </a:solidFill>
+              <a:latin typeface="Calibri"/>
+            </a:endParaRPr>
           </a:p>
         </p:txBody>
       </p:sp>
@@ -12305,7 +12663,6 @@
           <a:lstStyle/>
           <a:p>
             <a:pPr algn="ctr"/>
-            <a:endParaRPr/>
           </a:p>
         </p:txBody>
       </p:sp>
@@ -12359,6 +12716,12 @@
               </a:rPr>
               <a:t>, SVB) — 27 pp CAR swing between low/high buffer regimes</a:t>
             </a:r>
+            <a:endParaRPr sz="1200" b="0" i="0" dirty="0">
+              <a:solidFill>
+                <a:srgbClr val="1A1A2E"/>
+              </a:solidFill>
+              <a:latin typeface="Calibri"/>
+            </a:endParaRPr>
           </a:p>
         </p:txBody>
       </p:sp>
@@ -12402,7 +12765,6 @@
           <a:lstStyle/>
           <a:p>
             <a:pPr algn="ctr"/>
-            <a:endParaRPr/>
           </a:p>
         </p:txBody>
       </p:sp>
@@ -12438,6 +12800,12 @@
               </a:rPr>
               <a:t>Robustness</a:t>
             </a:r>
+            <a:endParaRPr sz="1100" b="1" i="0">
+              <a:solidFill>
+                <a:srgbClr val="FFFFFF"/>
+              </a:solidFill>
+              <a:latin typeface="Calibri"/>
+            </a:endParaRPr>
           </a:p>
         </p:txBody>
       </p:sp>
@@ -12481,7 +12849,6 @@
           <a:lstStyle/>
           <a:p>
             <a:pPr algn="ctr"/>
-            <a:endParaRPr/>
           </a:p>
         </p:txBody>
       </p:sp>
@@ -12517,6 +12884,12 @@
               </a:rPr>
               <a:t>✓  Mean-centering (VIF), Engle-Granger cointegration, first-differenced spec, post-2023 subsample</a:t>
             </a:r>
+            <a:endParaRPr sz="1200" b="0" i="0" dirty="0">
+              <a:solidFill>
+                <a:srgbClr val="1A1A2E"/>
+              </a:solidFill>
+              <a:latin typeface="Calibri"/>
+            </a:endParaRPr>
           </a:p>
         </p:txBody>
       </p:sp>
@@ -12562,7 +12935,6 @@
           <a:lstStyle/>
           <a:p>
             <a:pPr algn="ctr"/>
-            <a:endParaRPr/>
           </a:p>
         </p:txBody>
       </p:sp>
@@ -12598,6 +12970,12 @@
               </a:rPr>
               <a:t>This deck</a:t>
             </a:r>
+            <a:endParaRPr sz="1100" b="1" i="0" dirty="0">
+              <a:solidFill>
+                <a:srgbClr val="FFFFFF"/>
+              </a:solidFill>
+              <a:latin typeface="Calibri"/>
+            </a:endParaRPr>
           </a:p>
         </p:txBody>
       </p:sp>
@@ -12641,7 +13019,6 @@
           <a:lstStyle/>
           <a:p>
             <a:pPr algn="ctr"/>
-            <a:endParaRPr/>
           </a:p>
         </p:txBody>
       </p:sp>
@@ -12677,6 +13054,12 @@
               </a:rPr>
               <a:t>✓  Clarified: why OIS spread, what the buffer condition means, how to read CAR, what each event was</a:t>
             </a:r>
+            <a:endParaRPr sz="1200" b="0" i="0" dirty="0">
+              <a:solidFill>
+                <a:srgbClr val="1A1A2E"/>
+              </a:solidFill>
+              <a:latin typeface="Calibri"/>
+            </a:endParaRPr>
           </a:p>
         </p:txBody>
       </p:sp>
@@ -12786,7 +13169,6 @@
           <a:lstStyle/>
           <a:p>
             <a:pPr algn="ctr"/>
-            <a:endParaRPr/>
           </a:p>
         </p:txBody>
       </p:sp>
@@ -12830,7 +13212,6 @@
           <a:lstStyle/>
           <a:p>
             <a:pPr algn="ctr"/>
-            <a:endParaRPr/>
           </a:p>
         </p:txBody>
       </p:sp>
@@ -12866,6 +13247,12 @@
               </a:rPr>
               <a:t>Why OIS–Treasury Spread, Not Raw Yields?</a:t>
             </a:r>
+            <a:endParaRPr sz="2600" b="0" i="0">
+              <a:solidFill>
+                <a:srgbClr val="FFFFFF"/>
+              </a:solidFill>
+              <a:latin typeface="Calibri"/>
+            </a:endParaRPr>
           </a:p>
         </p:txBody>
       </p:sp>
@@ -12901,6 +13288,12 @@
               </a:rPr>
               <a:t>3</a:t>
             </a:r>
+            <a:endParaRPr sz="1300" b="0" i="0">
+              <a:solidFill>
+                <a:srgbClr val="555566"/>
+              </a:solidFill>
+              <a:latin typeface="Calibri"/>
+            </a:endParaRPr>
           </a:p>
         </p:txBody>
       </p:sp>
@@ -12944,7 +13337,6 @@
           <a:lstStyle/>
           <a:p>
             <a:pPr algn="ctr"/>
-            <a:endParaRPr/>
           </a:p>
         </p:txBody>
       </p:sp>
@@ -12980,6 +13372,12 @@
               </a:rPr>
               <a:t>A T-bill yield moves for two reasons simultaneously. We need to separate them.</a:t>
             </a:r>
+            <a:endParaRPr sz="1400" b="0" i="1">
+              <a:solidFill>
+                <a:srgbClr val="1B3A72"/>
+              </a:solidFill>
+              <a:latin typeface="Calibri"/>
+            </a:endParaRPr>
           </a:p>
         </p:txBody>
       </p:sp>
@@ -13023,7 +13421,6 @@
           <a:lstStyle/>
           <a:p>
             <a:pPr algn="ctr"/>
-            <a:endParaRPr/>
           </a:p>
         </p:txBody>
       </p:sp>
@@ -13059,6 +13456,12 @@
               </a:rPr>
               <a:t>Raw T-bill Yield</a:t>
             </a:r>
+            <a:endParaRPr sz="1300" b="1" i="0">
+              <a:solidFill>
+                <a:srgbClr val="FFFFFF"/>
+              </a:solidFill>
+              <a:latin typeface="Calibri"/>
+            </a:endParaRPr>
           </a:p>
         </p:txBody>
       </p:sp>
@@ -13094,6 +13497,12 @@
               </a:rPr>
               <a:t>(what we did NOT use)</a:t>
             </a:r>
+            <a:endParaRPr sz="1100" b="0" i="1" dirty="0">
+              <a:solidFill>
+                <a:srgbClr val="FFFFFF"/>
+              </a:solidFill>
+              <a:latin typeface="Calibri"/>
+            </a:endParaRPr>
           </a:p>
         </p:txBody>
       </p:sp>
@@ -13137,7 +13546,6 @@
           <a:lstStyle/>
           <a:p>
             <a:pPr algn="ctr"/>
-            <a:endParaRPr/>
           </a:p>
         </p:txBody>
       </p:sp>
@@ -13185,6 +13593,12 @@
               </a:rPr>
               <a:t>•  Driven by Fed rate expectations</a:t>
             </a:r>
+            <a:endParaRPr sz="1300" b="0" i="0" dirty="0">
+              <a:solidFill>
+                <a:srgbClr val="1A1A2E"/>
+              </a:solidFill>
+              <a:latin typeface="Calibri"/>
+            </a:endParaRPr>
           </a:p>
           <a:p>
             <a:pPr algn="l">
@@ -13201,6 +13615,12 @@
               </a:rPr>
               <a:t>•  Driven by inflation expectations</a:t>
             </a:r>
+            <a:endParaRPr sz="1300" b="0" i="0" dirty="0">
+              <a:solidFill>
+                <a:srgbClr val="1A1A2E"/>
+              </a:solidFill>
+              <a:latin typeface="Calibri"/>
+            </a:endParaRPr>
           </a:p>
           <a:p>
             <a:pPr algn="l">
@@ -13217,6 +13637,12 @@
               </a:rPr>
               <a:t>•  Driven by safe-asset demand</a:t>
             </a:r>
+            <a:endParaRPr sz="1300" b="0" i="0" dirty="0">
+              <a:solidFill>
+                <a:srgbClr val="1A1A2E"/>
+              </a:solidFill>
+              <a:latin typeface="Calibri"/>
+            </a:endParaRPr>
           </a:p>
           <a:p>
             <a:pPr algn="l">
@@ -13233,6 +13659,12 @@
               </a:rPr>
               <a:t>•  Cannot distinguish these three forces</a:t>
             </a:r>
+            <a:endParaRPr sz="1300" b="0" i="0" dirty="0">
+              <a:solidFill>
+                <a:srgbClr val="1A1A2E"/>
+              </a:solidFill>
+              <a:latin typeface="Calibri"/>
+            </a:endParaRPr>
           </a:p>
         </p:txBody>
       </p:sp>
@@ -13276,7 +13708,6 @@
           <a:lstStyle/>
           <a:p>
             <a:pPr algn="ctr"/>
-            <a:endParaRPr/>
           </a:p>
         </p:txBody>
       </p:sp>
@@ -13312,6 +13743,12 @@
               </a:rPr>
               <a:t>OIS Rate</a:t>
             </a:r>
+            <a:endParaRPr sz="1300" b="1" i="0">
+              <a:solidFill>
+                <a:srgbClr val="FFFFFF"/>
+              </a:solidFill>
+              <a:latin typeface="Calibri"/>
+            </a:endParaRPr>
           </a:p>
         </p:txBody>
       </p:sp>
@@ -13347,6 +13784,12 @@
               </a:rPr>
               <a:t>(the subtracted benchmark)</a:t>
             </a:r>
+            <a:endParaRPr sz="1100" b="0" i="1" dirty="0">
+              <a:solidFill>
+                <a:srgbClr val="FFFFFF"/>
+              </a:solidFill>
+              <a:latin typeface="Calibri"/>
+            </a:endParaRPr>
           </a:p>
         </p:txBody>
       </p:sp>
@@ -13390,7 +13833,6 @@
           <a:lstStyle/>
           <a:p>
             <a:pPr algn="ctr"/>
-            <a:endParaRPr/>
           </a:p>
         </p:txBody>
       </p:sp>
@@ -13438,6 +13880,12 @@
               </a:rPr>
               <a:t>•  Reflects expected Fed Funds path</a:t>
             </a:r>
+            <a:endParaRPr sz="1300" b="0" i="0" dirty="0">
+              <a:solidFill>
+                <a:srgbClr val="1A1A2E"/>
+              </a:solidFill>
+              <a:latin typeface="Calibri"/>
+            </a:endParaRPr>
           </a:p>
           <a:p>
             <a:pPr algn="l">
@@ -13454,6 +13902,12 @@
               </a:rPr>
               <a:t>•  Pure monetary policy expectations</a:t>
             </a:r>
+            <a:endParaRPr sz="1300" b="0" i="0" dirty="0">
+              <a:solidFill>
+                <a:srgbClr val="1A1A2E"/>
+              </a:solidFill>
+              <a:latin typeface="Calibri"/>
+            </a:endParaRPr>
           </a:p>
           <a:p>
             <a:pPr algn="l">
@@ -13470,6 +13924,12 @@
               </a:rPr>
               <a:t>•  No T-bill specific demand embedded</a:t>
             </a:r>
+            <a:endParaRPr sz="1300" b="0" i="0" dirty="0">
+              <a:solidFill>
+                <a:srgbClr val="1A1A2E"/>
+              </a:solidFill>
+              <a:latin typeface="Calibri"/>
+            </a:endParaRPr>
           </a:p>
           <a:p>
             <a:pPr algn="l">
@@ -13486,6 +13946,12 @@
               </a:rPr>
               <a:t>•  Moves with macro, not stablecoin flows</a:t>
             </a:r>
+            <a:endParaRPr sz="1300" b="0" i="0" dirty="0">
+              <a:solidFill>
+                <a:srgbClr val="1A1A2E"/>
+              </a:solidFill>
+              <a:latin typeface="Calibri"/>
+            </a:endParaRPr>
           </a:p>
         </p:txBody>
       </p:sp>
@@ -13529,7 +13995,6 @@
           <a:lstStyle/>
           <a:p>
             <a:pPr algn="ctr"/>
-            <a:endParaRPr/>
           </a:p>
         </p:txBody>
       </p:sp>
@@ -13565,6 +14030,12 @@
               </a:rPr>
               <a:t>OIS–Treasury Spread</a:t>
             </a:r>
+            <a:endParaRPr sz="1300" b="1" i="0">
+              <a:solidFill>
+                <a:srgbClr val="FFFFFF"/>
+              </a:solidFill>
+              <a:latin typeface="Calibri"/>
+            </a:endParaRPr>
           </a:p>
         </p:txBody>
       </p:sp>
@@ -13600,6 +14071,12 @@
               </a:rPr>
               <a:t>(our dependent variable)</a:t>
             </a:r>
+            <a:endParaRPr sz="1100" b="0" i="1" dirty="0">
+              <a:solidFill>
+                <a:srgbClr val="FFFFFF"/>
+              </a:solidFill>
+              <a:latin typeface="Calibri"/>
+            </a:endParaRPr>
           </a:p>
         </p:txBody>
       </p:sp>
@@ -13643,7 +14120,6 @@
           <a:lstStyle/>
           <a:p>
             <a:pPr algn="ctr"/>
-            <a:endParaRPr/>
           </a:p>
         </p:txBody>
       </p:sp>
@@ -13691,6 +14167,12 @@
               </a:rPr>
               <a:t>❖  = T-bill yield  −  OIS rate</a:t>
             </a:r>
+            <a:endParaRPr sz="1300" b="0" i="0" dirty="0">
+              <a:solidFill>
+                <a:srgbClr val="1A1A2E"/>
+              </a:solidFill>
+              <a:latin typeface="Calibri"/>
+            </a:endParaRPr>
           </a:p>
           <a:p>
             <a:pPr algn="l">
@@ -13707,6 +14189,12 @@
               </a:rPr>
               <a:t>❖  Cancels out monetary policy</a:t>
             </a:r>
+            <a:endParaRPr sz="1300" b="0" i="0" dirty="0">
+              <a:solidFill>
+                <a:srgbClr val="1A1A2E"/>
+              </a:solidFill>
+              <a:latin typeface="Calibri"/>
+            </a:endParaRPr>
           </a:p>
           <a:p>
             <a:pPr algn="l">
@@ -13723,6 +14211,12 @@
               </a:rPr>
               <a:t>❖  Isolates convenience / safety premium</a:t>
             </a:r>
+            <a:endParaRPr sz="1300" b="0" i="0" dirty="0">
+              <a:solidFill>
+                <a:srgbClr val="1A1A2E"/>
+              </a:solidFill>
+              <a:latin typeface="Calibri"/>
+            </a:endParaRPr>
           </a:p>
           <a:p>
             <a:pPr algn="l">
@@ -13739,6 +14233,12 @@
               </a:rPr>
               <a:t>❖  Only moves when T-bill demand shifts</a:t>
             </a:r>
+            <a:endParaRPr sz="1300" b="0" i="0" dirty="0">
+              <a:solidFill>
+                <a:srgbClr val="1A1A2E"/>
+              </a:solidFill>
+              <a:latin typeface="Calibri"/>
+            </a:endParaRPr>
           </a:p>
         </p:txBody>
       </p:sp>
@@ -13782,7 +14282,6 @@
           <a:lstStyle/>
           <a:p>
             <a:pPr algn="ctr"/>
-            <a:endParaRPr/>
           </a:p>
         </p:txBody>
       </p:sp>
@@ -13818,6 +14317,12 @@
               </a:rPr>
               <a:t>Literature precedent for using this spread as the convenience yield:</a:t>
             </a:r>
+            <a:endParaRPr sz="1300" b="1" i="0">
+              <a:solidFill>
+                <a:srgbClr val="FFFFFF"/>
+              </a:solidFill>
+              <a:latin typeface="Calibri"/>
+            </a:endParaRPr>
           </a:p>
         </p:txBody>
       </p:sp>
@@ -13861,7 +14366,6 @@
           <a:lstStyle/>
           <a:p>
             <a:pPr algn="ctr"/>
-            <a:endParaRPr/>
           </a:p>
         </p:txBody>
       </p:sp>
@@ -13898,6 +14402,12 @@
               <a:t>Krishnamurthy &amp;
 Vissing-Jorgensen (2012)</a:t>
             </a:r>
+            <a:endParaRPr sz="1200" b="1" i="0">
+              <a:solidFill>
+                <a:srgbClr val="1B3A72"/>
+              </a:solidFill>
+              <a:latin typeface="Calibri"/>
+            </a:endParaRPr>
           </a:p>
         </p:txBody>
       </p:sp>
@@ -13942,6 +14452,12 @@
               </a:rPr>
               <a:t>safety and liquidity</a:t>
             </a:r>
+            <a:endParaRPr sz="1100" b="1" i="0" dirty="0">
+              <a:solidFill>
+                <a:srgbClr val="1A1A2E"/>
+              </a:solidFill>
+              <a:latin typeface="Calibri"/>
+            </a:endParaRPr>
           </a:p>
         </p:txBody>
       </p:sp>
@@ -13985,7 +14501,6 @@
           <a:lstStyle/>
           <a:p>
             <a:pPr algn="ctr"/>
-            <a:endParaRPr/>
           </a:p>
         </p:txBody>
       </p:sp>
@@ -14021,6 +14536,12 @@
               </a:rPr>
               <a:t>Nagel (2016)</a:t>
             </a:r>
+            <a:endParaRPr sz="1200" b="1" i="0">
+              <a:solidFill>
+                <a:srgbClr val="1B3A72"/>
+              </a:solidFill>
+              <a:latin typeface="Calibri"/>
+            </a:endParaRPr>
           </a:p>
         </p:txBody>
       </p:sp>
@@ -14074,6 +14595,12 @@
               </a:rPr>
               <a:t>of near-money assets</a:t>
             </a:r>
+            <a:endParaRPr sz="1100" b="0" i="0" dirty="0">
+              <a:solidFill>
+                <a:srgbClr val="1A1A2E"/>
+              </a:solidFill>
+              <a:latin typeface="Calibri"/>
+            </a:endParaRPr>
           </a:p>
         </p:txBody>
       </p:sp>
@@ -14117,7 +14644,6 @@
           <a:lstStyle/>
           <a:p>
             <a:pPr algn="ctr"/>
-            <a:endParaRPr/>
           </a:p>
         </p:txBody>
       </p:sp>
@@ -14154,6 +14680,12 @@
               <a:t>Greenwood, Hanson
 &amp; Stein (2015)</a:t>
             </a:r>
+            <a:endParaRPr sz="1200" b="1" i="0">
+              <a:solidFill>
+                <a:srgbClr val="1B3A72"/>
+              </a:solidFill>
+              <a:latin typeface="Calibri"/>
+            </a:endParaRPr>
           </a:p>
         </p:txBody>
       </p:sp>
@@ -14198,6 +14730,12 @@
               </a:rPr>
               <a:t>insensitive to monetary policy</a:t>
             </a:r>
+            <a:endParaRPr sz="1100" b="1" i="0" dirty="0">
+              <a:solidFill>
+                <a:srgbClr val="1A1A2E"/>
+              </a:solidFill>
+              <a:latin typeface="Calibri"/>
+            </a:endParaRPr>
           </a:p>
         </p:txBody>
       </p:sp>
@@ -14241,7 +14779,6 @@
           <a:lstStyle/>
           <a:p>
             <a:pPr algn="ctr"/>
-            <a:endParaRPr/>
           </a:p>
         </p:txBody>
       </p:sp>
@@ -14277,6 +14814,12 @@
               </a:rPr>
               <a:t>When stablecoin issuers buy T-bills, T-bill yields fall but OIS does not move. Only the spread captures this demand shock. Raw yields would conflate it with Fed policy.</a:t>
             </a:r>
+            <a:endParaRPr sz="1700" b="1" i="0">
+              <a:solidFill>
+                <a:srgbClr val="FFFFFF"/>
+              </a:solidFill>
+              <a:latin typeface="Calibri"/>
+            </a:endParaRPr>
           </a:p>
         </p:txBody>
       </p:sp>
@@ -14386,7 +14929,6 @@
           <a:lstStyle/>
           <a:p>
             <a:pPr algn="ctr"/>
-            <a:endParaRPr/>
           </a:p>
         </p:txBody>
       </p:sp>
@@ -14430,7 +14972,6 @@
           <a:lstStyle/>
           <a:p>
             <a:pPr algn="ctr"/>
-            <a:endParaRPr/>
           </a:p>
         </p:txBody>
       </p:sp>
@@ -14466,6 +15007,12 @@
               </a:rPr>
               <a:t>What is the Buffer Condition?</a:t>
             </a:r>
+            <a:endParaRPr sz="2600" b="0" i="0">
+              <a:solidFill>
+                <a:srgbClr val="FFFFFF"/>
+              </a:solidFill>
+              <a:latin typeface="Calibri"/>
+            </a:endParaRPr>
           </a:p>
         </p:txBody>
       </p:sp>
@@ -14501,6 +15048,12 @@
               </a:rPr>
               <a:t>4</a:t>
             </a:r>
+            <a:endParaRPr sz="1300" b="0" i="0">
+              <a:solidFill>
+                <a:srgbClr val="555566"/>
+              </a:solidFill>
+              <a:latin typeface="Calibri"/>
+            </a:endParaRPr>
           </a:p>
         </p:txBody>
       </p:sp>
@@ -14544,7 +15097,6 @@
           <a:lstStyle/>
           <a:p>
             <a:pPr algn="ctr"/>
-            <a:endParaRPr/>
           </a:p>
         </p:txBody>
       </p:sp>
@@ -14580,6 +15132,12 @@
               </a:rPr>
               <a:t>Definition:</a:t>
             </a:r>
+            <a:endParaRPr sz="1400" b="1" i="0">
+              <a:solidFill>
+                <a:srgbClr val="AAC4E8"/>
+              </a:solidFill>
+              <a:latin typeface="Calibri"/>
+            </a:endParaRPr>
           </a:p>
         </p:txBody>
       </p:sp>
@@ -14636,6 +15194,13 @@
               </a:rPr>
               <a:t> Cash-Equivalent Reserves  ÷  Total Stablecoin Supply</a:t>
             </a:r>
+            <a:endParaRPr sz="1800" b="1" i="0" dirty="0">
+              <a:solidFill>
+                <a:srgbClr val="FFFFFF"/>
+              </a:solidFill>
+              <a:latin typeface="AppleGothic" pitchFamily="2" charset="-127"/>
+              <a:ea typeface="AppleGothic" pitchFamily="2" charset="-127"/>
+            </a:endParaRPr>
           </a:p>
         </p:txBody>
       </p:sp>
@@ -14671,6 +15236,12 @@
               </a:rPr>
               <a:t>Estimated from Hansen (2000) threshold regression:   L*  =  13%  of supply</a:t>
             </a:r>
+            <a:endParaRPr sz="1300" b="0" i="1" dirty="0">
+              <a:solidFill>
+                <a:srgbClr val="AAC4E8"/>
+              </a:solidFill>
+              <a:latin typeface="Calibri"/>
+            </a:endParaRPr>
           </a:p>
         </p:txBody>
       </p:sp>
@@ -14714,7 +15285,6 @@
           <a:lstStyle/>
           <a:p>
             <a:pPr algn="ctr"/>
-            <a:endParaRPr/>
           </a:p>
         </p:txBody>
       </p:sp>
@@ -14750,6 +15320,12 @@
               </a:rPr>
               <a:t>LOW BUFFER  (L &lt; 13%)</a:t>
             </a:r>
+            <a:endParaRPr sz="1400" b="1" i="0">
+              <a:solidFill>
+                <a:srgbClr val="FFFFFF"/>
+              </a:solidFill>
+              <a:latin typeface="Calibri"/>
+            </a:endParaRPr>
           </a:p>
         </p:txBody>
       </p:sp>
@@ -14785,6 +15361,12 @@
               </a:rPr>
               <a:t>e.g. Tether in May 2022: ~5–8% cash</a:t>
             </a:r>
+            <a:endParaRPr sz="1100" b="0" i="1" dirty="0">
+              <a:solidFill>
+                <a:srgbClr val="555566"/>
+              </a:solidFill>
+              <a:latin typeface="Calibri"/>
+            </a:endParaRPr>
           </a:p>
         </p:txBody>
       </p:sp>
@@ -14828,7 +15410,6 @@
           <a:lstStyle/>
           <a:p>
             <a:pPr algn="ctr"/>
-            <a:endParaRPr/>
           </a:p>
         </p:txBody>
       </p:sp>
@@ -14876,6 +15457,12 @@
               </a:rPr>
               <a:t>❖  Issuer holds mostly T-bills, very little cash</a:t>
             </a:r>
+            <a:endParaRPr sz="1300" b="0" i="0" dirty="0">
+              <a:solidFill>
+                <a:srgbClr val="1A1A2E"/>
+              </a:solidFill>
+              <a:latin typeface="Calibri"/>
+            </a:endParaRPr>
           </a:p>
           <a:p>
             <a:pPr algn="l">
@@ -14892,6 +15479,12 @@
               </a:rPr>
               <a:t>→  When investors redeem stablecoins for dollars...</a:t>
             </a:r>
+            <a:endParaRPr sz="1300" b="0" i="0" dirty="0">
+              <a:solidFill>
+                <a:srgbClr val="1A1A2E"/>
+              </a:solidFill>
+              <a:latin typeface="Calibri"/>
+            </a:endParaRPr>
           </a:p>
           <a:p>
             <a:pPr algn="l">
@@ -14908,6 +15501,12 @@
               </a:rPr>
               <a:t>→  Issuer MUST sell T-bills to raise the cash</a:t>
             </a:r>
+            <a:endParaRPr sz="1300" b="0" i="0" dirty="0">
+              <a:solidFill>
+                <a:srgbClr val="1A1A2E"/>
+              </a:solidFill>
+              <a:latin typeface="Calibri"/>
+            </a:endParaRPr>
           </a:p>
           <a:p>
             <a:pPr algn="l">
@@ -14924,6 +15523,12 @@
               </a:rPr>
               <a:t>→  This selling pushes T-bill yields UP</a:t>
             </a:r>
+            <a:endParaRPr sz="1300" b="0" i="0" dirty="0">
+              <a:solidFill>
+                <a:srgbClr val="1A1A2E"/>
+              </a:solidFill>
+              <a:latin typeface="Calibri"/>
+            </a:endParaRPr>
           </a:p>
           <a:p>
             <a:pPr algn="l">
@@ -14940,6 +15545,12 @@
               </a:rPr>
               <a:t>→  OIS-Treasury spread SPIKES (CAR is positive)</a:t>
             </a:r>
+            <a:endParaRPr sz="1300" b="0" i="0" dirty="0">
+              <a:solidFill>
+                <a:srgbClr val="1A1A2E"/>
+              </a:solidFill>
+              <a:latin typeface="Calibri"/>
+            </a:endParaRPr>
           </a:p>
         </p:txBody>
       </p:sp>
@@ -14983,7 +15594,6 @@
           <a:lstStyle/>
           <a:p>
             <a:pPr algn="ctr"/>
-            <a:endParaRPr/>
           </a:p>
         </p:txBody>
       </p:sp>
@@ -15019,6 +15629,12 @@
               </a:rPr>
               <a:t>The issuer becomes a forced seller into an already-stressed market.</a:t>
             </a:r>
+            <a:endParaRPr sz="1200" b="1" i="0">
+              <a:solidFill>
+                <a:srgbClr val="FFFFFF"/>
+              </a:solidFill>
+              <a:latin typeface="Calibri"/>
+            </a:endParaRPr>
           </a:p>
         </p:txBody>
       </p:sp>
@@ -15062,7 +15678,6 @@
           <a:lstStyle/>
           <a:p>
             <a:pPr algn="ctr"/>
-            <a:endParaRPr/>
           </a:p>
         </p:txBody>
       </p:sp>
@@ -15098,6 +15713,12 @@
               </a:rPr>
               <a:t>HIGH BUFFER  (L ≥ 13%)</a:t>
             </a:r>
+            <a:endParaRPr sz="1400" b="1" i="0">
+              <a:solidFill>
+                <a:srgbClr val="FFFFFF"/>
+              </a:solidFill>
+              <a:latin typeface="Calibri"/>
+            </a:endParaRPr>
           </a:p>
         </p:txBody>
       </p:sp>
@@ -15133,6 +15754,12 @@
               </a:rPr>
               <a:t>e.g. Circle in March 2023: ~18–22% cash</a:t>
             </a:r>
+            <a:endParaRPr sz="1100" b="0" i="1">
+              <a:solidFill>
+                <a:srgbClr val="555566"/>
+              </a:solidFill>
+              <a:latin typeface="Calibri"/>
+            </a:endParaRPr>
           </a:p>
         </p:txBody>
       </p:sp>
@@ -15176,7 +15803,6 @@
           <a:lstStyle/>
           <a:p>
             <a:pPr algn="ctr"/>
-            <a:endParaRPr/>
           </a:p>
         </p:txBody>
       </p:sp>
@@ -15224,6 +15850,12 @@
               </a:rPr>
               <a:t>❖  Issuer holds substantial cash reserves</a:t>
             </a:r>
+            <a:endParaRPr sz="1300" b="0" i="0" dirty="0">
+              <a:solidFill>
+                <a:srgbClr val="1A1A2E"/>
+              </a:solidFill>
+              <a:latin typeface="Calibri"/>
+            </a:endParaRPr>
           </a:p>
           <a:p>
             <a:pPr algn="l">
@@ -15240,6 +15872,12 @@
               </a:rPr>
               <a:t>→  When investors redeem stablecoins for dollars...</a:t>
             </a:r>
+            <a:endParaRPr sz="1300" b="0" i="0" dirty="0">
+              <a:solidFill>
+                <a:srgbClr val="1A1A2E"/>
+              </a:solidFill>
+              <a:latin typeface="Calibri"/>
+            </a:endParaRPr>
           </a:p>
           <a:p>
             <a:pPr algn="l">
@@ -15256,6 +15894,12 @@
               </a:rPr>
               <a:t>→  Issuer pays out from cash — T-bills untouched</a:t>
             </a:r>
+            <a:endParaRPr sz="1300" b="0" i="0" dirty="0">
+              <a:solidFill>
+                <a:srgbClr val="1A1A2E"/>
+              </a:solidFill>
+              <a:latin typeface="Calibri"/>
+            </a:endParaRPr>
           </a:p>
           <a:p>
             <a:pPr algn="l">
@@ -15272,6 +15916,12 @@
               </a:rPr>
               <a:t>→  No forced selling, no T-bill yield pressure</a:t>
             </a:r>
+            <a:endParaRPr sz="1300" b="0" i="0" dirty="0">
+              <a:solidFill>
+                <a:srgbClr val="1A1A2E"/>
+              </a:solidFill>
+              <a:latin typeface="Calibri"/>
+            </a:endParaRPr>
           </a:p>
           <a:p>
             <a:pPr algn="l">
@@ -15288,6 +15938,12 @@
               </a:rPr>
               <a:t>→  Spread does NOT spike from issuer behavior</a:t>
             </a:r>
+            <a:endParaRPr sz="1300" b="0" i="0" dirty="0">
+              <a:solidFill>
+                <a:srgbClr val="1A1A2E"/>
+              </a:solidFill>
+              <a:latin typeface="Calibri"/>
+            </a:endParaRPr>
           </a:p>
         </p:txBody>
       </p:sp>
@@ -15331,7 +15987,6 @@
           <a:lstStyle/>
           <a:p>
             <a:pPr algn="ctr"/>
-            <a:endParaRPr/>
           </a:p>
         </p:txBody>
       </p:sp>
@@ -15367,6 +16022,12 @@
               </a:rPr>
               <a:t>The cash buffer absorbs the redemption shock. T-bill market is insulated.</a:t>
             </a:r>
+            <a:endParaRPr sz="1200" b="1" i="0">
+              <a:solidFill>
+                <a:srgbClr val="FFFFFF"/>
+              </a:solidFill>
+              <a:latin typeface="Calibri"/>
+            </a:endParaRPr>
           </a:p>
         </p:txBody>
       </p:sp>
@@ -15410,7 +16071,6 @@
           <a:lstStyle/>
           <a:p>
             <a:pPr algn="ctr"/>
-            <a:endParaRPr/>
           </a:p>
         </p:txBody>
       </p:sp>
@@ -15464,6 +16124,12 @@
               </a:rPr>
               <a:t> Treasury markets from one that disrupts them.</a:t>
             </a:r>
+            <a:endParaRPr sz="1700" b="1" i="0" dirty="0">
+              <a:solidFill>
+                <a:srgbClr val="FFFFFF"/>
+              </a:solidFill>
+              <a:latin typeface="Calibri"/>
+            </a:endParaRPr>
           </a:p>
         </p:txBody>
       </p:sp>
@@ -15591,8 +16257,15 @@
                 <a:latin typeface="Calibri"/>
                 <a:sym typeface="+mn-ea"/>
               </a:rPr>
-              <a:t> and Conditioned Event Study</a:t>
-            </a:r>
+              <a:t> and Event Study</a:t>
+            </a:r>
+            <a:endParaRPr lang="en-US" sz="2400" dirty="0">
+              <a:solidFill>
+                <a:srgbClr val="FFFFFF"/>
+              </a:solidFill>
+              <a:latin typeface="Calibri"/>
+              <a:sym typeface="+mn-ea"/>
+            </a:endParaRPr>
           </a:p>
         </p:txBody>
       </p:sp>
@@ -15646,6 +16319,13 @@
               </a:rPr>
               <a:t>CAR = Cumulative Abnormal Return on the OIS–Treasury Spread</a:t>
             </a:r>
+            <a:endParaRPr b="1">
+              <a:solidFill>
+                <a:srgbClr val="FFFFFF"/>
+              </a:solidFill>
+              <a:latin typeface="Calibri"/>
+              <a:sym typeface="+mn-ea"/>
+            </a:endParaRPr>
           </a:p>
         </p:txBody>
       </p:sp>
@@ -15901,6 +16581,13 @@
               </a:rPr>
               <a:t>X-axis: trading days relative to event (day 0 = crisis date)</a:t>
             </a:r>
+            <a:endParaRPr lang="en-US" altLang="en-US" dirty="0">
+              <a:solidFill>
+                <a:srgbClr val="1A1A2E"/>
+              </a:solidFill>
+              <a:latin typeface="Calibri"/>
+              <a:sym typeface="+mn-ea"/>
+            </a:endParaRPr>
           </a:p>
           <a:p>
             <a:pPr algn="l"/>
@@ -16043,6 +16730,13 @@
               </a:rPr>
               <a:t>Cumulative Abnormal OIS–Treasury Spread</a:t>
             </a:r>
+            <a:endParaRPr b="1">
+              <a:solidFill>
+                <a:srgbClr val="FFFFFF"/>
+              </a:solidFill>
+              <a:latin typeface="Calibri"/>
+              <a:sym typeface="+mn-ea"/>
+            </a:endParaRPr>
           </a:p>
         </p:txBody>
       </p:sp>
@@ -16090,27 +16784,29 @@
               <a:rPr lang="en-US" altLang="en-US" sz="1400"/>
               <a:t>Event 2: USDT partial depeg — May 12, 2022 (3 days later) | Buffer: LOW (~5–8%) | CAR = +8.85 pp*** | Unlike UST (algorithmic, no real reserves), USDT was fiat-backed — a direct confidence run on real reserves. Same buffer. Same CAR. Different trigger. Same outcome.</a:t>
             </a:r>
+            <a:endParaRPr lang="en-US" altLang="en-US" sz="1400"/>
           </a:p>
         </p:txBody>
       </p:sp>
       <p:pic>
         <p:nvPicPr>
-          <p:cNvPr id="41" name="Picture 40"/>
+          <p:cNvPr id="4" name="Picture 3" descr="event_study_cars.png"/>
           <p:cNvPicPr>
             <a:picLocks noChangeAspect="1"/>
           </p:cNvPicPr>
           <p:nvPr/>
         </p:nvPicPr>
         <p:blipFill>
-          <a:blip r:embed="rId3"/>
+          <a:blip r:embed="rId1"/>
+          <a:srcRect t="10403" r="67422" b="1944"/>
           <a:stretch>
             <a:fillRect/>
           </a:stretch>
         </p:blipFill>
         <p:spPr>
           <a:xfrm>
-            <a:off x="6082030" y="1672590"/>
-            <a:ext cx="5603240" cy="3735705"/>
+            <a:off x="7341235" y="1680210"/>
+            <a:ext cx="2564130" cy="3741420"/>
           </a:xfrm>
           <a:prstGeom prst="rect">
             <a:avLst/>
@@ -16336,7 +17032,7 @@
                                           </p:stCondLst>
                                         </p:cTn>
                                         <p:tgtEl>
-                                          <p:spTgt spid="41"/>
+                                          <p:spTgt spid="4"/>
                                         </p:tgtEl>
                                         <p:attrNameLst>
                                           <p:attrName>style.visibility</p:attrName>
@@ -16494,7 +17190,6 @@
           <a:lstStyle/>
           <a:p>
             <a:pPr algn="ctr"/>
-            <a:endParaRPr/>
           </a:p>
         </p:txBody>
       </p:sp>
@@ -16538,7 +17233,6 @@
           <a:lstStyle/>
           <a:p>
             <a:pPr algn="ctr"/>
-            <a:endParaRPr/>
           </a:p>
         </p:txBody>
       </p:sp>
@@ -16610,6 +17304,12 @@
               </a:rPr>
               <a:t>, 2023</a:t>
             </a:r>
+            <a:endParaRPr sz="2600" b="0" i="0" dirty="0">
+              <a:solidFill>
+                <a:srgbClr val="FFFFFF"/>
+              </a:solidFill>
+              <a:latin typeface="Calibri"/>
+            </a:endParaRPr>
           </a:p>
         </p:txBody>
       </p:sp>
@@ -16653,7 +17353,6 @@
           <a:lstStyle/>
           <a:p>
             <a:pPr algn="ctr"/>
-            <a:endParaRPr/>
           </a:p>
         </p:txBody>
       </p:sp>
@@ -16689,6 +17388,12 @@
               </a:rPr>
               <a:t>Buffer Condition: HIGH   |   $3.3B (8% of reserves) frozen at SVB   |   CAR = −18.01 pp***   |   t-stat &gt; 30</a:t>
             </a:r>
+            <a:endParaRPr sz="1300" b="1" i="0">
+              <a:solidFill>
+                <a:srgbClr val="FFFFFF"/>
+              </a:solidFill>
+              <a:latin typeface="Calibri"/>
+            </a:endParaRPr>
           </a:p>
         </p:txBody>
       </p:sp>
@@ -16732,7 +17437,6 @@
           <a:lstStyle/>
           <a:p>
             <a:pPr algn="ctr"/>
-            <a:endParaRPr/>
           </a:p>
         </p:txBody>
       </p:sp>
@@ -16768,6 +17472,12 @@
               </a:rPr>
               <a:t>What happened</a:t>
             </a:r>
+            <a:endParaRPr sz="1400" b="1" i="0">
+              <a:solidFill>
+                <a:srgbClr val="1B3A72"/>
+              </a:solidFill>
+              <a:latin typeface="Calibri"/>
+            </a:endParaRPr>
           </a:p>
         </p:txBody>
       </p:sp>
@@ -16807,40 +17517,6 @@
               </a:rPr>
               <a:t>❖  SVB failed on March 10, 2023 — the second-largest US bank failure in history</a:t>
             </a:r>
-          </a:p>
-          <a:p>
-            <a:pPr algn="l">
-              <a:spcBef>
-                <a:spcPts val="600"/>
-              </a:spcBef>
-            </a:pPr>
-            <a:r>
-              <a:rPr sz="1200" b="0" i="0" dirty="0">
-                <a:solidFill>
-                  <a:srgbClr val="1A1A2E"/>
-                </a:solidFill>
-                <a:latin typeface="Calibri"/>
-              </a:rPr>
-              <a:t>❖  Circle disclosed: $3.3 billion of USDC reserves were held at SVB — temporarily inaccessible</a:t>
-            </a:r>
-            <a:r>
-              <a:rPr lang="en-US" sz="1200" b="0" i="0" dirty="0">
-                <a:solidFill>
-                  <a:srgbClr val="1A1A2E"/>
-                </a:solidFill>
-                <a:latin typeface="Calibri"/>
-              </a:rPr>
-              <a:t> *still had 6.4B at alternativ</a:t>
-            </a:r>
-            <a:r>
-              <a:rPr lang="en-US" sz="1200" dirty="0">
-                <a:solidFill>
-                  <a:srgbClr val="1A1A2E"/>
-                </a:solidFill>
-                <a:latin typeface="Calibri"/>
-              </a:rPr>
-              <a:t>e banks</a:t>
-            </a:r>
             <a:endParaRPr sz="1200" b="0" i="0" dirty="0">
               <a:solidFill>
                 <a:srgbClr val="1A1A2E"/>
@@ -16861,44 +17537,32 @@
                 </a:solidFill>
                 <a:latin typeface="Calibri"/>
               </a:rPr>
-              <a:t>❖  USDC </a:t>
-            </a:r>
-            <a:r>
-              <a:rPr sz="1200" b="0" i="0" dirty="0" err="1">
+              <a:t>❖  Circle disclosed: $3.3 billion of USDC reserves were held at SVB — temporarily inaccessible</a:t>
+            </a:r>
+            <a:r>
+              <a:rPr lang="en-US" sz="1200" b="0" i="0" dirty="0">
                 <a:solidFill>
                   <a:srgbClr val="1A1A2E"/>
                 </a:solidFill>
                 <a:latin typeface="Calibri"/>
               </a:rPr>
-              <a:t>depegged</a:t>
-            </a:r>
-            <a:r>
-              <a:rPr sz="1200" b="0" i="0" dirty="0">
+              <a:t> *still had 6.4B at alternativ</a:t>
+            </a:r>
+            <a:r>
+              <a:rPr lang="en-US" sz="1200" dirty="0">
                 <a:solidFill>
                   <a:srgbClr val="1A1A2E"/>
                 </a:solidFill>
                 <a:latin typeface="Calibri"/>
               </a:rPr>
-              <a:t> to ~$0.87 on March 11 — a larger nominal </a:t>
-            </a:r>
-            <a:r>
-              <a:rPr sz="1200" b="0" i="0" dirty="0" err="1">
-                <a:solidFill>
-                  <a:srgbClr val="1A1A2E"/>
-                </a:solidFill>
-                <a:latin typeface="Calibri"/>
-              </a:rPr>
-              <a:t>depeg</a:t>
-            </a:r>
-            <a:r>
-              <a:rPr sz="1200" b="0" i="0" dirty="0">
-                <a:solidFill>
-                  <a:srgbClr val="1A1A2E"/>
-                </a:solidFill>
-                <a:latin typeface="Calibri"/>
-              </a:rPr>
-              <a:t> than USDT in 2022</a:t>
-            </a:r>
+              <a:t>e banks</a:t>
+            </a:r>
+            <a:endParaRPr sz="1200" b="0" i="0" dirty="0">
+              <a:solidFill>
+                <a:srgbClr val="1A1A2E"/>
+              </a:solidFill>
+              <a:latin typeface="Calibri"/>
+            </a:endParaRPr>
           </a:p>
           <a:p>
             <a:pPr algn="l">
@@ -16913,8 +17577,72 @@
                 </a:solidFill>
                 <a:latin typeface="Calibri"/>
               </a:rPr>
+              <a:t>❖  USDC </a:t>
+            </a:r>
+            <a:r>
+              <a:rPr sz="1200" b="0" i="0" dirty="0" err="1">
+                <a:solidFill>
+                  <a:srgbClr val="1A1A2E"/>
+                </a:solidFill>
+                <a:latin typeface="Calibri"/>
+              </a:rPr>
+              <a:t>depegged</a:t>
+            </a:r>
+            <a:r>
+              <a:rPr sz="1200" b="0" i="0" dirty="0">
+                <a:solidFill>
+                  <a:srgbClr val="1A1A2E"/>
+                </a:solidFill>
+                <a:latin typeface="Calibri"/>
+              </a:rPr>
+              <a:t> to ~$0.87 on March 11 — a larger nominal </a:t>
+            </a:r>
+            <a:r>
+              <a:rPr sz="1200" b="0" i="0" dirty="0" err="1">
+                <a:solidFill>
+                  <a:srgbClr val="1A1A2E"/>
+                </a:solidFill>
+                <a:latin typeface="Calibri"/>
+              </a:rPr>
+              <a:t>depeg</a:t>
+            </a:r>
+            <a:r>
+              <a:rPr sz="1200" b="0" i="0" dirty="0">
+                <a:solidFill>
+                  <a:srgbClr val="1A1A2E"/>
+                </a:solidFill>
+                <a:latin typeface="Calibri"/>
+              </a:rPr>
+              <a:t> than USDT in 2022</a:t>
+            </a:r>
+            <a:endParaRPr sz="1200" b="0" i="0" dirty="0">
+              <a:solidFill>
+                <a:srgbClr val="1A1A2E"/>
+              </a:solidFill>
+              <a:latin typeface="Calibri"/>
+            </a:endParaRPr>
+          </a:p>
+          <a:p>
+            <a:pPr algn="l">
+              <a:spcBef>
+                <a:spcPts val="600"/>
+              </a:spcBef>
+            </a:pPr>
+            <a:r>
+              <a:rPr sz="1200" b="0" i="0" dirty="0">
+                <a:solidFill>
+                  <a:srgbClr val="1A1A2E"/>
+                </a:solidFill>
+                <a:latin typeface="Calibri"/>
+              </a:rPr>
               <a:t>❖  But by March 13, after the US government guaranteed SVB deposits, USDC returned to $1.00</a:t>
             </a:r>
+            <a:endParaRPr sz="1200" b="0" i="0" dirty="0">
+              <a:solidFill>
+                <a:srgbClr val="1A1A2E"/>
+              </a:solidFill>
+              <a:latin typeface="Calibri"/>
+            </a:endParaRPr>
           </a:p>
         </p:txBody>
       </p:sp>
@@ -16995,6 +17723,13 @@
               </a:rPr>
               <a:t>Circle did NOT need to sell T-bills — government backstop resolved the crisis before forced liquidation.</a:t>
             </a:r>
+            <a:endParaRPr sz="1000">
+              <a:solidFill>
+                <a:srgbClr val="1A1A2E"/>
+              </a:solidFill>
+              <a:latin typeface="Calibri"/>
+              <a:sym typeface="+mn-ea"/>
+            </a:endParaRPr>
           </a:p>
         </p:txBody>
       </p:sp>
@@ -17332,7 +18067,7 @@
           <p:nvPr/>
         </p:nvPicPr>
         <p:blipFill>
-          <a:blip r:embed="rId3"/>
+          <a:blip r:embed="rId1"/>
           <a:srcRect l="65880" t="8036" r="816"/>
           <a:stretch>
             <a:fillRect/>
@@ -17414,7 +18149,7 @@
               </a:rPr>
             </a:br>
             <a:r>
-              <a:rPr lang="en-US" dirty="0">
+              <a:rPr lang="en-US" sz="1600" dirty="0">
                 <a:solidFill>
                   <a:schemeClr val="bg1"/>
                 </a:solidFill>
@@ -17424,7 +18159,7 @@
               <a:t>2022  Low buffer (LUNA + USDT avg)  →  CAR = +8.9 pp   →  Forced T-bill selling pushed the spread UP</a:t>
             </a:r>
             <a:br>
-              <a:rPr lang="en-US" b="1" dirty="0">
+              <a:rPr lang="en-US" sz="1600" b="1" dirty="0">
                 <a:solidFill>
                   <a:schemeClr val="bg1"/>
                 </a:solidFill>
@@ -17433,17 +18168,17 @@
               </a:rPr>
             </a:br>
             <a:r>
-              <a:rPr lang="en-US" dirty="0">
+              <a:rPr lang="en-US" sz="1600" dirty="0">
                 <a:solidFill>
                   <a:schemeClr val="bg1"/>
                 </a:solidFill>
                 <a:latin typeface="Calibri"/>
                 <a:sym typeface="+mn-ea"/>
               </a:rPr>
-              <a:t>2023  High buffer (SVB)               →  CAR = −18.0 pp  →  No forced selling + flight-to-safety buying pushed the spread DOWN</a:t>
+              <a:t>2023  High buffer (SVB) →  CAR = −18.0 pp  →  No forced selling + flight-to-safety buying pushed the spread DOWN</a:t>
             </a:r>
             <a:br>
-              <a:rPr lang="en-US" b="1" dirty="0">
+              <a:rPr lang="en-US" sz="1600" b="1" dirty="0">
                 <a:solidFill>
                   <a:schemeClr val="bg1"/>
                 </a:solidFill>
@@ -17452,7 +18187,7 @@
               </a:rPr>
             </a:br>
             <a:r>
-              <a:rPr lang="en-US" dirty="0">
+              <a:rPr lang="en-US" sz="1600" dirty="0">
                 <a:solidFill>
                   <a:schemeClr val="bg1"/>
                 </a:solidFill>
@@ -17462,7 +18197,7 @@
               <a:t>Swing: +8.9 − (−18.0) = 26.9 pp  →  The buffer regime alone flipped both the direction and size of the Treasury market impact</a:t>
             </a:r>
             <a:br>
-              <a:rPr lang="en-US" b="1" dirty="0">
+              <a:rPr lang="en-US" sz="1600" b="1" dirty="0">
                 <a:solidFill>
                   <a:schemeClr val="bg1"/>
                 </a:solidFill>
@@ -17471,7 +18206,7 @@
               </a:rPr>
             </a:br>
             <a:r>
-              <a:rPr lang="en-US" dirty="0">
+              <a:rPr lang="en-US" sz="1600" dirty="0">
                 <a:solidFill>
                   <a:schemeClr val="bg1"/>
                 </a:solidFill>
@@ -17480,6 +18215,13 @@
               </a:rPr>
               <a:t>Welch t = 15.22***  |  p &lt; 0.001  →  The probability this difference is random is essentially zero</a:t>
             </a:r>
+            <a:endParaRPr lang="en-US" sz="1600" dirty="0">
+              <a:solidFill>
+                <a:schemeClr val="bg1"/>
+              </a:solidFill>
+              <a:latin typeface="Calibri"/>
+              <a:sym typeface="+mn-ea"/>
+            </a:endParaRPr>
           </a:p>
         </p:txBody>
       </p:sp>
@@ -17548,7 +18290,6 @@
           <a:lstStyle/>
           <a:p>
             <a:pPr algn="ctr"/>
-            <a:endParaRPr/>
           </a:p>
         </p:txBody>
       </p:sp>
@@ -17592,7 +18333,6 @@
           <a:lstStyle/>
           <a:p>
             <a:pPr algn="ctr"/>
-            <a:endParaRPr/>
           </a:p>
         </p:txBody>
       </p:sp>
@@ -17628,6 +18368,12 @@
               </a:rPr>
               <a:t>Roadmap</a:t>
             </a:r>
+            <a:endParaRPr sz="2600" b="0" i="0" dirty="0">
+              <a:solidFill>
+                <a:srgbClr val="FFFFFF"/>
+              </a:solidFill>
+              <a:latin typeface="Calibri"/>
+            </a:endParaRPr>
           </a:p>
         </p:txBody>
       </p:sp>
@@ -17671,7 +18417,6 @@
           <a:lstStyle/>
           <a:p>
             <a:pPr algn="ctr"/>
-            <a:endParaRPr/>
           </a:p>
         </p:txBody>
       </p:sp>
@@ -17707,6 +18452,12 @@
               </a:rPr>
               <a:t>What we have done</a:t>
             </a:r>
+            <a:endParaRPr sz="1500" b="1" i="0">
+              <a:solidFill>
+                <a:srgbClr val="FFFFFF"/>
+              </a:solidFill>
+              <a:latin typeface="Calibri"/>
+            </a:endParaRPr>
           </a:p>
         </p:txBody>
       </p:sp>
@@ -17750,7 +18501,6 @@
           <a:lstStyle/>
           <a:p>
             <a:pPr algn="ctr"/>
-            <a:endParaRPr/>
           </a:p>
         </p:txBody>
       </p:sp>
@@ -17786,6 +18536,12 @@
               </a:rPr>
               <a:t>Theory</a:t>
             </a:r>
+            <a:endParaRPr sz="1100" b="1" i="0">
+              <a:solidFill>
+                <a:srgbClr val="FFFFFF"/>
+              </a:solidFill>
+              <a:latin typeface="Calibri"/>
+            </a:endParaRPr>
           </a:p>
         </p:txBody>
       </p:sp>
@@ -17829,7 +18585,6 @@
           <a:lstStyle/>
           <a:p>
             <a:pPr algn="ctr"/>
-            <a:endParaRPr/>
           </a:p>
         </p:txBody>
       </p:sp>
@@ -17883,6 +18638,12 @@
               </a:rPr>
               <a:t>, and liquid buffer L</a:t>
             </a:r>
+            <a:endParaRPr sz="1200" b="0" i="0" dirty="0">
+              <a:solidFill>
+                <a:srgbClr val="1A1A2E"/>
+              </a:solidFill>
+              <a:latin typeface="Calibri"/>
+            </a:endParaRPr>
           </a:p>
         </p:txBody>
       </p:sp>
@@ -17926,7 +18687,6 @@
           <a:lstStyle/>
           <a:p>
             <a:pPr algn="ctr"/>
-            <a:endParaRPr/>
           </a:p>
         </p:txBody>
       </p:sp>
@@ -17962,6 +18722,12 @@
               </a:rPr>
               <a:t>Regression</a:t>
             </a:r>
+            <a:endParaRPr sz="1100" b="1" i="0">
+              <a:solidFill>
+                <a:srgbClr val="FFFFFF"/>
+              </a:solidFill>
+              <a:latin typeface="Calibri"/>
+            </a:endParaRPr>
           </a:p>
         </p:txBody>
       </p:sp>
@@ -18005,7 +18771,6 @@
           <a:lstStyle/>
           <a:p>
             <a:pPr algn="ctr"/>
-            <a:endParaRPr/>
           </a:p>
         </p:txBody>
       </p:sp>
@@ -18041,6 +18806,12 @@
               </a:rPr>
               <a:t>✓  β₁ = −6.02** — stablecoin growth compresses OIS–Treasury spreads (privilege amplification)</a:t>
             </a:r>
+            <a:endParaRPr sz="1200" b="0" i="0" dirty="0">
+              <a:solidFill>
+                <a:srgbClr val="1A1A2E"/>
+              </a:solidFill>
+              <a:latin typeface="Calibri"/>
+            </a:endParaRPr>
           </a:p>
         </p:txBody>
       </p:sp>
@@ -18084,7 +18855,6 @@
           <a:lstStyle/>
           <a:p>
             <a:pPr algn="ctr"/>
-            <a:endParaRPr/>
           </a:p>
         </p:txBody>
       </p:sp>
@@ -18120,6 +18890,12 @@
               </a:rPr>
               <a:t>Threshold</a:t>
             </a:r>
+            <a:endParaRPr sz="1100" b="1" i="0">
+              <a:solidFill>
+                <a:srgbClr val="FFFFFF"/>
+              </a:solidFill>
+              <a:latin typeface="Calibri"/>
+            </a:endParaRPr>
           </a:p>
         </p:txBody>
       </p:sp>
@@ -18163,7 +18939,6 @@
           <a:lstStyle/>
           <a:p>
             <a:pPr algn="ctr"/>
-            <a:endParaRPr/>
           </a:p>
         </p:txBody>
       </p:sp>
@@ -18199,6 +18974,12 @@
               </a:rPr>
               <a:t>✓  Hansen (2000) threshold at q* = 13% liquid cash — separates safe from fragile regime</a:t>
             </a:r>
+            <a:endParaRPr sz="1200" b="0" i="0" dirty="0">
+              <a:solidFill>
+                <a:srgbClr val="1A1A2E"/>
+              </a:solidFill>
+              <a:latin typeface="Calibri"/>
+            </a:endParaRPr>
           </a:p>
         </p:txBody>
       </p:sp>
@@ -18242,7 +19023,6 @@
           <a:lstStyle/>
           <a:p>
             <a:pPr algn="ctr"/>
-            <a:endParaRPr/>
           </a:p>
         </p:txBody>
       </p:sp>
@@ -18278,6 +19058,12 @@
               </a:rPr>
               <a:t>Event Study</a:t>
             </a:r>
+            <a:endParaRPr sz="1100" b="1" i="0">
+              <a:solidFill>
+                <a:srgbClr val="FFFFFF"/>
+              </a:solidFill>
+              <a:latin typeface="Calibri"/>
+            </a:endParaRPr>
           </a:p>
         </p:txBody>
       </p:sp>
@@ -18321,7 +19107,6 @@
           <a:lstStyle/>
           <a:p>
             <a:pPr algn="ctr"/>
-            <a:endParaRPr/>
           </a:p>
         </p:txBody>
       </p:sp>
@@ -18375,6 +19160,12 @@
               </a:rPr>
               <a:t>, SVB) — 27 pp CAR swing between low/high buffer regimes</a:t>
             </a:r>
+            <a:endParaRPr sz="1200" b="0" i="0" dirty="0">
+              <a:solidFill>
+                <a:srgbClr val="1A1A2E"/>
+              </a:solidFill>
+              <a:latin typeface="Calibri"/>
+            </a:endParaRPr>
           </a:p>
         </p:txBody>
       </p:sp>
@@ -18418,7 +19209,6 @@
           <a:lstStyle/>
           <a:p>
             <a:pPr algn="ctr"/>
-            <a:endParaRPr/>
           </a:p>
         </p:txBody>
       </p:sp>
@@ -18454,6 +19244,12 @@
               </a:rPr>
               <a:t>Robustness</a:t>
             </a:r>
+            <a:endParaRPr sz="1100" b="1" i="0">
+              <a:solidFill>
+                <a:srgbClr val="FFFFFF"/>
+              </a:solidFill>
+              <a:latin typeface="Calibri"/>
+            </a:endParaRPr>
           </a:p>
         </p:txBody>
       </p:sp>
@@ -18497,7 +19293,6 @@
           <a:lstStyle/>
           <a:p>
             <a:pPr algn="ctr"/>
-            <a:endParaRPr/>
           </a:p>
         </p:txBody>
       </p:sp>
@@ -18533,6 +19328,12 @@
               </a:rPr>
               <a:t>✓  Mean-centering (VIF), Engle-Granger cointegration, first-differenced spec, post-2023 subsample</a:t>
             </a:r>
+            <a:endParaRPr sz="1200" b="0" i="0">
+              <a:solidFill>
+                <a:srgbClr val="1A1A2E"/>
+              </a:solidFill>
+              <a:latin typeface="Calibri"/>
+            </a:endParaRPr>
           </a:p>
         </p:txBody>
       </p:sp>
@@ -18576,7 +19377,6 @@
           <a:lstStyle/>
           <a:p>
             <a:pPr algn="ctr"/>
-            <a:endParaRPr/>
           </a:p>
         </p:txBody>
       </p:sp>
@@ -18612,6 +19412,12 @@
               </a:rPr>
               <a:t>This deck</a:t>
             </a:r>
+            <a:endParaRPr sz="1100" b="1" i="0">
+              <a:solidFill>
+                <a:srgbClr val="FFFFFF"/>
+              </a:solidFill>
+              <a:latin typeface="Calibri"/>
+            </a:endParaRPr>
           </a:p>
         </p:txBody>
       </p:sp>
@@ -18655,7 +19461,6 @@
           <a:lstStyle/>
           <a:p>
             <a:pPr algn="ctr"/>
-            <a:endParaRPr/>
           </a:p>
         </p:txBody>
       </p:sp>
@@ -18691,6 +19496,12 @@
               </a:rPr>
               <a:t>✓  Clarified: why OIS spread, what the buffer condition means, how to read CAR, what each event was</a:t>
             </a:r>
+            <a:endParaRPr sz="1200" b="0" i="0">
+              <a:solidFill>
+                <a:srgbClr val="1A1A2E"/>
+              </a:solidFill>
+              <a:latin typeface="Calibri"/>
+            </a:endParaRPr>
           </a:p>
         </p:txBody>
       </p:sp>
@@ -18734,7 +19545,6 @@
           <a:lstStyle/>
           <a:p>
             <a:pPr algn="ctr"/>
-            <a:endParaRPr/>
           </a:p>
         </p:txBody>
       </p:sp>
@@ -18770,6 +19580,12 @@
               </a:rPr>
               <a:t>Planned for next week</a:t>
             </a:r>
+            <a:endParaRPr sz="1500" b="1" i="0" dirty="0">
+              <a:solidFill>
+                <a:srgbClr val="FFFFFF"/>
+              </a:solidFill>
+              <a:latin typeface="Calibri"/>
+            </a:endParaRPr>
           </a:p>
         </p:txBody>
       </p:sp>
@@ -18813,7 +19629,6 @@
           <a:lstStyle/>
           <a:p>
             <a:pPr algn="ctr"/>
-            <a:endParaRPr/>
           </a:p>
         </p:txBody>
       </p:sp>
@@ -18861,6 +19676,12 @@
               </a:rPr>
               <a:t>Placebo Test</a:t>
             </a:r>
+            <a:endParaRPr sz="1600" b="1" i="0" dirty="0">
+              <a:solidFill>
+                <a:srgbClr val="D4632A"/>
+              </a:solidFill>
+              <a:latin typeface="Calibri"/>
+            </a:endParaRPr>
           </a:p>
           <a:p>
             <a:pPr algn="l">
@@ -18877,6 +19698,12 @@
               </a:rPr>
               <a:t>Run the same event study methodology on 3 ordinary days with no known stablecoin stress event:</a:t>
             </a:r>
+            <a:endParaRPr sz="1300" b="0" i="0" dirty="0">
+              <a:solidFill>
+                <a:srgbClr val="1A1A2E"/>
+              </a:solidFill>
+              <a:latin typeface="Calibri"/>
+            </a:endParaRPr>
           </a:p>
           <a:p>
             <a:pPr algn="l">
@@ -18893,6 +19720,12 @@
               </a:rPr>
               <a:t>❖  Jun 15, 2021  (Low buffer)  —  Quiet summer — no redemption pressure</a:t>
             </a:r>
+            <a:endParaRPr sz="1200" b="0" i="0" dirty="0">
+              <a:solidFill>
+                <a:srgbClr val="1A1A2E"/>
+              </a:solidFill>
+              <a:latin typeface="Calibri"/>
+            </a:endParaRPr>
           </a:p>
           <a:p>
             <a:pPr algn="l">
@@ -18909,6 +19742,12 @@
               </a:rPr>
               <a:t>❖  Oct 12, 2021  (Low buffer)  —  Pre-LUNA, no crypto-specific stress</a:t>
             </a:r>
+            <a:endParaRPr sz="1200" b="0" i="0" dirty="0">
+              <a:solidFill>
+                <a:srgbClr val="1A1A2E"/>
+              </a:solidFill>
+              <a:latin typeface="Calibri"/>
+            </a:endParaRPr>
           </a:p>
           <a:p>
             <a:pPr algn="l">
@@ -18925,6 +19764,12 @@
               </a:rPr>
               <a:t>❖  Jul 15, 2025  (High buffer)  —  Post-SVB recovery, stable spread period</a:t>
             </a:r>
+            <a:endParaRPr sz="1200" b="0" i="0" dirty="0">
+              <a:solidFill>
+                <a:srgbClr val="1A1A2E"/>
+              </a:solidFill>
+              <a:latin typeface="Calibri"/>
+            </a:endParaRPr>
           </a:p>
           <a:p>
             <a:pPr algn="l">
@@ -18941,6 +19786,12 @@
               </a:rPr>
               <a:t> </a:t>
             </a:r>
+            <a:endParaRPr sz="600" b="0" i="0" dirty="0">
+              <a:solidFill>
+                <a:srgbClr val="1A1A2E"/>
+              </a:solidFill>
+              <a:latin typeface="Calibri"/>
+            </a:endParaRPr>
           </a:p>
           <a:p>
             <a:pPr algn="l">
@@ -18957,6 +19808,12 @@
               </a:rPr>
               <a:t>What we expect to show:</a:t>
             </a:r>
+            <a:endParaRPr sz="1400" b="1" i="0" dirty="0">
+              <a:solidFill>
+                <a:srgbClr val="1B3A72"/>
+              </a:solidFill>
+              <a:latin typeface="Calibri"/>
+            </a:endParaRPr>
           </a:p>
           <a:p>
             <a:pPr algn="l">
@@ -18973,6 +19830,12 @@
               </a:rPr>
               <a:t>CARs on placebo days should be near 0 pp — confirming that the 9–18 pp swings in actual events are caused by the crisis itself, not by random market drift.</a:t>
             </a:r>
+            <a:endParaRPr sz="1300" b="0" i="0" dirty="0">
+              <a:solidFill>
+                <a:srgbClr val="1A1A2E"/>
+              </a:solidFill>
+              <a:latin typeface="Calibri"/>
+            </a:endParaRPr>
           </a:p>
           <a:p>
             <a:pPr algn="l">
@@ -18989,6 +19852,12 @@
               </a:rPr>
               <a:t> </a:t>
             </a:r>
+            <a:endParaRPr sz="600" b="0" i="0" dirty="0">
+              <a:solidFill>
+                <a:srgbClr val="1A1A2E"/>
+              </a:solidFill>
+              <a:latin typeface="Calibri"/>
+            </a:endParaRPr>
           </a:p>
           <a:p>
             <a:pPr algn="l">
@@ -19005,6 +19874,12 @@
               </a:rPr>
               <a:t>Preliminary result: placebo mean |CAR| = 0.55 pp vs. actual mean |CAR| = 11.92 pp  →  21.7× difference</a:t>
             </a:r>
+            <a:endParaRPr sz="1200" b="1" i="1" dirty="0">
+              <a:solidFill>
+                <a:srgbClr val="D4632A"/>
+              </a:solidFill>
+              <a:latin typeface="Calibri"/>
+            </a:endParaRPr>
           </a:p>
         </p:txBody>
       </p:sp>
@@ -19091,14 +19966,14 @@
           <p:nvPr/>
         </p:nvPicPr>
         <p:blipFill>
-          <a:blip r:embed="rId3">
+          <a:blip r:embed="rId1">
             <a:lum bright="70000" contrast="-70000"/>
             <a:extLst>
               <a:ext uri="{BEBA8EAE-BF5A-486C-A8C5-ECC9F3942E4B}">
                 <a14:imgProps xmlns:a14="http://schemas.microsoft.com/office/drawing/2010/main">
-                  <a14:imgLayer r:embed="rId4">
+                  <a14:imgLayer r:embed="rId2">
                     <a14:imgEffect>
-                      <a14:artisticPhotocopy detail="2"/>
+                      <a14:artisticPhotocopy trans="30000" detail="2"/>
                     </a14:imgEffect>
                   </a14:imgLayer>
                 </a14:imgProps>
@@ -19178,6 +20053,13 @@
               </a:rPr>
               <a:t>Thank You</a:t>
             </a:r>
+            <a:endParaRPr lang="en-US" altLang="ko-KR" sz="2400" dirty="0">
+              <a:solidFill>
+                <a:prstClr val="white"/>
+              </a:solidFill>
+              <a:latin typeface="Hiragino Kaku Gothic Std W8" panose="020B0800000000000000" pitchFamily="34" charset="-128"/>
+              <a:ea typeface="Hiragino Kaku Gothic Std W8" panose="020B0800000000000000" pitchFamily="34" charset="-128"/>
+            </a:endParaRPr>
           </a:p>
           <a:p>
             <a:pPr algn="ctr" defTabSz="914400" latinLnBrk="1">
@@ -19223,6 +20105,11 @@
               </a:rPr>
               <a:t>Yonsei GSIS 2026-1 </a:t>
             </a:r>
+            <a:endParaRPr lang="en-US" altLang="ko-KR" sz="1800" b="1" dirty="0">
+              <a:solidFill>
+                <a:schemeClr val="bg1"/>
+              </a:solidFill>
+            </a:endParaRPr>
           </a:p>
           <a:p>
             <a:r>
@@ -19595,7 +20482,6 @@
       </a:style>
     </a:lnDef>
   </a:objectDefaults>
-  <a:extraClrSchemeLst/>
   <a:extLst>
     <a:ext uri="{05A4C25C-085E-4340-85A3-A5531E510DB2}">
       <thm15:themeFamily xmlns:thm15="http://schemas.microsoft.com/office/thememl/2012/main" name="Office Theme" id="{62F939B6-93AF-4DB8-9C6B-D6C7DFDC589F}" vid="{4A3C46E8-61CC-4603-A589-7422A47A8E4A}"/>
@@ -19876,7 +20762,6 @@
       </a:style>
     </a:lnDef>
   </a:objectDefaults>
-  <a:extraClrSchemeLst/>
   <a:extLst>
     <a:ext uri="{05A4C25C-085E-4340-85A3-A5531E510DB2}">
       <thm15:themeFamily xmlns:thm15="http://schemas.microsoft.com/office/thememl/2012/main" name="Office Theme" id="{62F939B6-93AF-4DB8-9C6B-D6C7DFDC589F}" vid="{4A3C46E8-61CC-4603-A589-7422A47A8E4A}"/>

</xml_diff>